<commit_message>
results 3070 + apply on presentation
</commit_message>
<xml_diff>
--- a/project/praesentation/cuTile_Auto-Tuner.pptx
+++ b/project/praesentation/cuTile_Auto-Tuner.pptx
@@ -24,6 +24,7 @@
     <p:sldId id="272" r:id="rId24"/>
     <p:sldId id="273" r:id="rId25"/>
     <p:sldId id="274" r:id="rId26"/>
+    <p:sldId id="275" r:id="rId27"/>
   </p:sldIdLst>
   <p:sldSz cx="12191695" cy="6858000" type="screen4x3"/>
   <p:notesSz cx="6858000" cy="9144000"/>
@@ -1080,7 +1081,7 @@
           <a:lstStyle/>
           <a:p>
             <a:r>
-              <a:t>Der Tuner soll nicht auf eine GPU overfitten. Weil die optimale L2-Gruppe von der L2-Groesse abhaengt, ist das GPU-Modell im Cache-Key. GB10 (25 MB L2, integriert, eher DRAM-limitiert) vs. RTX 3070 (diskret, kleines L2, bandbreitenlimitiert). Erwartung: das Roofline-Modell schaltet auf memory um, andere Gewinner-Configs. Portabilitaet ist by construction (device_props), aber bisher nur auf der GB10 validiert — die 3070-Messung steht noch aus (Platzhalter-Balken).</a:t>
+              <a:t>Absolute TFLOPS der GB10 und 3070 zu vergleichen ist nicht sinnvoll (andere Peak-Leistung, Bandbreite, L2: 25 MB vs 4 MB). Vergleichbar ist der Optimierungshebel: der Speedup Tuner/Default pro Shape. Ergebnis: der Hebel wirkt auf beiden Karten, auf der 3070 sogar staerker (Ø 1.88x vs 1.36x) — der aus dem GB10-Handtuning stammende 8x8-Default passt auf der 3070 schlechter, also holt der Tuner dort mehr raus. Und die gemessen beste Config ist in 16/16 Shapes zwischen den Karten verschieden (GB10 mag 128/128, die 3070 oft 64/128 oder 256/64 mit anderem k_prim/L2). Das ist das Argument fuer GPU-spezifisches Autotuning und warum das GPU-Modell im Cache-Key steht. Portabilitaet ist by construction (alles aus device_props) — jetzt auch auf einer zweiten, bandbreitenlimitierten GPU bestaetigt.</a:t>
             </a:r>
           </a:p>
         </p:txBody>
@@ -1150,7 +1151,7 @@
           <a:lstStyle/>
           <a:p>
             <a:r>
-              <a:t>Tuning lohnt sich ueber Wiederverwendung. Eine Kontraktion laeuft ~8 ms, die 3 s Tuning amortisieren sich, sobald dieselbe Shape oft laeuft — im Training/Inferenz der Normalfall (feste Layer-Dims). Config-Cache (cache.py + autotune.py), Key inkl. GPU-Modell. End-to-end bestaetigt: 16 Shapes getunt &amp; gecacht, 2. Aufruf Cache-Hit, Top-7-Picks bei ~95-100 %. Nur bei stark dynamischen Shapes geht die Rechnung nicht auf -&gt; Bucketing/Padding.</a:t>
+              <a:t>Die gemessen beste Config ist in 16/16 Shapes zwischen GB10 und 3070 verschieden: die GB10 mag grosse 128x128-Tiles (25 MB L2 vertraegt sie), die 3070 kleineres k_prim=32 und oft asymmetrische/64-breite Tiles. Der Autotuner (v2-Modell, nur top-7 gemessen) trifft im Schnitt ~96 % (GB10) bzw. ~90 % (3070) des Optimums — auf der 3070 etwas unzuverlaessiger (einzelne Shapes wie krumm/square_1b fallen auf ~60-75 %). KOSTEN: eine Shape zu tunen (top-7 kompilieren+messen) kostet auf der GB10 ~3 s. Auf der 3070 lief alles unter WSL, wo der gcc-Compile viel langsamer ist — je nach Shape ~3 s bis ~2 min (ein voller Sweep dauerte dort bis ~1.9 h vs. ~5 min auf der GB10). Es ist ein Einmalkosten-Posten, der gecacht wird, und der Nutzen ist auf der 3070 groesser (Oe 1.88x) — fuer wiederverwendete Shapes lohnt es sich, fuer Einmalrechnungen auf der 3070 grenzwertig. BEWERTUNGSMETHODE: das Roofline-Modell schaltet sein Regime selbst per device_props um (max(memory,compute)). Interessant: die GB10 ist die bandbreiten-limitierte Karte (273 GB/s LPDDR, 3/16 Shapes memory-bound), die 3070 bleibt compute-bound (448 GB/s GDDR6, 0/16). Der praktische Tuner (autotune.py) nutzt aber fest v2, weil v2 auf beiden Karten der bessere top-7-Vorfilter ist (roofline korreliert global besser: Spearman +0.57 vs v2 +0.19 auf der 3070, ist aber schlechterer Vorfilter: 83 % vs 91 %).</a:t>
             </a:r>
           </a:p>
         </p:txBody>
@@ -1220,7 +1221,7 @@
           <a:lstStyle/>
           <a:p>
             <a:r>
-              <a:t>Kernaussagen: A05 reproduziert Hand, A06 transferiert und schlaegt den Handkernel, cuBLAS wird auf GEMM nicht geschlagen (Wert = Allgemeinheit + Gewinne wo die Library keinen Pfad hat), das Modell taugt als Vorfilter (v2) aber nicht als exakter Ranker, und der Praxiswert ist GPU-spezifisches, gecachtes Tuning. Wichtigste Erkenntnis: die Eingrenzung ist das Sichere, die Entscheidung muss man messen.</a:t>
+              <a:t>Tuning lohnt sich ueber Wiederverwendung. Eine Kontraktion laeuft ~8 ms, die 3 s Tuning amortisieren sich, sobald dieselbe Shape oft laeuft — im Training/Inferenz der Normalfall (feste Layer-Dims). Config-Cache (cache.py + autotune.py), Key inkl. GPU-Modell. End-to-end bestaetigt: 16 Shapes getunt &amp; gecacht, 2. Aufruf Cache-Hit, Top-7-Picks bei ~95-100 %. Nur bei stark dynamischen Shapes geht die Rechnung nicht auf -&gt; Bucketing/Padding.</a:t>
             </a:r>
           </a:p>
         </p:txBody>
@@ -1291,6 +1292,76 @@
           <a:p>
             <a:r>
               <a:t>In A05/A06 haben wir die Tiling-Config von Hand begruendet. Das funktioniert, skaliert aber nicht auf neue Kontraktionen/Shapes/GPUs. Kernbeobachtung aus der Vorlesung: die Performance steckt in der Konfiguration (Tile-Groessen, Ausfuehrungsreihenfolge), nicht im Kernel-Code. Scope: kein allgemeiner Compiler, sondern ein kleiner Such-/Messloop.</a:t>
+            </a:r>
+          </a:p>
+        </p:txBody>
+      </p:sp>
+      <p:sp>
+        <p:nvSpPr>
+          <p:cNvPr id="4" name="Slide Number Placeholder 3"/>
+          <p:cNvSpPr>
+            <a:spLocks noGrp="1"/>
+          </p:cNvSpPr>
+          <p:nvPr>
+            <p:ph type="sldNum" idx="5" sz="quarter"/>
+          </p:nvPr>
+        </p:nvSpPr>
+        <p:spPr/>
+      </p:sp>
+    </p:spTree>
+  </p:cSld>
+  <p:clrMapOvr>
+    <a:masterClrMapping/>
+  </p:clrMapOvr>
+</p:notes>
+</file>
+
+<file path=ppt/notesSlides/notesSlide20.xml><?xml version="1.0" encoding="utf-8"?>
+<p:notes xmlns:a="http://schemas.openxmlformats.org/drawingml/2006/main" xmlns:p="http://schemas.openxmlformats.org/presentationml/2006/main" xmlns:r="http://schemas.openxmlformats.org/officeDocument/2006/relationships">
+  <p:cSld>
+    <p:spTree>
+      <p:nvGrpSpPr>
+        <p:cNvPr id="1" name=""/>
+        <p:cNvGrpSpPr/>
+        <p:nvPr/>
+      </p:nvGrpSpPr>
+      <p:grpSpPr>
+        <a:xfrm>
+          <a:off x="0" y="0"/>
+          <a:ext cx="0" cy="0"/>
+          <a:chOff x="0" y="0"/>
+          <a:chExt cx="0" cy="0"/>
+        </a:xfrm>
+      </p:grpSpPr>
+      <p:sp>
+        <p:nvSpPr>
+          <p:cNvPr id="2" name="Slide Image Placeholder 1"/>
+          <p:cNvSpPr>
+            <a:spLocks noGrp="1"/>
+          </p:cNvSpPr>
+          <p:nvPr>
+            <p:ph type="sldImg" idx="2"/>
+          </p:nvPr>
+        </p:nvSpPr>
+        <p:spPr/>
+      </p:sp>
+      <p:sp>
+        <p:nvSpPr>
+          <p:cNvPr id="3" name="Notes Placeholder 2"/>
+          <p:cNvSpPr>
+            <a:spLocks noGrp="1"/>
+          </p:cNvSpPr>
+          <p:nvPr>
+            <p:ph type="body" idx="3" sz="quarter"/>
+          </p:nvPr>
+        </p:nvSpPr>
+        <p:spPr/>
+        <p:txBody>
+          <a:bodyPr/>
+          <a:lstStyle/>
+          <a:p>
+            <a:r>
+              <a:t>Kernaussagen: A05 reproduziert Hand, A06 transferiert und schlaegt den Handkernel, cuBLAS wird auf GEMM nicht geschlagen (Wert = Allgemeinheit + Gewinne wo die Library keinen Pfad hat), das Modell taugt als Vorfilter (v2) aber nicht als exakter Ranker, und der Praxiswert ist GPU-spezifisches, gecachtes Tuning. Wichtigste Erkenntnis: die Eingrenzung ist das Sichere, die Entscheidung muss man messen.</a:t>
             </a:r>
           </a:p>
         </p:txBody>
@@ -8004,7 +8075,7 @@
                 </a:solidFill>
                 <a:latin typeface="Calibri"/>
               </a:rPr>
-              <a:t>AUSBLICK</a:t>
+              <a:t>ERGEBNISSE · CROSS-GPU</a:t>
             </a:r>
           </a:p>
         </p:txBody>
@@ -8039,7 +8110,7 @@
                 </a:solidFill>
                 <a:latin typeface="Calibri"/>
               </a:rPr>
-              <a:t>Cross-GPU: ist Tuning GPU-abhängig?</a:t>
+              <a:t>Derselbe Hebel, aber andere Config pro GPU</a:t>
             </a:r>
           </a:p>
         </p:txBody>
@@ -8160,7 +8231,7 @@
       </p:sp>
       <p:pic>
         <p:nvPicPr>
-          <p:cNvPr id="7" name="Picture 6" descr="fig_crossgpu_placeholder.png"/>
+          <p:cNvPr id="7" name="Picture 6" descr="fig_crossgpu_lever.png"/>
           <p:cNvPicPr>
             <a:picLocks noChangeAspect="1"/>
           </p:cNvPicPr>
@@ -8174,8 +8245,8 @@
         </p:blipFill>
         <p:spPr>
           <a:xfrm>
-            <a:off x="1246508" y="1554480"/>
-            <a:ext cx="6468103" cy="4114800"/>
+            <a:off x="2449389" y="1572768"/>
+            <a:ext cx="7262740" cy="4069080"/>
           </a:xfrm>
           <a:prstGeom prst="rect">
             <a:avLst/>
@@ -8184,142 +8255,7 @@
       </p:pic>
       <p:sp>
         <p:nvSpPr>
-          <p:cNvPr id="8" name="TextBox 7"/>
-          <p:cNvSpPr txBox="1"/>
-          <p:nvPr/>
-        </p:nvSpPr>
-        <p:spPr>
-          <a:xfrm>
-            <a:off x="8595360" y="1920240"/>
-            <a:ext cx="3063240" cy="3749039"/>
-          </a:xfrm>
-          <a:prstGeom prst="rect">
-            <a:avLst/>
-          </a:prstGeom>
-          <a:noFill/>
-        </p:spPr>
-        <p:txBody>
-          <a:bodyPr wrap="square">
-            <a:spAutoFit/>
-          </a:bodyPr>
-          <a:lstStyle/>
-          <a:p>
-            <a:pPr>
-              <a:lnSpc>
-                <a:spcPct val="110000"/>
-              </a:lnSpc>
-              <a:spcAft>
-                <a:spcPts val="1000"/>
-              </a:spcAft>
-            </a:pPr>
-            <a:r>
-              <a:rPr sz="1450" b="1" i="0">
-                <a:solidFill>
-                  <a:srgbClr val="2A78D6"/>
-                </a:solidFill>
-                <a:latin typeface="Calibri"/>
-              </a:rPr>
-              <a:t>▸  </a:t>
-            </a:r>
-            <a:r>
-              <a:rPr sz="1450" b="0" i="0">
-                <a:solidFill>
-                  <a:srgbClr val="3F3E3A"/>
-                </a:solidFill>
-                <a:latin typeface="Calibri"/>
-              </a:rPr>
-              <a:t>Optimale L2-Gruppe hängt an der L2-Größe → GPU im Cache-Key.</a:t>
-            </a:r>
-          </a:p>
-          <a:p>
-            <a:pPr>
-              <a:lnSpc>
-                <a:spcPct val="110000"/>
-              </a:lnSpc>
-              <a:spcAft>
-                <a:spcPts val="1000"/>
-              </a:spcAft>
-            </a:pPr>
-            <a:r>
-              <a:rPr sz="1450" b="1" i="0">
-                <a:solidFill>
-                  <a:srgbClr val="2A78D6"/>
-                </a:solidFill>
-                <a:latin typeface="Calibri"/>
-              </a:rPr>
-              <a:t>▸  </a:t>
-            </a:r>
-            <a:r>
-              <a:rPr sz="1450" b="0" i="0">
-                <a:solidFill>
-                  <a:srgbClr val="3F3E3A"/>
-                </a:solidFill>
-                <a:latin typeface="Calibri"/>
-              </a:rPr>
-              <a:t>GB10: 25 MB L2, integriert. RTX 3070: diskret, bandbreitenlimitiert.</a:t>
-            </a:r>
-          </a:p>
-          <a:p>
-            <a:pPr>
-              <a:lnSpc>
-                <a:spcPct val="110000"/>
-              </a:lnSpc>
-              <a:spcAft>
-                <a:spcPts val="1000"/>
-              </a:spcAft>
-            </a:pPr>
-            <a:r>
-              <a:rPr sz="1450" b="1" i="0">
-                <a:solidFill>
-                  <a:srgbClr val="2A78D6"/>
-                </a:solidFill>
-                <a:latin typeface="Calibri"/>
-              </a:rPr>
-              <a:t>▸  </a:t>
-            </a:r>
-            <a:r>
-              <a:rPr sz="1450" b="0" i="0">
-                <a:solidFill>
-                  <a:srgbClr val="3F3E3A"/>
-                </a:solidFill>
-                <a:latin typeface="Calibri"/>
-              </a:rPr>
-              <a:t>Erwartung: roofline schaltet auf memory, andere Gewinner.</a:t>
-            </a:r>
-          </a:p>
-          <a:p>
-            <a:pPr>
-              <a:lnSpc>
-                <a:spcPct val="110000"/>
-              </a:lnSpc>
-              <a:spcAft>
-                <a:spcPts val="1000"/>
-              </a:spcAft>
-            </a:pPr>
-            <a:r>
-              <a:rPr sz="1450" b="1" i="0">
-                <a:solidFill>
-                  <a:srgbClr val="2A78D6"/>
-                </a:solidFill>
-                <a:latin typeface="Calibri"/>
-              </a:rPr>
-              <a:t>▸  </a:t>
-            </a:r>
-            <a:r>
-              <a:rPr sz="1450" b="1" i="0">
-                <a:solidFill>
-                  <a:srgbClr val="EB6834"/>
-                </a:solidFill>
-                <a:latin typeface="Calibri"/>
-              </a:rPr>
-              <a:t>RTX-3070-Messung folgt.</a:t>
-            </a:r>
-          </a:p>
-        </p:txBody>
-      </p:sp>
-      <p:sp>
-        <p:nvSpPr>
-          <p:cNvPr id="9" name="Rectangle 8"/>
+          <p:cNvPr id="8" name="Rectangle 7"/>
           <p:cNvSpPr/>
           <p:nvPr/>
         </p:nvSpPr>
@@ -8363,7 +8299,7 @@
       </p:sp>
       <p:sp>
         <p:nvSpPr>
-          <p:cNvPr id="10" name="TextBox 9"/>
+          <p:cNvPr id="9" name="TextBox 8"/>
           <p:cNvSpPr txBox="1"/>
           <p:nvPr/>
         </p:nvSpPr>
@@ -8391,7 +8327,7 @@
                 </a:solidFill>
                 <a:latin typeface="Calibri"/>
               </a:rPr>
-              <a:t>Portabilität ist by construction (alles aus device_props), empirisch bisher nur auf der GB10 belegt.</a:t>
+              <a:t>Tuning hilft auf beiden Karten (Ø 1.36× GB10, 1.88× 3070) und die optimale Config ist in 16/16 Shapes verschieden — genau deshalb: GPU-spezifisch tunen + cachen.</a:t>
             </a:r>
           </a:p>
         </p:txBody>
@@ -8452,7 +8388,7 @@
                 </a:solidFill>
                 <a:latin typeface="Calibri"/>
               </a:rPr>
-              <a:t>EINORDNUNG</a:t>
+              <a:t>ERGEBNISSE · CROSS-GPU</a:t>
             </a:r>
           </a:p>
         </p:txBody>
@@ -8487,7 +8423,7 @@
                 </a:solidFill>
                 <a:latin typeface="Calibri"/>
               </a:rPr>
-              <a:t>Wann sich Tuning lohnt: Cache &amp; Amortisierung</a:t>
+              <a:t>Was der Tuner pro GPU wählt — und was es kostet</a:t>
             </a:r>
           </a:p>
         </p:txBody>
@@ -8606,16 +8542,40 @@
           </a:p>
         </p:txBody>
       </p:sp>
-      <p:sp>
-        <p:nvSpPr>
-          <p:cNvPr id="7" name="TextBox 6"/>
+      <p:pic>
+        <p:nvPicPr>
+          <p:cNvPr id="7" name="Picture 6" descr="fig_config_table.png"/>
+          <p:cNvPicPr>
+            <a:picLocks noChangeAspect="1"/>
+          </p:cNvPicPr>
+          <p:nvPr/>
+        </p:nvPicPr>
+        <p:blipFill>
+          <a:blip r:embed="rId2"/>
+          <a:stretch>
+            <a:fillRect/>
+          </a:stretch>
+        </p:blipFill>
+        <p:spPr>
+          <a:xfrm>
+            <a:off x="457200" y="1668356"/>
+            <a:ext cx="7635240" cy="3832183"/>
+          </a:xfrm>
+          <a:prstGeom prst="rect">
+            <a:avLst/>
+          </a:prstGeom>
+        </p:spPr>
+      </p:pic>
+      <p:sp>
+        <p:nvSpPr>
+          <p:cNvPr id="8" name="TextBox 7"/>
           <p:cNvSpPr txBox="1"/>
           <p:nvPr/>
         </p:nvSpPr>
         <p:spPr>
           <a:xfrm>
-            <a:off x="658368" y="1783080"/>
-            <a:ext cx="6766560" cy="3657600"/>
+            <a:off x="8229600" y="1874519"/>
+            <a:ext cx="3429000" cy="3794760"/>
           </a:xfrm>
           <a:prstGeom prst="rect">
             <a:avLst/>
@@ -8637,7 +8597,7 @@
               </a:spcAft>
             </a:pPr>
             <a:r>
-              <a:rPr sz="1650" b="1" i="0">
+              <a:rPr sz="1400" b="1" i="0">
                 <a:solidFill>
                   <a:srgbClr val="2A78D6"/>
                 </a:solidFill>
@@ -8646,13 +8606,13 @@
               <a:t>▸  </a:t>
             </a:r>
             <a:r>
-              <a:rPr sz="1650" b="0" i="0">
+              <a:rPr sz="1400" b="0" i="0">
                 <a:solidFill>
                   <a:srgbClr val="3F3E3A"/>
                 </a:solidFill>
                 <a:latin typeface="Calibri"/>
               </a:rPr>
-              <a:t>Eine Kontraktion läuft ~8 ms; Tuning ~3 s ist ein Einmalposten.</a:t>
+              <a:t>Optimum in 16/16 Shapes verschieden — pro GPU eine andere Config.</a:t>
             </a:r>
           </a:p>
           <a:p>
@@ -8665,7 +8625,7 @@
               </a:spcAft>
             </a:pPr>
             <a:r>
-              <a:rPr sz="1650" b="1" i="0">
+              <a:rPr sz="1400" b="1" i="0">
                 <a:solidFill>
                   <a:srgbClr val="2A78D6"/>
                 </a:solidFill>
@@ -8674,13 +8634,13 @@
               <a:t>▸  </a:t>
             </a:r>
             <a:r>
-              <a:rPr sz="1650" b="0" i="0">
+              <a:rPr sz="1400" b="0" i="0">
                 <a:solidFill>
                   <a:srgbClr val="3F3E3A"/>
                 </a:solidFill>
                 <a:latin typeface="Calibri"/>
               </a:rPr>
-              <a:t>Im Netz sind Layer-Dims fix → millionenfach dieselbe Shape.</a:t>
+              <a:t>Autotuner (v2, top-7) trifft ⌀ 96 % (GB10) / 90 % (3070) des Optimums.</a:t>
             </a:r>
           </a:p>
           <a:p>
@@ -8693,7 +8653,7 @@
               </a:spcAft>
             </a:pPr>
             <a:r>
-              <a:rPr sz="1650" b="1" i="0">
+              <a:rPr sz="1400" b="1" i="0">
                 <a:solidFill>
                   <a:srgbClr val="2A78D6"/>
                 </a:solidFill>
@@ -8702,13 +8662,13 @@
               <a:t>▸  </a:t>
             </a:r>
             <a:r>
-              <a:rPr sz="1650" b="0" i="0">
+              <a:rPr sz="1400" b="0" i="0">
                 <a:solidFill>
                   <a:srgbClr val="3F3E3A"/>
                 </a:solidFill>
                 <a:latin typeface="Calibri"/>
               </a:rPr>
-              <a:t>Config-Cache: Key = Einsum + Shapes + GPU-Modell.</a:t>
+              <a:t>Kosten: GB10 ~3 s/Shape; 3070 (WSL-Compile) ~3 s–2 min — Compile dominiert.</a:t>
             </a:r>
           </a:p>
           <a:p>
@@ -8721,7 +8681,7 @@
               </a:spcAft>
             </a:pPr>
             <a:r>
-              <a:rPr sz="1650" b="1" i="0">
+              <a:rPr sz="1400" b="1" i="0">
                 <a:solidFill>
                   <a:srgbClr val="2A78D6"/>
                 </a:solidFill>
@@ -8730,108 +8690,36 @@
               <a:t>▸  </a:t>
             </a:r>
             <a:r>
-              <a:rPr sz="1650" b="0" i="0">
+              <a:rPr sz="1400" b="0" i="0">
                 <a:solidFill>
                   <a:srgbClr val="3F3E3A"/>
                 </a:solidFill>
                 <a:latin typeface="Calibri"/>
               </a:rPr>
-              <a:t>Genau so machen es cuBLAS, Triton (autotune), torch.compile.</a:t>
-            </a:r>
-          </a:p>
-        </p:txBody>
-      </p:sp>
-      <p:sp>
-        <p:nvSpPr>
-          <p:cNvPr id="8" name="TextBox 7"/>
-          <p:cNvSpPr txBox="1"/>
-          <p:nvPr/>
-        </p:nvSpPr>
-        <p:spPr>
-          <a:xfrm>
-            <a:off x="7772400" y="2011680"/>
-            <a:ext cx="3749039" cy="640080"/>
-          </a:xfrm>
-          <a:prstGeom prst="rect">
-            <a:avLst/>
-          </a:prstGeom>
-          <a:noFill/>
-        </p:spPr>
-        <p:txBody>
-          <a:bodyPr wrap="square" anchor="t">
-            <a:spAutoFit/>
-          </a:bodyPr>
-          <a:lstStyle/>
-          <a:p>
-            <a:pPr algn="ctr"/>
-            <a:r>
-              <a:rPr sz="3400" b="1" i="0">
-                <a:solidFill>
-                  <a:srgbClr val="2A78D6"/>
-                </a:solidFill>
-                <a:latin typeface="Calibri"/>
-              </a:rPr>
-              <a:t>~3 s → 0 s</a:t>
-            </a:r>
-          </a:p>
-        </p:txBody>
-      </p:sp>
-      <p:sp>
-        <p:nvSpPr>
-          <p:cNvPr id="9" name="TextBox 8"/>
-          <p:cNvSpPr txBox="1"/>
-          <p:nvPr/>
-        </p:nvSpPr>
-        <p:spPr>
-          <a:xfrm>
-            <a:off x="7772400" y="2670048"/>
-            <a:ext cx="3749039" cy="457200"/>
-          </a:xfrm>
-          <a:prstGeom prst="rect">
-            <a:avLst/>
-          </a:prstGeom>
-          <a:noFill/>
-        </p:spPr>
-        <p:txBody>
-          <a:bodyPr wrap="square" anchor="t">
-            <a:spAutoFit/>
-          </a:bodyPr>
-          <a:lstStyle/>
-          <a:p>
-            <a:pPr algn="ctr"/>
-            <a:r>
-              <a:rPr sz="1250" b="0" i="0">
-                <a:solidFill>
-                  <a:srgbClr val="3F3E3A"/>
-                </a:solidFill>
-                <a:latin typeface="Calibri"/>
-              </a:rPr>
-              <a:t>erste getunte Shape → jede weitere aus dem Cache</a:t>
-            </a:r>
-          </a:p>
-        </p:txBody>
-      </p:sp>
-      <p:sp>
-        <p:nvSpPr>
-          <p:cNvPr id="10" name="Rounded Rectangle 9"/>
+              <a:t>Roofline schaltet sein Regime selbst um; praktisch bleibt v2 der beste Vorfilter.</a:t>
+            </a:r>
+          </a:p>
+        </p:txBody>
+      </p:sp>
+      <p:sp>
+        <p:nvSpPr>
+          <p:cNvPr id="9" name="Rectangle 8"/>
           <p:cNvSpPr/>
           <p:nvPr/>
         </p:nvSpPr>
         <p:spPr>
           <a:xfrm>
-            <a:off x="7772400" y="3657600"/>
-            <a:ext cx="3749039" cy="1463040"/>
-          </a:xfrm>
-          <a:prstGeom prst="roundRect">
+            <a:off x="658368" y="5870448"/>
+            <a:ext cx="82296" cy="402336"/>
+          </a:xfrm>
+          <a:prstGeom prst="rect">
             <a:avLst/>
           </a:prstGeom>
           <a:solidFill>
-            <a:srgbClr val="F4F7FB"/>
+            <a:srgbClr val="EB6834"/>
           </a:solidFill>
-          <a:ln w="12700">
-            <a:solidFill>
-              <a:srgbClr val="DDE4EC"/>
-            </a:solidFill>
+          <a:ln>
+            <a:noFill/>
           </a:ln>
           <a:effectLst/>
         </p:spPr>
@@ -8859,14 +8747,14 @@
       </p:sp>
       <p:sp>
         <p:nvSpPr>
-          <p:cNvPr id="11" name="TextBox 10"/>
+          <p:cNvPr id="10" name="TextBox 9"/>
           <p:cNvSpPr txBox="1"/>
           <p:nvPr/>
         </p:nvSpPr>
         <p:spPr>
           <a:xfrm>
-            <a:off x="7973568" y="3822191"/>
-            <a:ext cx="3383280" cy="1188720"/>
+            <a:off x="868680" y="5815584"/>
+            <a:ext cx="10607040" cy="502920"/>
           </a:xfrm>
           <a:prstGeom prst="rect">
             <a:avLst/>
@@ -8881,45 +8769,129 @@
           <a:p>
             <a:pPr algn="l"/>
             <a:r>
-              <a:rPr sz="1350" b="1" i="0">
+              <a:rPr sz="1500" b="0" i="0">
+                <a:solidFill>
+                  <a:srgbClr val="3F3E3A"/>
+                </a:solidFill>
+                <a:latin typeface="Calibri"/>
+              </a:rPr>
+              <a:t>Pro GPU von Hand zu tunen ist nicht machbar — das nimmt der gecachte Tuner ab, ohne auf eine Karte zu overfitten.</a:t>
+            </a:r>
+          </a:p>
+        </p:txBody>
+      </p:sp>
+    </p:spTree>
+  </p:cSld>
+  <p:clrMapOvr>
+    <a:masterClrMapping/>
+  </p:clrMapOvr>
+</p:sld>
+</file>
+
+<file path=ppt/slides/slide19.xml><?xml version="1.0" encoding="utf-8"?>
+<p:sld xmlns:a="http://schemas.openxmlformats.org/drawingml/2006/main" xmlns:p="http://schemas.openxmlformats.org/presentationml/2006/main" xmlns:r="http://schemas.openxmlformats.org/officeDocument/2006/relationships">
+  <p:cSld>
+    <p:bg>
+      <p:bgPr>
+        <a:solidFill>
+          <a:srgbClr val="FFFFFF"/>
+        </a:solidFill>
+        <a:effectLst/>
+      </p:bgPr>
+    </p:bg>
+    <p:spTree>
+      <p:nvGrpSpPr>
+        <p:cNvPr id="1" name=""/>
+        <p:cNvGrpSpPr/>
+        <p:nvPr/>
+      </p:nvGrpSpPr>
+      <p:grpSpPr/>
+      <p:sp>
+        <p:nvSpPr>
+          <p:cNvPr id="2" name="TextBox 1"/>
+          <p:cNvSpPr txBox="1"/>
+          <p:nvPr/>
+        </p:nvSpPr>
+        <p:spPr>
+          <a:xfrm>
+            <a:off x="640080" y="384048"/>
+            <a:ext cx="10972800" cy="256032"/>
+          </a:xfrm>
+          <a:prstGeom prst="rect">
+            <a:avLst/>
+          </a:prstGeom>
+          <a:noFill/>
+        </p:spPr>
+        <p:txBody>
+          <a:bodyPr wrap="square" anchor="t">
+            <a:spAutoFit/>
+          </a:bodyPr>
+          <a:lstStyle/>
+          <a:p>
+            <a:pPr algn="l"/>
+            <a:r>
+              <a:rPr sz="1250" b="1" i="0">
+                <a:solidFill>
+                  <a:srgbClr val="2A78D6"/>
+                </a:solidFill>
+                <a:latin typeface="Calibri"/>
+              </a:rPr>
+              <a:t>EINORDNUNG</a:t>
+            </a:r>
+          </a:p>
+        </p:txBody>
+      </p:sp>
+      <p:sp>
+        <p:nvSpPr>
+          <p:cNvPr id="3" name="TextBox 2"/>
+          <p:cNvSpPr txBox="1"/>
+          <p:nvPr/>
+        </p:nvSpPr>
+        <p:spPr>
+          <a:xfrm>
+            <a:off x="621792" y="676656"/>
+            <a:ext cx="10972800" cy="822960"/>
+          </a:xfrm>
+          <a:prstGeom prst="rect">
+            <a:avLst/>
+          </a:prstGeom>
+          <a:noFill/>
+        </p:spPr>
+        <p:txBody>
+          <a:bodyPr wrap="square" anchor="t">
+            <a:spAutoFit/>
+          </a:bodyPr>
+          <a:lstStyle/>
+          <a:p>
+            <a:pPr algn="l"/>
+            <a:r>
+              <a:rPr sz="2700" b="1" i="0">
                 <a:solidFill>
                   <a:srgbClr val="0B0B0B"/>
                 </a:solidFill>
                 <a:latin typeface="Calibri"/>
               </a:rPr>
-              <a:t>End-to-end bestätigt</a:t>
-            </a:r>
-          </a:p>
-          <a:p>
-            <a:pPr algn="l"/>
-            <a:r>
-              <a:rPr sz="1250" b="0" i="0">
-                <a:solidFill>
-                  <a:srgbClr val="3F3E3A"/>
-                </a:solidFill>
-                <a:latin typeface="Calibri"/>
-              </a:rPr>
-              <a:t>16 Shapes getunt &amp; gecacht, 2. Aufruf Cache-Hit, Top-7 bei ~95–100 %.</a:t>
-            </a:r>
-          </a:p>
-        </p:txBody>
-      </p:sp>
-      <p:sp>
-        <p:nvSpPr>
-          <p:cNvPr id="12" name="Rectangle 11"/>
+              <a:t>Wann sich Tuning lohnt: Cache &amp; Amortisierung</a:t>
+            </a:r>
+          </a:p>
+        </p:txBody>
+      </p:sp>
+      <p:sp>
+        <p:nvSpPr>
+          <p:cNvPr id="4" name="Rectangle 3"/>
           <p:cNvSpPr/>
           <p:nvPr/>
         </p:nvSpPr>
         <p:spPr>
           <a:xfrm>
-            <a:off x="658368" y="5870448"/>
-            <a:ext cx="82296" cy="402336"/>
+            <a:off x="658368" y="1389888"/>
+            <a:ext cx="1920240" cy="50292"/>
           </a:xfrm>
           <a:prstGeom prst="rect">
             <a:avLst/>
           </a:prstGeom>
           <a:solidFill>
-            <a:srgbClr val="EB6834"/>
+            <a:srgbClr val="2A78D6"/>
           </a:solidFill>
           <a:ln>
             <a:noFill/>
@@ -8950,14 +8922,14 @@
       </p:sp>
       <p:sp>
         <p:nvSpPr>
-          <p:cNvPr id="13" name="TextBox 12"/>
+          <p:cNvPr id="5" name="TextBox 4"/>
           <p:cNvSpPr txBox="1"/>
           <p:nvPr/>
         </p:nvSpPr>
         <p:spPr>
           <a:xfrm>
-            <a:off x="868680" y="5815584"/>
-            <a:ext cx="10607040" cy="502920"/>
+            <a:off x="640080" y="6455664"/>
+            <a:ext cx="6400800" cy="274320"/>
           </a:xfrm>
           <a:prstGeom prst="rect">
             <a:avLst/>
@@ -8965,69 +8937,285 @@
           <a:noFill/>
         </p:spPr>
         <p:txBody>
-          <a:bodyPr wrap="square" anchor="ctr">
+          <a:bodyPr wrap="square" anchor="t">
             <a:spAutoFit/>
           </a:bodyPr>
           <a:lstStyle/>
           <a:p>
             <a:pPr algn="l"/>
             <a:r>
-              <a:rPr sz="1500" b="0" i="0">
+              <a:rPr sz="1000" b="0" i="0">
+                <a:solidFill>
+                  <a:srgbClr val="898781"/>
+                </a:solidFill>
+                <a:latin typeface="Calibri"/>
+              </a:rPr>
+              <a:t>cuTile Auto-Tuner · Becker-Klöser · Elagina</a:t>
+            </a:r>
+          </a:p>
+        </p:txBody>
+      </p:sp>
+      <p:sp>
+        <p:nvSpPr>
+          <p:cNvPr id="6" name="TextBox 5"/>
+          <p:cNvSpPr txBox="1"/>
+          <p:nvPr/>
+        </p:nvSpPr>
+        <p:spPr>
+          <a:xfrm>
+            <a:off x="10607040" y="6455664"/>
+            <a:ext cx="1005840" cy="274320"/>
+          </a:xfrm>
+          <a:prstGeom prst="rect">
+            <a:avLst/>
+          </a:prstGeom>
+          <a:noFill/>
+        </p:spPr>
+        <p:txBody>
+          <a:bodyPr wrap="square" anchor="t">
+            <a:spAutoFit/>
+          </a:bodyPr>
+          <a:lstStyle/>
+          <a:p>
+            <a:pPr algn="r"/>
+            <a:r>
+              <a:rPr sz="1000" b="0" i="0">
+                <a:solidFill>
+                  <a:srgbClr val="898781"/>
+                </a:solidFill>
+                <a:latin typeface="Calibri"/>
+              </a:rPr>
+              <a:t>16</a:t>
+            </a:r>
+          </a:p>
+        </p:txBody>
+      </p:sp>
+      <p:sp>
+        <p:nvSpPr>
+          <p:cNvPr id="7" name="TextBox 6"/>
+          <p:cNvSpPr txBox="1"/>
+          <p:nvPr/>
+        </p:nvSpPr>
+        <p:spPr>
+          <a:xfrm>
+            <a:off x="658368" y="1783080"/>
+            <a:ext cx="6766560" cy="3657600"/>
+          </a:xfrm>
+          <a:prstGeom prst="rect">
+            <a:avLst/>
+          </a:prstGeom>
+          <a:noFill/>
+        </p:spPr>
+        <p:txBody>
+          <a:bodyPr wrap="square">
+            <a:spAutoFit/>
+          </a:bodyPr>
+          <a:lstStyle/>
+          <a:p>
+            <a:pPr>
+              <a:lnSpc>
+                <a:spcPct val="110000"/>
+              </a:lnSpc>
+              <a:spcAft>
+                <a:spcPts val="1000"/>
+              </a:spcAft>
+            </a:pPr>
+            <a:r>
+              <a:rPr sz="1650" b="1" i="0">
+                <a:solidFill>
+                  <a:srgbClr val="2A78D6"/>
+                </a:solidFill>
+                <a:latin typeface="Calibri"/>
+              </a:rPr>
+              <a:t>▸  </a:t>
+            </a:r>
+            <a:r>
+              <a:rPr sz="1650" b="0" i="0">
                 <a:solidFill>
                   <a:srgbClr val="3F3E3A"/>
                 </a:solidFill>
                 <a:latin typeface="Calibri"/>
               </a:rPr>
-              <a:t>Break-even in Sekunden bei fester Shape; für stark dynamische Shapes hilft Bucketing/Padding.</a:t>
-            </a:r>
-          </a:p>
-        </p:txBody>
-      </p:sp>
-    </p:spTree>
-  </p:cSld>
-  <p:clrMapOvr>
-    <a:masterClrMapping/>
-  </p:clrMapOvr>
-</p:sld>
-</file>
-
-<file path=ppt/slides/slide19.xml><?xml version="1.0" encoding="utf-8"?>
-<p:sld xmlns:a="http://schemas.openxmlformats.org/drawingml/2006/main" xmlns:p="http://schemas.openxmlformats.org/presentationml/2006/main" xmlns:r="http://schemas.openxmlformats.org/officeDocument/2006/relationships">
-  <p:cSld>
-    <p:bg>
-      <p:bgPr>
-        <a:solidFill>
-          <a:srgbClr val="0E1B2E"/>
-        </a:solidFill>
-        <a:effectLst/>
-      </p:bgPr>
-    </p:bg>
-    <p:spTree>
-      <p:nvGrpSpPr>
-        <p:cNvPr id="1" name=""/>
-        <p:cNvGrpSpPr/>
-        <p:nvPr/>
-      </p:nvGrpSpPr>
-      <p:grpSpPr/>
-      <p:sp>
-        <p:nvSpPr>
-          <p:cNvPr id="2" name="Rectangle 1"/>
+              <a:t>Eine Kontraktion läuft ~8 ms; Tuning ~3 s ist ein Einmalposten.</a:t>
+            </a:r>
+          </a:p>
+          <a:p>
+            <a:pPr>
+              <a:lnSpc>
+                <a:spcPct val="110000"/>
+              </a:lnSpc>
+              <a:spcAft>
+                <a:spcPts val="1000"/>
+              </a:spcAft>
+            </a:pPr>
+            <a:r>
+              <a:rPr sz="1650" b="1" i="0">
+                <a:solidFill>
+                  <a:srgbClr val="2A78D6"/>
+                </a:solidFill>
+                <a:latin typeface="Calibri"/>
+              </a:rPr>
+              <a:t>▸  </a:t>
+            </a:r>
+            <a:r>
+              <a:rPr sz="1650" b="0" i="0">
+                <a:solidFill>
+                  <a:srgbClr val="3F3E3A"/>
+                </a:solidFill>
+                <a:latin typeface="Calibri"/>
+              </a:rPr>
+              <a:t>Im Netz sind Layer-Dims fix → millionenfach dieselbe Shape.</a:t>
+            </a:r>
+          </a:p>
+          <a:p>
+            <a:pPr>
+              <a:lnSpc>
+                <a:spcPct val="110000"/>
+              </a:lnSpc>
+              <a:spcAft>
+                <a:spcPts val="1000"/>
+              </a:spcAft>
+            </a:pPr>
+            <a:r>
+              <a:rPr sz="1650" b="1" i="0">
+                <a:solidFill>
+                  <a:srgbClr val="2A78D6"/>
+                </a:solidFill>
+                <a:latin typeface="Calibri"/>
+              </a:rPr>
+              <a:t>▸  </a:t>
+            </a:r>
+            <a:r>
+              <a:rPr sz="1650" b="0" i="0">
+                <a:solidFill>
+                  <a:srgbClr val="3F3E3A"/>
+                </a:solidFill>
+                <a:latin typeface="Calibri"/>
+              </a:rPr>
+              <a:t>Config-Cache: Key = Einsum + Shapes + GPU-Modell.</a:t>
+            </a:r>
+          </a:p>
+          <a:p>
+            <a:pPr>
+              <a:lnSpc>
+                <a:spcPct val="110000"/>
+              </a:lnSpc>
+              <a:spcAft>
+                <a:spcPts val="1000"/>
+              </a:spcAft>
+            </a:pPr>
+            <a:r>
+              <a:rPr sz="1650" b="1" i="0">
+                <a:solidFill>
+                  <a:srgbClr val="2A78D6"/>
+                </a:solidFill>
+                <a:latin typeface="Calibri"/>
+              </a:rPr>
+              <a:t>▸  </a:t>
+            </a:r>
+            <a:r>
+              <a:rPr sz="1650" b="0" i="0">
+                <a:solidFill>
+                  <a:srgbClr val="3F3E3A"/>
+                </a:solidFill>
+                <a:latin typeface="Calibri"/>
+              </a:rPr>
+              <a:t>Genau so machen es cuBLAS, Triton (autotune), torch.compile.</a:t>
+            </a:r>
+          </a:p>
+        </p:txBody>
+      </p:sp>
+      <p:sp>
+        <p:nvSpPr>
+          <p:cNvPr id="8" name="TextBox 7"/>
+          <p:cNvSpPr txBox="1"/>
+          <p:nvPr/>
+        </p:nvSpPr>
+        <p:spPr>
+          <a:xfrm>
+            <a:off x="7772400" y="2011680"/>
+            <a:ext cx="3749039" cy="640080"/>
+          </a:xfrm>
+          <a:prstGeom prst="rect">
+            <a:avLst/>
+          </a:prstGeom>
+          <a:noFill/>
+        </p:spPr>
+        <p:txBody>
+          <a:bodyPr wrap="square" anchor="t">
+            <a:spAutoFit/>
+          </a:bodyPr>
+          <a:lstStyle/>
+          <a:p>
+            <a:pPr algn="ctr"/>
+            <a:r>
+              <a:rPr sz="3400" b="1" i="0">
+                <a:solidFill>
+                  <a:srgbClr val="2A78D6"/>
+                </a:solidFill>
+                <a:latin typeface="Calibri"/>
+              </a:rPr>
+              <a:t>~3 s → 0 s</a:t>
+            </a:r>
+          </a:p>
+        </p:txBody>
+      </p:sp>
+      <p:sp>
+        <p:nvSpPr>
+          <p:cNvPr id="9" name="TextBox 8"/>
+          <p:cNvSpPr txBox="1"/>
+          <p:nvPr/>
+        </p:nvSpPr>
+        <p:spPr>
+          <a:xfrm>
+            <a:off x="7772400" y="2670048"/>
+            <a:ext cx="3749039" cy="457200"/>
+          </a:xfrm>
+          <a:prstGeom prst="rect">
+            <a:avLst/>
+          </a:prstGeom>
+          <a:noFill/>
+        </p:spPr>
+        <p:txBody>
+          <a:bodyPr wrap="square" anchor="t">
+            <a:spAutoFit/>
+          </a:bodyPr>
+          <a:lstStyle/>
+          <a:p>
+            <a:pPr algn="ctr"/>
+            <a:r>
+              <a:rPr sz="1250" b="0" i="0">
+                <a:solidFill>
+                  <a:srgbClr val="3F3E3A"/>
+                </a:solidFill>
+                <a:latin typeface="Calibri"/>
+              </a:rPr>
+              <a:t>erste getunte Shape → jede weitere aus dem Cache</a:t>
+            </a:r>
+          </a:p>
+        </p:txBody>
+      </p:sp>
+      <p:sp>
+        <p:nvSpPr>
+          <p:cNvPr id="10" name="Rounded Rectangle 9"/>
           <p:cNvSpPr/>
           <p:nvPr/>
         </p:nvSpPr>
         <p:spPr>
           <a:xfrm>
-            <a:off x="0" y="0"/>
-            <a:ext cx="320040" cy="6858000"/>
-          </a:xfrm>
-          <a:prstGeom prst="rect">
+            <a:off x="7772400" y="3657600"/>
+            <a:ext cx="3749039" cy="1463040"/>
+          </a:xfrm>
+          <a:prstGeom prst="roundRect">
             <a:avLst/>
           </a:prstGeom>
           <a:solidFill>
-            <a:srgbClr val="2A78D6"/>
+            <a:srgbClr val="F4F7FB"/>
           </a:solidFill>
-          <a:ln>
-            <a:noFill/>
+          <a:ln w="12700">
+            <a:solidFill>
+              <a:srgbClr val="DDE4EC"/>
+            </a:solidFill>
           </a:ln>
           <a:effectLst/>
         </p:spPr>
@@ -9055,14 +9243,14 @@
       </p:sp>
       <p:sp>
         <p:nvSpPr>
-          <p:cNvPr id="3" name="TextBox 2"/>
+          <p:cNvPr id="11" name="TextBox 10"/>
           <p:cNvSpPr txBox="1"/>
           <p:nvPr/>
         </p:nvSpPr>
         <p:spPr>
           <a:xfrm>
-            <a:off x="822960" y="621792"/>
-            <a:ext cx="10515600" cy="347472"/>
+            <a:off x="7973568" y="3822191"/>
+            <a:ext cx="3383280" cy="1188720"/>
           </a:xfrm>
           <a:prstGeom prst="rect">
             <a:avLst/>
@@ -9070,69 +9258,46 @@
           <a:noFill/>
         </p:spPr>
         <p:txBody>
-          <a:bodyPr wrap="square" anchor="t">
+          <a:bodyPr wrap="square" anchor="ctr">
             <a:spAutoFit/>
           </a:bodyPr>
           <a:lstStyle/>
           <a:p>
             <a:pPr algn="l"/>
             <a:r>
-              <a:rPr sz="1500" b="1" i="0">
-                <a:solidFill>
-                  <a:srgbClr val="2A78D6"/>
-                </a:solidFill>
-                <a:latin typeface="Calibri"/>
-              </a:rPr>
-              <a:t>FAZIT</a:t>
-            </a:r>
-          </a:p>
-        </p:txBody>
-      </p:sp>
-      <p:sp>
-        <p:nvSpPr>
-          <p:cNvPr id="4" name="TextBox 3"/>
-          <p:cNvSpPr txBox="1"/>
-          <p:nvPr/>
-        </p:nvSpPr>
-        <p:spPr>
-          <a:xfrm>
-            <a:off x="786384" y="1078992"/>
-            <a:ext cx="10972800" cy="822960"/>
-          </a:xfrm>
-          <a:prstGeom prst="rect">
-            <a:avLst/>
-          </a:prstGeom>
-          <a:noFill/>
-        </p:spPr>
-        <p:txBody>
-          <a:bodyPr wrap="square" anchor="t">
-            <a:spAutoFit/>
-          </a:bodyPr>
-          <a:lstStyle/>
+              <a:rPr sz="1350" b="1" i="0">
+                <a:solidFill>
+                  <a:srgbClr val="0B0B0B"/>
+                </a:solidFill>
+                <a:latin typeface="Calibri"/>
+              </a:rPr>
+              <a:t>End-to-end bestätigt</a:t>
+            </a:r>
+          </a:p>
           <a:p>
             <a:pPr algn="l"/>
             <a:r>
-              <a:rPr sz="2600" b="1" i="0">
-                <a:solidFill>
-                  <a:srgbClr val="FFFFFF"/>
-                </a:solidFill>
-                <a:latin typeface="Calibri"/>
-              </a:rPr>
-              <a:t>Eingrenzen ist sicher — entscheiden muss man messen</a:t>
-            </a:r>
-          </a:p>
-        </p:txBody>
-      </p:sp>
-      <p:sp>
-        <p:nvSpPr>
-          <p:cNvPr id="5" name="Rectangle 4"/>
+              <a:rPr sz="1250" b="0" i="0">
+                <a:solidFill>
+                  <a:srgbClr val="3F3E3A"/>
+                </a:solidFill>
+                <a:latin typeface="Calibri"/>
+              </a:rPr>
+              <a:t>16 Shapes getunt &amp; gecacht, 2. Aufruf Cache-Hit, Top-7 bei ~95–100 %.</a:t>
+            </a:r>
+          </a:p>
+        </p:txBody>
+      </p:sp>
+      <p:sp>
+        <p:nvSpPr>
+          <p:cNvPr id="12" name="Rectangle 11"/>
           <p:cNvSpPr/>
           <p:nvPr/>
         </p:nvSpPr>
         <p:spPr>
           <a:xfrm>
-            <a:off x="822960" y="1874519"/>
-            <a:ext cx="1828800" cy="54864"/>
+            <a:off x="658368" y="5870448"/>
+            <a:ext cx="82296" cy="402336"/>
           </a:xfrm>
           <a:prstGeom prst="rect">
             <a:avLst/>
@@ -9169,14 +9334,14 @@
       </p:sp>
       <p:sp>
         <p:nvSpPr>
-          <p:cNvPr id="6" name="TextBox 5"/>
+          <p:cNvPr id="13" name="TextBox 12"/>
           <p:cNvSpPr txBox="1"/>
           <p:nvPr/>
         </p:nvSpPr>
         <p:spPr>
           <a:xfrm>
-            <a:off x="822960" y="2194560"/>
-            <a:ext cx="10607040" cy="4023360"/>
+            <a:off x="868680" y="5815584"/>
+            <a:ext cx="10607040" cy="502920"/>
           </a:xfrm>
           <a:prstGeom prst="rect">
             <a:avLst/>
@@ -9184,178 +9349,20 @@
           <a:noFill/>
         </p:spPr>
         <p:txBody>
-          <a:bodyPr wrap="square">
+          <a:bodyPr wrap="square" anchor="ctr">
             <a:spAutoFit/>
           </a:bodyPr>
           <a:lstStyle/>
           <a:p>
-            <a:pPr>
-              <a:spcAft>
-                <a:spcPts val="1200"/>
-              </a:spcAft>
-            </a:pPr>
-            <a:r>
-              <a:rPr sz="1700" b="1" i="0">
-                <a:solidFill>
-                  <a:srgbClr val="EB6834"/>
-                </a:solidFill>
-                <a:latin typeface="Calibri"/>
-              </a:rPr>
-              <a:t>▸  </a:t>
-            </a:r>
-            <a:r>
-              <a:rPr sz="1700" b="1" i="0">
-                <a:solidFill>
-                  <a:srgbClr val="FFFFFF"/>
-                </a:solidFill>
-                <a:latin typeface="Calibri"/>
-              </a:rPr>
-              <a:t>A05: </a:t>
-            </a:r>
-            <a:r>
-              <a:rPr sz="1700" b="0" i="0">
-                <a:solidFill>
-                  <a:srgbClr val="D7E3F2"/>
-                </a:solidFill>
-                <a:latin typeface="Calibri"/>
-              </a:rPr>
-              <a:t>Tuner reproduziert Hand (Ø 1.03×), gewinnt bei krummen Shapes (+58 %).</a:t>
-            </a:r>
-          </a:p>
-          <a:p>
-            <a:pPr>
-              <a:spcAft>
-                <a:spcPts val="1200"/>
-              </a:spcAft>
-            </a:pPr>
-            <a:r>
-              <a:rPr sz="1700" b="1" i="0">
-                <a:solidFill>
-                  <a:srgbClr val="EB6834"/>
-                </a:solidFill>
-                <a:latin typeface="Calibri"/>
-              </a:rPr>
-              <a:t>▸  </a:t>
-            </a:r>
-            <a:r>
-              <a:rPr sz="1700" b="1" i="0">
-                <a:solidFill>
-                  <a:srgbClr val="FFFFFF"/>
-                </a:solidFill>
-                <a:latin typeface="Calibri"/>
-              </a:rPr>
-              <a:t>A06: </a:t>
-            </a:r>
-            <a:r>
-              <a:rPr sz="1700" b="0" i="0">
-                <a:solidFill>
-                  <a:srgbClr val="D7E3F2"/>
-                </a:solidFill>
-                <a:latin typeface="Calibri"/>
-              </a:rPr>
-              <a:t>sauberer Transfer, ein zusätzlicher Kernel-Typ, schlägt den Handkernel (+24 %).</a:t>
-            </a:r>
-          </a:p>
-          <a:p>
-            <a:pPr>
-              <a:spcAft>
-                <a:spcPts val="1200"/>
-              </a:spcAft>
-            </a:pPr>
-            <a:r>
-              <a:rPr sz="1700" b="1" i="0">
-                <a:solidFill>
-                  <a:srgbClr val="EB6834"/>
-                </a:solidFill>
-                <a:latin typeface="Calibri"/>
-              </a:rPr>
-              <a:t>▸  </a:t>
-            </a:r>
-            <a:r>
-              <a:rPr sz="1700" b="1" i="0">
-                <a:solidFill>
-                  <a:srgbClr val="FFFFFF"/>
-                </a:solidFill>
-                <a:latin typeface="Calibri"/>
-              </a:rPr>
-              <a:t>cuBLAS: </a:t>
-            </a:r>
-            <a:r>
-              <a:rPr sz="1700" b="0" i="0">
-                <a:solidFill>
-                  <a:srgbClr val="D7E3F2"/>
-                </a:solidFill>
-                <a:latin typeface="Calibri"/>
-              </a:rPr>
-              <a:t>auf GEMM nicht geschlagen — Wert ist Allgemeinheit + Gewinne ohne guten Library-Pfad.</a:t>
-            </a:r>
-          </a:p>
-          <a:p>
-            <a:pPr>
-              <a:spcAft>
-                <a:spcPts val="1200"/>
-              </a:spcAft>
-            </a:pPr>
-            <a:r>
-              <a:rPr sz="1700" b="1" i="0">
-                <a:solidFill>
-                  <a:srgbClr val="EB6834"/>
-                </a:solidFill>
-                <a:latin typeface="Calibri"/>
-              </a:rPr>
-              <a:t>▸  </a:t>
-            </a:r>
-            <a:r>
-              <a:rPr sz="1700" b="1" i="0">
-                <a:solidFill>
-                  <a:srgbClr val="FFFFFF"/>
-                </a:solidFill>
-                <a:latin typeface="Calibri"/>
-              </a:rPr>
-              <a:t>Modell: </a:t>
-            </a:r>
-            <a:r>
-              <a:rPr sz="1700" b="0" i="0">
-                <a:solidFill>
-                  <a:srgbClr val="D7E3F2"/>
-                </a:solidFill>
-                <a:latin typeface="Calibri"/>
-              </a:rPr>
-              <a:t>v2 bester Vorfilter (97.8 % @ top-7), roofline bester Ranker — messen bleibt entscheidend.</a:t>
-            </a:r>
-          </a:p>
-          <a:p>
-            <a:pPr>
-              <a:spcAft>
-                <a:spcPts val="1200"/>
-              </a:spcAft>
-            </a:pPr>
-            <a:r>
-              <a:rPr sz="1700" b="1" i="0">
-                <a:solidFill>
-                  <a:srgbClr val="EB6834"/>
-                </a:solidFill>
-                <a:latin typeface="Calibri"/>
-              </a:rPr>
-              <a:t>▸  </a:t>
-            </a:r>
-            <a:r>
-              <a:rPr sz="1700" b="1" i="0">
-                <a:solidFill>
-                  <a:srgbClr val="FFFFFF"/>
-                </a:solidFill>
-                <a:latin typeface="Calibri"/>
-              </a:rPr>
-              <a:t>Praxis: </a:t>
-            </a:r>
-            <a:r>
-              <a:rPr sz="1700" b="0" i="0">
-                <a:solidFill>
-                  <a:srgbClr val="D7E3F2"/>
-                </a:solidFill>
-                <a:latin typeface="Calibri"/>
-              </a:rPr>
-              <a:t>GPU-spezifisch + gecacht; Cross-GPU by construction, auf der 3070 noch zu bestätigen.</a:t>
+            <a:pPr algn="l"/>
+            <a:r>
+              <a:rPr sz="1500" b="0" i="0">
+                <a:solidFill>
+                  <a:srgbClr val="3F3E3A"/>
+                </a:solidFill>
+                <a:latin typeface="Calibri"/>
+              </a:rPr>
+              <a:t>Break-even in Sekunden bei fester Shape; für stark dynamische Shapes hilft Bucketing/Padding.</a:t>
             </a:r>
           </a:p>
         </p:txBody>
@@ -9955,6 +9962,383 @@
                 <a:latin typeface="Calibri"/>
               </a:rPr>
               <a:t>Die Performance steckt in der Config, nicht im Kernel-Code — genau das automatisieren wir.</a:t>
+            </a:r>
+          </a:p>
+        </p:txBody>
+      </p:sp>
+    </p:spTree>
+  </p:cSld>
+  <p:clrMapOvr>
+    <a:masterClrMapping/>
+  </p:clrMapOvr>
+</p:sld>
+</file>
+
+<file path=ppt/slides/slide20.xml><?xml version="1.0" encoding="utf-8"?>
+<p:sld xmlns:a="http://schemas.openxmlformats.org/drawingml/2006/main" xmlns:p="http://schemas.openxmlformats.org/presentationml/2006/main" xmlns:r="http://schemas.openxmlformats.org/officeDocument/2006/relationships">
+  <p:cSld>
+    <p:bg>
+      <p:bgPr>
+        <a:solidFill>
+          <a:srgbClr val="0E1B2E"/>
+        </a:solidFill>
+        <a:effectLst/>
+      </p:bgPr>
+    </p:bg>
+    <p:spTree>
+      <p:nvGrpSpPr>
+        <p:cNvPr id="1" name=""/>
+        <p:cNvGrpSpPr/>
+        <p:nvPr/>
+      </p:nvGrpSpPr>
+      <p:grpSpPr/>
+      <p:sp>
+        <p:nvSpPr>
+          <p:cNvPr id="2" name="Rectangle 1"/>
+          <p:cNvSpPr/>
+          <p:nvPr/>
+        </p:nvSpPr>
+        <p:spPr>
+          <a:xfrm>
+            <a:off x="0" y="0"/>
+            <a:ext cx="320040" cy="6858000"/>
+          </a:xfrm>
+          <a:prstGeom prst="rect">
+            <a:avLst/>
+          </a:prstGeom>
+          <a:solidFill>
+            <a:srgbClr val="2A78D6"/>
+          </a:solidFill>
+          <a:ln>
+            <a:noFill/>
+          </a:ln>
+          <a:effectLst/>
+        </p:spPr>
+        <p:style>
+          <a:lnRef idx="1">
+            <a:schemeClr val="accent1"/>
+          </a:lnRef>
+          <a:fillRef idx="3">
+            <a:schemeClr val="accent1"/>
+          </a:fillRef>
+          <a:effectRef idx="2">
+            <a:schemeClr val="accent1"/>
+          </a:effectRef>
+          <a:fontRef idx="minor">
+            <a:schemeClr val="lt1"/>
+          </a:fontRef>
+        </p:style>
+        <p:txBody>
+          <a:bodyPr rtlCol="0" anchor="ctr"/>
+          <a:lstStyle/>
+          <a:p>
+            <a:pPr algn="ctr"/>
+          </a:p>
+        </p:txBody>
+      </p:sp>
+      <p:sp>
+        <p:nvSpPr>
+          <p:cNvPr id="3" name="TextBox 2"/>
+          <p:cNvSpPr txBox="1"/>
+          <p:nvPr/>
+        </p:nvSpPr>
+        <p:spPr>
+          <a:xfrm>
+            <a:off x="822960" y="621792"/>
+            <a:ext cx="10515600" cy="347472"/>
+          </a:xfrm>
+          <a:prstGeom prst="rect">
+            <a:avLst/>
+          </a:prstGeom>
+          <a:noFill/>
+        </p:spPr>
+        <p:txBody>
+          <a:bodyPr wrap="square" anchor="t">
+            <a:spAutoFit/>
+          </a:bodyPr>
+          <a:lstStyle/>
+          <a:p>
+            <a:pPr algn="l"/>
+            <a:r>
+              <a:rPr sz="1500" b="1" i="0">
+                <a:solidFill>
+                  <a:srgbClr val="2A78D6"/>
+                </a:solidFill>
+                <a:latin typeface="Calibri"/>
+              </a:rPr>
+              <a:t>FAZIT</a:t>
+            </a:r>
+          </a:p>
+        </p:txBody>
+      </p:sp>
+      <p:sp>
+        <p:nvSpPr>
+          <p:cNvPr id="4" name="TextBox 3"/>
+          <p:cNvSpPr txBox="1"/>
+          <p:nvPr/>
+        </p:nvSpPr>
+        <p:spPr>
+          <a:xfrm>
+            <a:off x="786384" y="1078992"/>
+            <a:ext cx="10972800" cy="822960"/>
+          </a:xfrm>
+          <a:prstGeom prst="rect">
+            <a:avLst/>
+          </a:prstGeom>
+          <a:noFill/>
+        </p:spPr>
+        <p:txBody>
+          <a:bodyPr wrap="square" anchor="t">
+            <a:spAutoFit/>
+          </a:bodyPr>
+          <a:lstStyle/>
+          <a:p>
+            <a:pPr algn="l"/>
+            <a:r>
+              <a:rPr sz="2600" b="1" i="0">
+                <a:solidFill>
+                  <a:srgbClr val="FFFFFF"/>
+                </a:solidFill>
+                <a:latin typeface="Calibri"/>
+              </a:rPr>
+              <a:t>Eingrenzen ist sicher — entscheiden muss man messen</a:t>
+            </a:r>
+          </a:p>
+        </p:txBody>
+      </p:sp>
+      <p:sp>
+        <p:nvSpPr>
+          <p:cNvPr id="5" name="Rectangle 4"/>
+          <p:cNvSpPr/>
+          <p:nvPr/>
+        </p:nvSpPr>
+        <p:spPr>
+          <a:xfrm>
+            <a:off x="822960" y="1874519"/>
+            <a:ext cx="1828800" cy="54864"/>
+          </a:xfrm>
+          <a:prstGeom prst="rect">
+            <a:avLst/>
+          </a:prstGeom>
+          <a:solidFill>
+            <a:srgbClr val="EB6834"/>
+          </a:solidFill>
+          <a:ln>
+            <a:noFill/>
+          </a:ln>
+          <a:effectLst/>
+        </p:spPr>
+        <p:style>
+          <a:lnRef idx="1">
+            <a:schemeClr val="accent1"/>
+          </a:lnRef>
+          <a:fillRef idx="3">
+            <a:schemeClr val="accent1"/>
+          </a:fillRef>
+          <a:effectRef idx="2">
+            <a:schemeClr val="accent1"/>
+          </a:effectRef>
+          <a:fontRef idx="minor">
+            <a:schemeClr val="lt1"/>
+          </a:fontRef>
+        </p:style>
+        <p:txBody>
+          <a:bodyPr rtlCol="0" anchor="ctr"/>
+          <a:lstStyle/>
+          <a:p>
+            <a:pPr algn="ctr"/>
+          </a:p>
+        </p:txBody>
+      </p:sp>
+      <p:sp>
+        <p:nvSpPr>
+          <p:cNvPr id="6" name="TextBox 5"/>
+          <p:cNvSpPr txBox="1"/>
+          <p:nvPr/>
+        </p:nvSpPr>
+        <p:spPr>
+          <a:xfrm>
+            <a:off x="822960" y="2194560"/>
+            <a:ext cx="10607040" cy="4023360"/>
+          </a:xfrm>
+          <a:prstGeom prst="rect">
+            <a:avLst/>
+          </a:prstGeom>
+          <a:noFill/>
+        </p:spPr>
+        <p:txBody>
+          <a:bodyPr wrap="square">
+            <a:spAutoFit/>
+          </a:bodyPr>
+          <a:lstStyle/>
+          <a:p>
+            <a:pPr>
+              <a:spcAft>
+                <a:spcPts val="1200"/>
+              </a:spcAft>
+            </a:pPr>
+            <a:r>
+              <a:rPr sz="1700" b="1" i="0">
+                <a:solidFill>
+                  <a:srgbClr val="EB6834"/>
+                </a:solidFill>
+                <a:latin typeface="Calibri"/>
+              </a:rPr>
+              <a:t>▸  </a:t>
+            </a:r>
+            <a:r>
+              <a:rPr sz="1700" b="1" i="0">
+                <a:solidFill>
+                  <a:srgbClr val="FFFFFF"/>
+                </a:solidFill>
+                <a:latin typeface="Calibri"/>
+              </a:rPr>
+              <a:t>A05: </a:t>
+            </a:r>
+            <a:r>
+              <a:rPr sz="1700" b="0" i="0">
+                <a:solidFill>
+                  <a:srgbClr val="D7E3F2"/>
+                </a:solidFill>
+                <a:latin typeface="Calibri"/>
+              </a:rPr>
+              <a:t>Tuner reproduziert Hand (Ø 1.03×), gewinnt bei krummen Shapes (+58 %).</a:t>
+            </a:r>
+          </a:p>
+          <a:p>
+            <a:pPr>
+              <a:spcAft>
+                <a:spcPts val="1200"/>
+              </a:spcAft>
+            </a:pPr>
+            <a:r>
+              <a:rPr sz="1700" b="1" i="0">
+                <a:solidFill>
+                  <a:srgbClr val="EB6834"/>
+                </a:solidFill>
+                <a:latin typeface="Calibri"/>
+              </a:rPr>
+              <a:t>▸  </a:t>
+            </a:r>
+            <a:r>
+              <a:rPr sz="1700" b="1" i="0">
+                <a:solidFill>
+                  <a:srgbClr val="FFFFFF"/>
+                </a:solidFill>
+                <a:latin typeface="Calibri"/>
+              </a:rPr>
+              <a:t>A06: </a:t>
+            </a:r>
+            <a:r>
+              <a:rPr sz="1700" b="0" i="0">
+                <a:solidFill>
+                  <a:srgbClr val="D7E3F2"/>
+                </a:solidFill>
+                <a:latin typeface="Calibri"/>
+              </a:rPr>
+              <a:t>sauberer Transfer, ein zusätzlicher Kernel-Typ, schlägt den Handkernel (+24 %).</a:t>
+            </a:r>
+          </a:p>
+          <a:p>
+            <a:pPr>
+              <a:spcAft>
+                <a:spcPts val="1200"/>
+              </a:spcAft>
+            </a:pPr>
+            <a:r>
+              <a:rPr sz="1700" b="1" i="0">
+                <a:solidFill>
+                  <a:srgbClr val="EB6834"/>
+                </a:solidFill>
+                <a:latin typeface="Calibri"/>
+              </a:rPr>
+              <a:t>▸  </a:t>
+            </a:r>
+            <a:r>
+              <a:rPr sz="1700" b="1" i="0">
+                <a:solidFill>
+                  <a:srgbClr val="FFFFFF"/>
+                </a:solidFill>
+                <a:latin typeface="Calibri"/>
+              </a:rPr>
+              <a:t>cuBLAS: </a:t>
+            </a:r>
+            <a:r>
+              <a:rPr sz="1700" b="0" i="0">
+                <a:solidFill>
+                  <a:srgbClr val="D7E3F2"/>
+                </a:solidFill>
+                <a:latin typeface="Calibri"/>
+              </a:rPr>
+              <a:t>auf GEMM nicht geschlagen — Wert ist Allgemeinheit + Gewinne ohne guten Library-Pfad.</a:t>
+            </a:r>
+          </a:p>
+          <a:p>
+            <a:pPr>
+              <a:spcAft>
+                <a:spcPts val="1200"/>
+              </a:spcAft>
+            </a:pPr>
+            <a:r>
+              <a:rPr sz="1700" b="1" i="0">
+                <a:solidFill>
+                  <a:srgbClr val="EB6834"/>
+                </a:solidFill>
+                <a:latin typeface="Calibri"/>
+              </a:rPr>
+              <a:t>▸  </a:t>
+            </a:r>
+            <a:r>
+              <a:rPr sz="1700" b="1" i="0">
+                <a:solidFill>
+                  <a:srgbClr val="FFFFFF"/>
+                </a:solidFill>
+                <a:latin typeface="Calibri"/>
+              </a:rPr>
+              <a:t>Modell: </a:t>
+            </a:r>
+            <a:r>
+              <a:rPr sz="1700" b="0" i="0">
+                <a:solidFill>
+                  <a:srgbClr val="D7E3F2"/>
+                </a:solidFill>
+                <a:latin typeface="Calibri"/>
+              </a:rPr>
+              <a:t>v2 bester Vorfilter (97.8 % @ top-7), roofline bester Ranker — messen bleibt entscheidend.</a:t>
+            </a:r>
+          </a:p>
+          <a:p>
+            <a:pPr>
+              <a:spcAft>
+                <a:spcPts val="1200"/>
+              </a:spcAft>
+            </a:pPr>
+            <a:r>
+              <a:rPr sz="1700" b="1" i="0">
+                <a:solidFill>
+                  <a:srgbClr val="EB6834"/>
+                </a:solidFill>
+                <a:latin typeface="Calibri"/>
+              </a:rPr>
+              <a:t>▸  </a:t>
+            </a:r>
+            <a:r>
+              <a:rPr sz="1700" b="1" i="0">
+                <a:solidFill>
+                  <a:srgbClr val="FFFFFF"/>
+                </a:solidFill>
+                <a:latin typeface="Calibri"/>
+              </a:rPr>
+              <a:t>Praxis: </a:t>
+            </a:r>
+            <a:r>
+              <a:rPr sz="1700" b="0" i="0">
+                <a:solidFill>
+                  <a:srgbClr val="D7E3F2"/>
+                </a:solidFill>
+                <a:latin typeface="Calibri"/>
+              </a:rPr>
+              <a:t>GPU-spezifisch + gecacht — auf GB10 und 3070 bestätigt: Hebel wirkt, beste Config je GPU verschieden.</a:t>
             </a:r>
           </a:p>
         </p:txBody>

</xml_diff>

<commit_message>
Anpassungen Folien / Präsentation
</commit_message>
<xml_diff>
--- a/project/praesentation/cuTile_Auto-Tuner.pptx
+++ b/project/praesentation/cuTile_Auto-Tuner.pptx
@@ -25,6 +25,8 @@
     <p:sldId id="273" r:id="rId25"/>
     <p:sldId id="274" r:id="rId26"/>
     <p:sldId id="275" r:id="rId27"/>
+    <p:sldId id="276" r:id="rId28"/>
+    <p:sldId id="277" r:id="rId29"/>
   </p:sldIdLst>
   <p:sldSz cx="12191695" cy="6858000" type="screen4x3"/>
   <p:notesSz cx="6858000" cy="9144000"/>
@@ -591,7 +593,7 @@
           <a:lstStyle/>
           <a:p>
             <a:r>
-              <a:t>Teil 2 (Person 2): wie gut das Ganze misst.</a:t>
+              <a:t>A06-Ring acspx,bspy-&gt;abcyx: zwei Reduktionen (s,p), mehrere Output-Dims. Der eigentliche Knackpunkt ist die Batch-Topologie: A05 hat einen geteilten Batch c, A06 unabhaengige Batches (a,c nur in A, b nur in B). Der A05-Kernel indiziert A und B mit demselben c_idx — A06 kann das nicht ausdruecken. Deshalb ein zweiter Kernel-Typ (Ring-Kernel) mit Per-Tile-permute und aeusserer SEQ-Schleife ueber s. Enumerator 243 -&gt; Pruning 171 (nur Variante A). Der Single-M/N/K-Pfad (A05) bleibt bitgleich.</a:t>
             </a:r>
           </a:p>
         </p:txBody>
@@ -661,7 +663,7 @@
           <a:lstStyle/>
           <a:p>
             <a:r>
-              <a:t>Gemessen wird pro Shape: getunter Kernel, Default (naive 8x8), torch.einsum (cuBLAS), bei A06 zusaetzlich der Handkernel (49.84). fp16 rein, fp32 Akku. Jede Config wird gegen torch.einsum geprueft (allclose rtol=1e-2/atol=1e-1). Ergebnis: 8x342 (A05) + 8x171 (A06), alle korrekt, 0 Fehlschlaege, inkl. der unteilbaren krumm-Shapes. GB10: 48 SMs, 25 MB L2, integriert.</a:t>
+              <a:t>So haben wir die Reihenfolge definiert (verify + make_executable): die Dimensionen stehen immer in der Ordnung PAR links, dann SEQ, dann PRIM rechts. Regeln aus verify(): (1) keine K-Dim darf PAR sein (Reduktion nicht parallel), (2) alle SEQ links von allen PRIM, (3) alle PAR links von allen SEQ, (4) die rechtesten Dims sind PRIM und muessen je &gt;=1 M-, N- und K-Dim enthalten (das ist die mma-Kachel). Der Tuner splittet jede M/N-Dim in l2_outer x l2 x prim und K in outer x prim, markiert die letzte M/N/K-Dim als PRIM und legt den Rest ab: m_l2/n_l2 werden in Variante A als PAR (Swizzle ueber die Block-ID) gesetzt, in Variante B als SEQ-Loops im CTA. A06 legt zusaetzlich die unabhaengigen Batches (a,c,b) als PAR und die zweite Reduktion s als SEQ ab. Kurz: der Tuner sucht nur die Groessen und A/B — die Struktur/Reihenfolge ist fix, verify() garantiert die Gueltigkeit. Den konkreten Kernel-Code dazu haben wir auf Folie 7 (A05) und 9 (A06).</a:t>
             </a:r>
           </a:p>
         </p:txBody>
@@ -731,7 +733,7 @@
           <a:lstStyle/>
           <a:p>
             <a:r>
-              <a:t>Auf regulaeren GEMMs ist der Tuner ~1.00x = er bestaetigt das Handtuning. Wo die feste 8x8-Gruppe schlecht passt, gewinnt er: large_k +7 %, krumm +58 % (41.8 vs 26.6). Im Schnitt 1.03x, nie schlechter, 97.6 % des absoluten Optimums. Robuste Quasi-Universal-Config 128/128/64 (7 von 8), nur large_k will k_prim=128. 256-breite Tiles sind Gift (Registerbudget).</a:t>
+              <a:t>Teil 2 (Person 2): wie gut das Ganze misst.</a:t>
             </a:r>
           </a:p>
         </p:txBody>
@@ -801,7 +803,7 @@
           <a:lstStyle/>
           <a:p>
             <a:r>
-              <a:t>Auf reinem GEMM gewinnt cuBLAS (Tuner ~77 % von torch, geom. Mittel) — erwartbar, cuBLAS ist eine gereifte Library. Auf Ring-Shapes ist der Tuner im Mittel leicht vorn (~1.17x geom.), sehr shape-abhaengig: gross wo torchs Pfad schlecht ist (tall 3.95x, large_k 2.65x), schwach wo gut (krumm 0.38x). Ehrliche Korrektur: der Assignment-Wert A06_TORCH_EINSUM=16.18 ist veraltet; frisch macht dieselbe Shape 60.22 TFLOPS, gleichauf mit dem Tuner.</a:t>
+              <a:t>Gemessen wird pro Shape: getunter Kernel, Default (naive 8x8), torch.einsum (cuBLAS), bei A06 zusaetzlich der Handkernel (49.84). fp16 rein, fp32 Akku. Jede Config wird gegen torch.einsum geprueft (allclose rtol=1e-2/atol=1e-1). Ergebnis: 8x342 (A05) + 8x171 (A06), alle korrekt, 0 Fehlschlaege, inkl. der unteilbaren krumm-Shapes. GB10: 48 SMs, 25 MB L2, integriert.</a:t>
             </a:r>
           </a:p>
         </p:txBody>
@@ -871,7 +873,7 @@
           <a:lstStyle/>
           <a:p>
             <a:r>
-              <a:t>Referenz-Shape: Tuner ~60 gegen Handkernel 49.84 (+24 %), gegen die mismatchte 8x8-Default 26.3 (2.29x — aber das ist die falsche Messlatte), gleichauf mit frischem torch 60.2. Der Gewinn kommt aus k_prim=32: der Handkernel nahm p=64 als einen mma-Tile, der Tuner teilt in zwei 32er-Kacheln. Ueber alle 8 Ring-Shapes 1.10-2.47x ueber Default, alle 171 Configs je Shape korrekt inkl. Padding.</a:t>
+              <a:t>Vier Balken: Default (naive 8x8), Tuner-Pick (bester der Modell-Top-7 = was der Tuner praktisch liefert), Bench Best (bestes von 342 gemessenen Configs = Voll-Sweep-Optimum), torch (cuBLAS). Auf regulaeren GEMMs ist der Tuner-Pick ~= Default (bestaetigt das Handtuning); die Bench-Best liegt nur ~1-3 % drueber, nur bei krumm deutlich (26.6 -&gt; 41.8, +58 %). ENTSCHEIDEND fuer die Frage 'schlaegt torch unsere Bench-Best?': ja, auf 7/8 GEMM-Shapes liegt torch ueber unserer absoluten Bench-Best (nur die hand-getunte a05-Referenz zieht knapp vorbei). Der Grund ist nicht die Config-Suche, sondern die Kernel-Reife: cuBLAS nutzt hand-optimiertes SASS-Assembly, Split-K, ausgefeiltes Pipelining/Scheduling — Reife, die unser generisches ct.Constant-Template nicht erreicht. Das ist ehrlich und erwartbar; cuBLAS auf GEMM zu schlagen war nie das Ziel.</a:t>
             </a:r>
           </a:p>
         </p:txBody>
@@ -941,7 +943,7 @@
           <a:lstStyle/>
           <a:p>
             <a:r>
-              <a:t>Ground Truth = Voll-Sweep. Frage: zieht das Modell die real beste Config in die Top-k? Drei Stufen: top-7 (~3 s) -&gt; im Schnitt 97 % des Optimums; top-45 (~18 s) -&gt; 99 %; Voll-Sweep (~3 min) -&gt; 100 %. Die exakt Beste erwischt top-7 meist nicht (sie sitzt im Modell tief, das Spitzenfeld liegt innerhalb ~3 % im Messrauschen). Kostet aber praktisch nichts an Performance.</a:t>
+              <a:t>Auf reinem GEMM gewinnt cuBLAS (Tuner ~77 % von torch, geom. Mittel) — erwartbar, cuBLAS ist eine gereifte Library. Auf Ring-Shapes ist der Tuner im Mittel leicht vorn (~1.17x geom.), sehr shape-abhaengig: gross wo torchs Pfad schlecht ist (tall 3.95x, large_k 2.65x), schwach wo gut (krumm 0.38x). Ehrliche Korrektur: der Assignment-Wert A06_TORCH_EINSUM=16.18 ist veraltet; frisch macht dieselbe Shape 60.22 TFLOPS, gleichauf mit dem Tuner.</a:t>
             </a:r>
           </a:p>
         </p:txBody>
@@ -1011,7 +1013,7 @@
           <a:lstStyle/>
           <a:p>
             <a:r>
-              <a:t>Drei Kostenmodelle. bw (reine Bandbreite) rankt schlecht (Spearman +0.03) — falsche Physik, die GB10 hat 25 MB L2, fast alles resident, Knappheit ist Compute/Occupancy. v2 (bw + Register-Filter) +0.38 und 97.8 % top-7 -&gt; bleibt Default. roofline (max(memory,compute), L2-bewusst, selbst-umschaltend) korreliert am besten (+0.50), ist aber schlechterer Vorfilter (85.5 %), gerade weil er das Compute-Regime richtig trifft. Take-away: Korrelation != Vorfilter-Guete.</a:t>
+              <a:t>Referenz-Shape: Tuner ~60 gegen Handkernel 49.84 (+24 %), gegen die mismatchte 8x8-Default 26.3 (2.29x — aber das ist die falsche Messlatte), gleichauf mit frischem torch 60.2. Der Gewinn kommt aus k_prim=32: der Handkernel nahm p=64 als einen mma-Tile, der Tuner teilt in zwei 32er-Kacheln. Ueber alle 8 Ring-Shapes 1.10-2.47x ueber Default, alle 171 Configs je Shape korrekt inkl. Padding. Vierter Balken (Bench Best = bestes von 171): schlaegt torch dort, wo dessen Ring-Pfad schlecht ist (square, tall, wide, large_k), verliert wo torch einen guten Pfad findet (small_k, krumm, batch). Anders als bei A05 (wo cuBLAS immer gewinnt) ist die Ring-Familie also der Fall, in dem sich der eigene Kernel lohnt.</a:t>
             </a:r>
           </a:p>
         </p:txBody>
@@ -1081,7 +1083,7 @@
           <a:lstStyle/>
           <a:p>
             <a:r>
-              <a:t>Absolute TFLOPS der GB10 und 3070 zu vergleichen ist nicht sinnvoll (andere Peak-Leistung, Bandbreite, L2: 25 MB vs 4 MB). Vergleichbar ist der Optimierungshebel: der Speedup Tuner/Default pro Shape. Ergebnis: der Hebel wirkt auf beiden Karten, auf der 3070 sogar staerker (Ø 1.88x vs 1.36x) — der aus dem GB10-Handtuning stammende 8x8-Default passt auf der 3070 schlechter, also holt der Tuner dort mehr raus. Und die gemessen beste Config ist in 16/16 Shapes zwischen den Karten verschieden (GB10 mag 128/128, die 3070 oft 64/128 oder 256/64 mit anderem k_prim/L2). Das ist das Argument fuer GPU-spezifisches Autotuning und warum das GPU-Modell im Cache-Key steht. Portabilitaet ist by construction (alles aus device_props) — jetzt auch auf einer zweiten, bandbreitenlimitierten GPU bestaetigt.</a:t>
+              <a:t>Ground Truth = Voll-Sweep. Frage: zieht das Modell die real beste Config in die Top-k? Drei Stufen: top-7 (~3 s) -&gt; im Schnitt 97 % des Optimums; top-45 (~18 s) -&gt; 99 %; Voll-Sweep (~3 min) -&gt; 100 %. Die exakt Beste erwischt top-7 meist nicht (sie sitzt im Modell tief, das Spitzenfeld liegt innerhalb ~3 % im Messrauschen). Kostet aber praktisch nichts an Performance.</a:t>
             </a:r>
           </a:p>
         </p:txBody>
@@ -1151,7 +1153,7 @@
           <a:lstStyle/>
           <a:p>
             <a:r>
-              <a:t>Die gemessen beste Config ist in 16/16 Shapes zwischen GB10 und 3070 verschieden: die GB10 mag grosse 128x128-Tiles (25 MB L2 vertraegt sie), die 3070 kleineres k_prim=32 und oft asymmetrische/64-breite Tiles. Der Autotuner (v2-Modell, nur top-7 gemessen) trifft im Schnitt ~96 % (GB10) bzw. ~90 % (3070) des Optimums — auf der 3070 etwas unzuverlaessiger (einzelne Shapes wie krumm/square_1b fallen auf ~60-75 %). KOSTEN: eine Shape zu tunen (top-7 kompilieren+messen) kostet auf der GB10 ~3 s. Auf der 3070 lief alles unter WSL, wo der gcc-Compile viel langsamer ist — je nach Shape ~3 s bis ~2 min (ein voller Sweep dauerte dort bis ~1.9 h vs. ~5 min auf der GB10). Es ist ein Einmalkosten-Posten, der gecacht wird, und der Nutzen ist auf der 3070 groesser (Oe 1.88x) — fuer wiederverwendete Shapes lohnt es sich, fuer Einmalrechnungen auf der 3070 grenzwertig. BEWERTUNGSMETHODE: das Roofline-Modell schaltet sein Regime selbst per device_props um (max(memory,compute)). Interessant: die GB10 ist die bandbreiten-limitierte Karte (273 GB/s LPDDR, 3/16 Shapes memory-bound), die 3070 bleibt compute-bound (448 GB/s GDDR6, 0/16). Der praktische Tuner (autotune.py) nutzt aber fest v2, weil v2 auf beiden Karten der bessere top-7-Vorfilter ist (roofline korreliert global besser: Spearman +0.57 vs v2 +0.19 auf der 3070, ist aber schlechterer Vorfilter: 83 % vs 91 %).</a:t>
+              <a:t>Drei Kostenmodelle. bw (reine Bandbreite) rankt schlecht (Spearman +0.03) — falsche Physik, die GB10 hat 25 MB L2, fast alles resident, Knappheit ist Compute/Occupancy. v2 (bw + Register-Filter) +0.38 und 97.8 % top-7 -&gt; bleibt Default. roofline (max(memory,compute), L2-bewusst, selbst-umschaltend) korreliert am besten (+0.50), ist aber schlechterer Vorfilter (85.5 %), gerade weil er das Compute-Regime richtig trifft. Take-away: Korrelation != Vorfilter-Guete.</a:t>
             </a:r>
           </a:p>
         </p:txBody>
@@ -1221,7 +1223,7 @@
           <a:lstStyle/>
           <a:p>
             <a:r>
-              <a:t>Tuning lohnt sich ueber Wiederverwendung. Eine Kontraktion laeuft ~8 ms, die 3 s Tuning amortisieren sich, sobald dieselbe Shape oft laeuft — im Training/Inferenz der Normalfall (feste Layer-Dims). Config-Cache (cache.py + autotune.py), Key inkl. GPU-Modell. End-to-end bestaetigt: 16 Shapes getunt &amp; gecacht, 2. Aufruf Cache-Hit, Top-7-Picks bei ~95-100 %. Nur bei stark dynamischen Shapes geht die Rechnung nicht auf -&gt; Bucketing/Padding.</a:t>
+              <a:t>Absolute TFLOPS der GB10 und 3070 zu vergleichen ist nicht sinnvoll (andere Peak-Leistung, Bandbreite, L2: 25 MB vs 4 MB). Vergleichbar ist der Optimierungshebel: der Speedup Tuner/Default pro Shape. Ergebnis: der Hebel wirkt auf beiden Karten, auf der 3070 sogar staerker (Ø 1.88x vs 1.36x) — der aus dem GB10-Handtuning stammende 8x8-Default passt auf der 3070 schlechter, also holt der Tuner dort mehr raus. Und die gemessen beste Config ist in 16/16 Shapes zwischen den Karten verschieden (GB10 mag 128/128, die 3070 oft 64/128 oder 256/64 mit anderem k_prim/L2). Das ist das Argument fuer GPU-spezifisches Autotuning und warum das GPU-Modell im Cache-Key steht. Portabilitaet ist by construction (alles aus device_props) — jetzt auch auf einer zweiten, bandbreitenlimitierten GPU bestaetigt.</a:t>
             </a:r>
           </a:p>
         </p:txBody>
@@ -1361,6 +1363,146 @@
           <a:lstStyle/>
           <a:p>
             <a:r>
+              <a:t>Die gemessen beste Config ist in 16/16 Shapes zwischen GB10 und 3070 verschieden: die GB10 mag grosse 128x128-Tiles (25 MB L2 vertraegt sie), die 3070 kleineres k_prim=32 und oft asymmetrische/64-breite Tiles. Der Autotuner (v2-Modell, nur top-7 gemessen) trifft im Schnitt ~96 % (GB10) bzw. ~90 % (3070) des Optimums — auf der 3070 etwas unzuverlaessiger (einzelne Shapes wie krumm/square_1b fallen auf ~60-75 %). KOSTEN: eine Shape zu tunen (top-7 kompilieren+messen) kostet auf der GB10 ~3 s. Auf der 3070 lief alles unter WSL, wo der gcc-Compile viel langsamer ist — je nach Shape ~3 s bis ~2 min (ein voller Sweep dauerte dort bis ~1.9 h vs. ~5 min auf der GB10). Es ist ein Einmalkosten-Posten, der gecacht wird, und der Nutzen ist auf der 3070 groesser (Oe 1.88x) — fuer wiederverwendete Shapes lohnt es sich, fuer Einmalrechnungen auf der 3070 grenzwertig. BEWERTUNGSMETHODE: das Roofline-Modell schaltet sein Regime selbst per device_props um (max(memory,compute)). Interessant: die GB10 ist die bandbreiten-limitierte Karte (273 GB/s LPDDR, 3/16 Shapes memory-bound), die 3070 bleibt compute-bound (448 GB/s GDDR6, 0/16). Der praktische Tuner (autotune.py) nutzt aber fest v2, weil v2 auf beiden Karten der bessere top-7-Vorfilter ist (roofline korreliert global besser: Spearman +0.57 vs v2 +0.19 auf der 3070, ist aber schlechterer Vorfilter: 83 % vs 91 %).</a:t>
+            </a:r>
+          </a:p>
+        </p:txBody>
+      </p:sp>
+      <p:sp>
+        <p:nvSpPr>
+          <p:cNvPr id="4" name="Slide Number Placeholder 3"/>
+          <p:cNvSpPr>
+            <a:spLocks noGrp="1"/>
+          </p:cNvSpPr>
+          <p:nvPr>
+            <p:ph type="sldNum" idx="5" sz="quarter"/>
+          </p:nvPr>
+        </p:nvSpPr>
+        <p:spPr/>
+      </p:sp>
+    </p:spTree>
+  </p:cSld>
+  <p:clrMapOvr>
+    <a:masterClrMapping/>
+  </p:clrMapOvr>
+</p:notes>
+</file>
+
+<file path=ppt/notesSlides/notesSlide21.xml><?xml version="1.0" encoding="utf-8"?>
+<p:notes xmlns:a="http://schemas.openxmlformats.org/drawingml/2006/main" xmlns:p="http://schemas.openxmlformats.org/presentationml/2006/main" xmlns:r="http://schemas.openxmlformats.org/officeDocument/2006/relationships">
+  <p:cSld>
+    <p:spTree>
+      <p:nvGrpSpPr>
+        <p:cNvPr id="1" name=""/>
+        <p:cNvGrpSpPr/>
+        <p:nvPr/>
+      </p:nvGrpSpPr>
+      <p:grpSpPr>
+        <a:xfrm>
+          <a:off x="0" y="0"/>
+          <a:ext cx="0" cy="0"/>
+          <a:chOff x="0" y="0"/>
+          <a:chExt cx="0" cy="0"/>
+        </a:xfrm>
+      </p:grpSpPr>
+      <p:sp>
+        <p:nvSpPr>
+          <p:cNvPr id="2" name="Slide Image Placeholder 1"/>
+          <p:cNvSpPr>
+            <a:spLocks noGrp="1"/>
+          </p:cNvSpPr>
+          <p:nvPr>
+            <p:ph type="sldImg" idx="2"/>
+          </p:nvPr>
+        </p:nvSpPr>
+        <p:spPr/>
+      </p:sp>
+      <p:sp>
+        <p:nvSpPr>
+          <p:cNvPr id="3" name="Notes Placeholder 2"/>
+          <p:cNvSpPr>
+            <a:spLocks noGrp="1"/>
+          </p:cNvSpPr>
+          <p:nvPr>
+            <p:ph type="body" idx="3" sz="quarter"/>
+          </p:nvPr>
+        </p:nvSpPr>
+        <p:spPr/>
+        <p:txBody>
+          <a:bodyPr/>
+          <a:lstStyle/>
+          <a:p>
+            <a:r>
+              <a:t>Tuning lohnt sich ueber Wiederverwendung. Eine Kontraktion laeuft ~8 ms, die 3 s Tuning amortisieren sich, sobald dieselbe Shape oft laeuft — im Training/Inferenz der Normalfall (feste Layer-Dims). Config-Cache (cache.py + autotune.py), Key inkl. GPU-Modell. End-to-end bestaetigt: 16 Shapes getunt &amp; gecacht, 2. Aufruf Cache-Hit, Top-7-Picks bei ~95-100 %. Nur bei stark dynamischen Shapes geht die Rechnung nicht auf -&gt; Bucketing/Padding.</a:t>
+            </a:r>
+          </a:p>
+        </p:txBody>
+      </p:sp>
+      <p:sp>
+        <p:nvSpPr>
+          <p:cNvPr id="4" name="Slide Number Placeholder 3"/>
+          <p:cNvSpPr>
+            <a:spLocks noGrp="1"/>
+          </p:cNvSpPr>
+          <p:nvPr>
+            <p:ph type="sldNum" idx="5" sz="quarter"/>
+          </p:nvPr>
+        </p:nvSpPr>
+        <p:spPr/>
+      </p:sp>
+    </p:spTree>
+  </p:cSld>
+  <p:clrMapOvr>
+    <a:masterClrMapping/>
+  </p:clrMapOvr>
+</p:notes>
+</file>
+
+<file path=ppt/notesSlides/notesSlide22.xml><?xml version="1.0" encoding="utf-8"?>
+<p:notes xmlns:a="http://schemas.openxmlformats.org/drawingml/2006/main" xmlns:p="http://schemas.openxmlformats.org/presentationml/2006/main" xmlns:r="http://schemas.openxmlformats.org/officeDocument/2006/relationships">
+  <p:cSld>
+    <p:spTree>
+      <p:nvGrpSpPr>
+        <p:cNvPr id="1" name=""/>
+        <p:cNvGrpSpPr/>
+        <p:nvPr/>
+      </p:nvGrpSpPr>
+      <p:grpSpPr>
+        <a:xfrm>
+          <a:off x="0" y="0"/>
+          <a:ext cx="0" cy="0"/>
+          <a:chOff x="0" y="0"/>
+          <a:chExt cx="0" cy="0"/>
+        </a:xfrm>
+      </p:grpSpPr>
+      <p:sp>
+        <p:nvSpPr>
+          <p:cNvPr id="2" name="Slide Image Placeholder 1"/>
+          <p:cNvSpPr>
+            <a:spLocks noGrp="1"/>
+          </p:cNvSpPr>
+          <p:nvPr>
+            <p:ph type="sldImg" idx="2"/>
+          </p:nvPr>
+        </p:nvSpPr>
+        <p:spPr/>
+      </p:sp>
+      <p:sp>
+        <p:nvSpPr>
+          <p:cNvPr id="3" name="Notes Placeholder 2"/>
+          <p:cNvSpPr>
+            <a:spLocks noGrp="1"/>
+          </p:cNvSpPr>
+          <p:nvPr>
+            <p:ph type="body" idx="3" sz="quarter"/>
+          </p:nvPr>
+        </p:nvSpPr>
+        <p:spPr/>
+        <p:txBody>
+          <a:bodyPr/>
+          <a:lstStyle/>
+          <a:p>
+            <a:r>
               <a:t>Kernaussagen: A05 reproduziert Hand, A06 transferiert und schlaegt den Handkernel, cuBLAS wird auf GEMM nicht geschlagen (Wert = Allgemeinheit + Gewinne wo die Library keinen Pfad hat), das Modell taugt als Vorfilter (v2) aber nicht als exakter Ranker, und der Praxiswert ist GPU-spezifisches, gecachtes Tuning. Wichtigste Erkenntnis: die Eingrenzung ist das Sichere, die Entscheidung muss man messen.</a:t>
             </a:r>
           </a:p>
@@ -1851,7 +1993,7 @@
           <a:lstStyle/>
           <a:p>
             <a:r>
-              <a:t>A06-Ring acspx,bspy-&gt;abcyx: zwei Reduktionen (s,p), mehrere Output-Dims. Der eigentliche Knackpunkt ist die Batch-Topologie: A05 hat einen geteilten Batch c, A06 unabhaengige Batches (a,c nur in A, b nur in B). Der A05-Kernel indiziert A und B mit demselben c_idx — A06 kann das nicht ausdruecken. Deshalb ein zweiter Kernel-Typ (Ring-Kernel) mit Per-Tile-permute und aeusserer SEQ-Schleife ueber s. Enumerator 243 -&gt; Pruning 171 (nur Variante A). Der Single-M/N/K-Pfad (A05) bleibt bitgleich.</a:t>
+              <a:t>Detail zur Pruning-Folie. PRUNING rechnet vier Dinge vor dem Compile: (1) alle Prim-Groessen Vielfache von 16 (fp16-Tensor-Cores); (2) Shared Memory pro Block = (m_prim·k_prim + k_prim·n_prim) · 2 Byte (fp16) · 2 (Double-Buffering) muss ins nutzbare SMEM (101376 − 1024 ≈ 100 KB) passen → 126 Configs raus; (3) der fp32-Akku braucht m_prim·n_prim Register (1 pro Element), unter der halben Registerdatei (½·65536 = 32768) → 18 raus; (4) gepaddetes Volumen ≤ 8× Original. RANKING schaetzt den DRAM-Traffic: A wird pro Gruppen-Spalte geladen, B pro Gruppen-Zeile, C einmal → Traffic ≈ [ M·K·ceil(N/(n_l2·n_prim)) + K·N·ceil(M/(m_l2·m_prim)) + M·N ] · 2 Byte. Groessere L2-Gruppe = kleinere ceil-Terme = weniger Traffic (das ist der L2-Reuse im Modell). Zeit = Traffic / Bandbreite, BW = mem_clock · (Bus/8) ≈ 273 GB/s (GB10, LPDDR). Die Roofline nimmt max(t_mem, t_compute) mit t_compute = 2·M·N·K / (Peak · util), Peak = SMs · Takt · FMAs · 2 ≈ 119 TFLOPS. Alle Hardware-Werte kommen aus device_props — deshalb ist das Modell portabel (auf der 3070 andere Zahlen, gleiche Formeln).</a:t>
             </a:r>
           </a:p>
         </p:txBody>
@@ -5154,7 +5296,7 @@
     <p:bg>
       <p:bgPr>
         <a:solidFill>
-          <a:srgbClr val="0E1B2E"/>
+          <a:srgbClr val="FFFFFF"/>
         </a:solidFill>
         <a:effectLst/>
       </p:bgPr>
@@ -5168,14 +5310,84 @@
       <p:grpSpPr/>
       <p:sp>
         <p:nvSpPr>
-          <p:cNvPr id="2" name="Rectangle 1"/>
+          <p:cNvPr id="2" name="TextBox 1"/>
+          <p:cNvSpPr txBox="1"/>
+          <p:nvPr/>
+        </p:nvSpPr>
+        <p:spPr>
+          <a:xfrm>
+            <a:off x="640080" y="384048"/>
+            <a:ext cx="10972800" cy="256032"/>
+          </a:xfrm>
+          <a:prstGeom prst="rect">
+            <a:avLst/>
+          </a:prstGeom>
+          <a:noFill/>
+        </p:spPr>
+        <p:txBody>
+          <a:bodyPr wrap="square" anchor="t">
+            <a:spAutoFit/>
+          </a:bodyPr>
+          <a:lstStyle/>
+          <a:p>
+            <a:pPr algn="l"/>
+            <a:r>
+              <a:rPr sz="1250" b="1" i="0">
+                <a:solidFill>
+                  <a:srgbClr val="2A78D6"/>
+                </a:solidFill>
+                <a:latin typeface="Calibri"/>
+              </a:rPr>
+              <a:t>ERWEITERUNG</a:t>
+            </a:r>
+          </a:p>
+        </p:txBody>
+      </p:sp>
+      <p:sp>
+        <p:nvSpPr>
+          <p:cNvPr id="3" name="TextBox 2"/>
+          <p:cNvSpPr txBox="1"/>
+          <p:nvPr/>
+        </p:nvSpPr>
+        <p:spPr>
+          <a:xfrm>
+            <a:off x="621792" y="676656"/>
+            <a:ext cx="10972800" cy="822960"/>
+          </a:xfrm>
+          <a:prstGeom prst="rect">
+            <a:avLst/>
+          </a:prstGeom>
+          <a:noFill/>
+        </p:spPr>
+        <p:txBody>
+          <a:bodyPr wrap="square" anchor="t">
+            <a:spAutoFit/>
+          </a:bodyPr>
+          <a:lstStyle/>
+          <a:p>
+            <a:pPr algn="l"/>
+            <a:r>
+              <a:rPr sz="2700" b="1" i="0">
+                <a:solidFill>
+                  <a:srgbClr val="0B0B0B"/>
+                </a:solidFill>
+                <a:latin typeface="Calibri"/>
+              </a:rPr>
+              <a:t>A06: eine zweite Struktur-Familie</a:t>
+            </a:r>
+          </a:p>
+        </p:txBody>
+      </p:sp>
+      <p:sp>
+        <p:nvSpPr>
+          <p:cNvPr id="4" name="Rectangle 3"/>
           <p:cNvSpPr/>
           <p:nvPr/>
         </p:nvSpPr>
         <p:spPr>
           <a:xfrm>
-            <a:off x="0" y="0"/>
-            <a:ext cx="320040" cy="6858000"/>
+            <a:off x="658368" y="1389888"/>
+            <a:ext cx="1920240" cy="50292"/>
           </a:xfrm>
           <a:prstGeom prst="rect">
             <a:avLst/>
@@ -5212,14 +5424,14 @@
       </p:sp>
       <p:sp>
         <p:nvSpPr>
-          <p:cNvPr id="3" name="TextBox 2"/>
+          <p:cNvPr id="5" name="TextBox 4"/>
           <p:cNvSpPr txBox="1"/>
           <p:nvPr/>
         </p:nvSpPr>
         <p:spPr>
           <a:xfrm>
-            <a:off x="822960" y="2487168"/>
-            <a:ext cx="10515600" cy="365760"/>
+            <a:off x="640080" y="6455664"/>
+            <a:ext cx="6400800" cy="274320"/>
           </a:xfrm>
           <a:prstGeom prst="rect">
             <a:avLst/>
@@ -5234,27 +5446,27 @@
           <a:p>
             <a:pPr algn="l"/>
             <a:r>
-              <a:rPr sz="1800" b="1" i="0">
-                <a:solidFill>
-                  <a:srgbClr val="2A78D6"/>
-                </a:solidFill>
-                <a:latin typeface="Calibri"/>
-              </a:rPr>
-              <a:t>TEIL 2</a:t>
-            </a:r>
-          </a:p>
-        </p:txBody>
-      </p:sp>
-      <p:sp>
-        <p:nvSpPr>
-          <p:cNvPr id="4" name="TextBox 3"/>
+              <a:rPr sz="1000" b="0" i="0">
+                <a:solidFill>
+                  <a:srgbClr val="898781"/>
+                </a:solidFill>
+                <a:latin typeface="Calibri"/>
+              </a:rPr>
+              <a:t>cuTile Auto-Tuner · Becker-Klöser · Elagina</a:t>
+            </a:r>
+          </a:p>
+        </p:txBody>
+      </p:sp>
+      <p:sp>
+        <p:nvSpPr>
+          <p:cNvPr id="6" name="TextBox 5"/>
           <p:cNvSpPr txBox="1"/>
           <p:nvPr/>
         </p:nvSpPr>
         <p:spPr>
           <a:xfrm>
-            <a:off x="786384" y="2926080"/>
-            <a:ext cx="10607040" cy="1280160"/>
+            <a:off x="10607040" y="6455664"/>
+            <a:ext cx="1005840" cy="274320"/>
           </a:xfrm>
           <a:prstGeom prst="rect">
             <a:avLst/>
@@ -5267,29 +5479,188 @@
           </a:bodyPr>
           <a:lstStyle/>
           <a:p>
-            <a:pPr algn="l"/>
-            <a:r>
-              <a:rPr sz="4000" b="1" i="0">
-                <a:solidFill>
-                  <a:srgbClr val="FFFFFF"/>
-                </a:solidFill>
-                <a:latin typeface="Calibri"/>
-              </a:rPr>
-              <a:t>Evaluation &amp; Ergebnisse</a:t>
-            </a:r>
-          </a:p>
-        </p:txBody>
-      </p:sp>
-      <p:sp>
-        <p:nvSpPr>
-          <p:cNvPr id="5" name="Rectangle 4"/>
+            <a:pPr algn="r"/>
+            <a:r>
+              <a:rPr sz="1000" b="0" i="0">
+                <a:solidFill>
+                  <a:srgbClr val="898781"/>
+                </a:solidFill>
+                <a:latin typeface="Calibri"/>
+              </a:rPr>
+              <a:t>08</a:t>
+            </a:r>
+          </a:p>
+        </p:txBody>
+      </p:sp>
+      <p:pic>
+        <p:nvPicPr>
+          <p:cNvPr id="7" name="Picture 6" descr="code_ring_a.png"/>
+          <p:cNvPicPr>
+            <a:picLocks noChangeAspect="1"/>
+          </p:cNvPicPr>
+          <p:nvPr/>
+        </p:nvPicPr>
+        <p:blipFill>
+          <a:blip r:embed="rId2"/>
+          <a:stretch>
+            <a:fillRect/>
+          </a:stretch>
+        </p:blipFill>
+        <p:spPr>
+          <a:xfrm>
+            <a:off x="1024574" y="1554480"/>
+            <a:ext cx="6729090" cy="4114800"/>
+          </a:xfrm>
+          <a:prstGeom prst="rect">
+            <a:avLst/>
+          </a:prstGeom>
+        </p:spPr>
+      </p:pic>
+      <p:sp>
+        <p:nvSpPr>
+          <p:cNvPr id="8" name="TextBox 7"/>
+          <p:cNvSpPr txBox="1"/>
+          <p:nvPr/>
+        </p:nvSpPr>
+        <p:spPr>
+          <a:xfrm>
+            <a:off x="8412480" y="1874519"/>
+            <a:ext cx="3246120" cy="3840480"/>
+          </a:xfrm>
+          <a:prstGeom prst="rect">
+            <a:avLst/>
+          </a:prstGeom>
+          <a:noFill/>
+        </p:spPr>
+        <p:txBody>
+          <a:bodyPr wrap="square">
+            <a:spAutoFit/>
+          </a:bodyPr>
+          <a:lstStyle/>
+          <a:p>
+            <a:pPr>
+              <a:lnSpc>
+                <a:spcPct val="110000"/>
+              </a:lnSpc>
+              <a:spcAft>
+                <a:spcPts val="1000"/>
+              </a:spcAft>
+            </a:pPr>
+            <a:r>
+              <a:rPr sz="1450" b="1" i="0">
+                <a:solidFill>
+                  <a:srgbClr val="2A78D6"/>
+                </a:solidFill>
+                <a:latin typeface="Calibri"/>
+              </a:rPr>
+              <a:t>▸  </a:t>
+            </a:r>
+            <a:r>
+              <a:rPr sz="1450" b="0" i="0">
+                <a:solidFill>
+                  <a:srgbClr val="3F3E3A"/>
+                </a:solidFill>
+                <a:latin typeface="Calibri"/>
+              </a:rPr>
+              <a:t>Nicht „doppeltes K" — die Batch-Topologie ist das Problem.</a:t>
+            </a:r>
+          </a:p>
+          <a:p>
+            <a:pPr>
+              <a:lnSpc>
+                <a:spcPct val="110000"/>
+              </a:lnSpc>
+              <a:spcAft>
+                <a:spcPts val="1000"/>
+              </a:spcAft>
+            </a:pPr>
+            <a:r>
+              <a:rPr sz="1450" b="1" i="0">
+                <a:solidFill>
+                  <a:srgbClr val="2A78D6"/>
+                </a:solidFill>
+                <a:latin typeface="Calibri"/>
+              </a:rPr>
+              <a:t>▸  </a:t>
+            </a:r>
+            <a:r>
+              <a:rPr sz="1450" b="0" i="0">
+                <a:solidFill>
+                  <a:srgbClr val="3F3E3A"/>
+                </a:solidFill>
+                <a:latin typeface="Calibri"/>
+              </a:rPr>
+              <a:t>A05: geteilter Batch c. A06: unabhängige a,c (A) und b (B).</a:t>
+            </a:r>
+          </a:p>
+          <a:p>
+            <a:pPr>
+              <a:lnSpc>
+                <a:spcPct val="110000"/>
+              </a:lnSpc>
+              <a:spcAft>
+                <a:spcPts val="1000"/>
+              </a:spcAft>
+            </a:pPr>
+            <a:r>
+              <a:rPr sz="1450" b="1" i="0">
+                <a:solidFill>
+                  <a:srgbClr val="2A78D6"/>
+                </a:solidFill>
+                <a:latin typeface="Calibri"/>
+              </a:rPr>
+              <a:t>▸  </a:t>
+            </a:r>
+            <a:r>
+              <a:rPr sz="1450" b="0" i="0">
+                <a:solidFill>
+                  <a:srgbClr val="3F3E3A"/>
+                </a:solidFill>
+                <a:latin typeface="Calibri"/>
+              </a:rPr>
+              <a:t>→ zweiter Kernel-Typ (Ring), kein Umbau.</a:t>
+            </a:r>
+          </a:p>
+          <a:p>
+            <a:pPr>
+              <a:lnSpc>
+                <a:spcPct val="110000"/>
+              </a:lnSpc>
+              <a:spcAft>
+                <a:spcPts val="1000"/>
+              </a:spcAft>
+            </a:pPr>
+            <a:r>
+              <a:rPr sz="1450" b="1" i="0">
+                <a:solidFill>
+                  <a:srgbClr val="2A78D6"/>
+                </a:solidFill>
+                <a:latin typeface="Calibri"/>
+              </a:rPr>
+              <a:t>▸  </a:t>
+            </a:r>
+            <a:r>
+              <a:rPr sz="1450" b="0" i="0">
+                <a:solidFill>
+                  <a:srgbClr val="3F3E3A"/>
+                </a:solidFill>
+                <a:latin typeface="Calibri"/>
+              </a:rPr>
+              <a:t>Der Tuner sucht Configs, nicht Kernel — A05-Pfad bleibt bitgleich.</a:t>
+            </a:r>
+          </a:p>
+        </p:txBody>
+      </p:sp>
+      <p:sp>
+        <p:nvSpPr>
+          <p:cNvPr id="9" name="Rectangle 8"/>
           <p:cNvSpPr/>
           <p:nvPr/>
         </p:nvSpPr>
         <p:spPr>
           <a:xfrm>
-            <a:off x="841248" y="4114800"/>
-            <a:ext cx="1828800" cy="64008"/>
+            <a:off x="658368" y="5870448"/>
+            <a:ext cx="82296" cy="402336"/>
           </a:xfrm>
           <a:prstGeom prst="rect">
             <a:avLst/>
@@ -5326,14 +5697,14 @@
       </p:sp>
       <p:sp>
         <p:nvSpPr>
-          <p:cNvPr id="6" name="TextBox 5"/>
+          <p:cNvPr id="10" name="TextBox 9"/>
           <p:cNvSpPr txBox="1"/>
           <p:nvPr/>
         </p:nvSpPr>
         <p:spPr>
           <a:xfrm>
-            <a:off x="822960" y="4343400"/>
-            <a:ext cx="10515600" cy="457200"/>
+            <a:off x="868680" y="5815584"/>
+            <a:ext cx="10607040" cy="502920"/>
           </a:xfrm>
           <a:prstGeom prst="rect">
             <a:avLst/>
@@ -5341,7 +5712,7 @@
           <a:noFill/>
         </p:spPr>
         <p:txBody>
-          <a:bodyPr wrap="square" anchor="t">
+          <a:bodyPr wrap="square" anchor="ctr">
             <a:spAutoFit/>
           </a:bodyPr>
           <a:lstStyle/>
@@ -5350,11 +5721,11 @@
             <a:r>
               <a:rPr sz="1500" b="0" i="0">
                 <a:solidFill>
-                  <a:srgbClr val="C3D4EA"/>
-                </a:solidFill>
-                <a:latin typeface="Calibri"/>
-              </a:rPr>
-              <a:t>Gegen Handkernel · gegen cuBLAS · über Shapes &amp; GPUs</a:t>
+                  <a:srgbClr val="3F3E3A"/>
+                </a:solidFill>
+                <a:latin typeface="Calibri"/>
+              </a:rPr>
+              <a:t>Wie cuBLAS/CUTLASS (Template-Menge) oder Triton (autotune pro @jit): neue Topologie = neues Template, Configs getunt.</a:t>
             </a:r>
           </a:p>
         </p:txBody>
@@ -5415,7 +5786,7 @@
                 </a:solidFill>
                 <a:latin typeface="Calibri"/>
               </a:rPr>
-              <a:t>EVALUATION</a:t>
+              <a:t>UMSETZUNG · CONFIG-AUFBAU</a:t>
             </a:r>
           </a:p>
         </p:txBody>
@@ -5450,7 +5821,7 @@
                 </a:solidFill>
                 <a:latin typeface="Calibri"/>
               </a:rPr>
-              <a:t>Benchmark-Setup &amp; Baselines</a:t>
+              <a:t>Wie wir die Reihenfolge der Dimensionen definiert haben</a:t>
             </a:r>
           </a:p>
         </p:txBody>
@@ -5564,312 +5935,38 @@
                 </a:solidFill>
                 <a:latin typeface="Calibri"/>
               </a:rPr>
-              <a:t>08</a:t>
-            </a:r>
-          </a:p>
-        </p:txBody>
-      </p:sp>
-      <p:sp>
-        <p:nvSpPr>
-          <p:cNvPr id="7" name="TextBox 6"/>
-          <p:cNvSpPr txBox="1"/>
-          <p:nvPr/>
-        </p:nvSpPr>
-        <p:spPr>
-          <a:xfrm>
-            <a:off x="658368" y="1783080"/>
-            <a:ext cx="6675120" cy="3566160"/>
-          </a:xfrm>
-          <a:prstGeom prst="rect">
-            <a:avLst/>
-          </a:prstGeom>
-          <a:noFill/>
-        </p:spPr>
-        <p:txBody>
-          <a:bodyPr wrap="square">
-            <a:spAutoFit/>
-          </a:bodyPr>
-          <a:lstStyle/>
-          <a:p>
-            <a:pPr>
-              <a:lnSpc>
-                <a:spcPct val="110000"/>
-              </a:lnSpc>
-              <a:spcAft>
-                <a:spcPts val="1000"/>
-              </a:spcAft>
-            </a:pPr>
-            <a:r>
-              <a:rPr sz="1650" b="1" i="0">
-                <a:solidFill>
-                  <a:srgbClr val="2A78D6"/>
-                </a:solidFill>
-                <a:latin typeface="Calibri"/>
-              </a:rPr>
-              <a:t>▸  </a:t>
-            </a:r>
-            <a:r>
-              <a:rPr sz="1650" b="0" i="0">
-                <a:solidFill>
-                  <a:srgbClr val="3F3E3A"/>
-                </a:solidFill>
-                <a:latin typeface="Calibri"/>
-              </a:rPr>
-              <a:t>Pro Shape: Tuner vs. Default (8×8) vs. torch.einsum (cuBLAS); A06 auch vs. Handkernel.</a:t>
-            </a:r>
-          </a:p>
-          <a:p>
-            <a:pPr>
-              <a:lnSpc>
-                <a:spcPct val="110000"/>
-              </a:lnSpc>
-              <a:spcAft>
-                <a:spcPts val="1000"/>
-              </a:spcAft>
-            </a:pPr>
-            <a:r>
-              <a:rPr sz="1650" b="1" i="0">
-                <a:solidFill>
-                  <a:srgbClr val="2A78D6"/>
-                </a:solidFill>
-                <a:latin typeface="Calibri"/>
-              </a:rPr>
-              <a:t>▸  </a:t>
-            </a:r>
-            <a:r>
-              <a:rPr sz="1650" b="0" i="0">
-                <a:solidFill>
-                  <a:srgbClr val="3F3E3A"/>
-                </a:solidFill>
-                <a:latin typeface="Calibri"/>
-              </a:rPr>
-              <a:t>fp16 rein, fp32 akkumuliert; Korrektheit via allclose gegen torch.einsum.</a:t>
-            </a:r>
-          </a:p>
-          <a:p>
-            <a:pPr>
-              <a:lnSpc>
-                <a:spcPct val="110000"/>
-              </a:lnSpc>
-              <a:spcAft>
-                <a:spcPts val="1000"/>
-              </a:spcAft>
-            </a:pPr>
-            <a:r>
-              <a:rPr sz="1650" b="1" i="0">
-                <a:solidFill>
-                  <a:srgbClr val="2A78D6"/>
-                </a:solidFill>
-                <a:latin typeface="Calibri"/>
-              </a:rPr>
-              <a:t>▸  </a:t>
-            </a:r>
-            <a:r>
-              <a:rPr sz="1650" b="0" i="0">
-                <a:solidFill>
-                  <a:srgbClr val="3F3E3A"/>
-                </a:solidFill>
-                <a:latin typeface="Calibri"/>
-              </a:rPr>
-              <a:t>8 Shape-Regime je Familie: square / tall / wide / small_k / large_k / krumm / batch.</a:t>
-            </a:r>
-          </a:p>
-          <a:p>
-            <a:pPr>
-              <a:lnSpc>
-                <a:spcPct val="110000"/>
-              </a:lnSpc>
-              <a:spcAft>
-                <a:spcPts val="1000"/>
-              </a:spcAft>
-            </a:pPr>
-            <a:r>
-              <a:rPr sz="1650" b="1" i="0">
-                <a:solidFill>
-                  <a:srgbClr val="2A78D6"/>
-                </a:solidFill>
-                <a:latin typeface="Calibri"/>
-              </a:rPr>
-              <a:t>▸  </a:t>
-            </a:r>
-            <a:r>
-              <a:rPr sz="1650" b="0" i="0">
-                <a:solidFill>
-                  <a:srgbClr val="3F3E3A"/>
-                </a:solidFill>
-                <a:latin typeface="Calibri"/>
-              </a:rPr>
-              <a:t>GPU: NVIDIA GB10 (DGX Spark) — 48 SMs, 25 MB L2, integrierter LPDDR.</a:t>
-            </a:r>
-          </a:p>
-        </p:txBody>
-      </p:sp>
-      <p:sp>
-        <p:nvSpPr>
-          <p:cNvPr id="8" name="TextBox 7"/>
-          <p:cNvSpPr txBox="1"/>
-          <p:nvPr/>
-        </p:nvSpPr>
-        <p:spPr>
-          <a:xfrm>
-            <a:off x="7772400" y="1965960"/>
-            <a:ext cx="3749039" cy="640080"/>
-          </a:xfrm>
-          <a:prstGeom prst="rect">
-            <a:avLst/>
-          </a:prstGeom>
-          <a:noFill/>
-        </p:spPr>
-        <p:txBody>
-          <a:bodyPr wrap="square" anchor="t">
-            <a:spAutoFit/>
-          </a:bodyPr>
-          <a:lstStyle/>
-          <a:p>
-            <a:pPr algn="ctr"/>
-            <a:r>
-              <a:rPr sz="3400" b="1" i="0">
-                <a:solidFill>
-                  <a:srgbClr val="0C830C"/>
-                </a:solidFill>
-                <a:latin typeface="Calibri"/>
-              </a:rPr>
-              <a:t>0</a:t>
-            </a:r>
-          </a:p>
-        </p:txBody>
-      </p:sp>
-      <p:sp>
-        <p:nvSpPr>
-          <p:cNvPr id="9" name="TextBox 8"/>
-          <p:cNvSpPr txBox="1"/>
-          <p:nvPr/>
-        </p:nvSpPr>
-        <p:spPr>
-          <a:xfrm>
-            <a:off x="7772400" y="2624328"/>
-            <a:ext cx="3749039" cy="457200"/>
-          </a:xfrm>
-          <a:prstGeom prst="rect">
-            <a:avLst/>
-          </a:prstGeom>
-          <a:noFill/>
-        </p:spPr>
-        <p:txBody>
-          <a:bodyPr wrap="square" anchor="t">
-            <a:spAutoFit/>
-          </a:bodyPr>
-          <a:lstStyle/>
-          <a:p>
-            <a:pPr algn="ctr"/>
-            <a:r>
-              <a:rPr sz="1250" b="0" i="0">
-                <a:solidFill>
-                  <a:srgbClr val="3F3E3A"/>
-                </a:solidFill>
-                <a:latin typeface="Calibri"/>
-              </a:rPr>
-              <a:t>Fehlschläge bei 8×342 (A05) + 8×171 (A06)</a:t>
-            </a:r>
-          </a:p>
-        </p:txBody>
-      </p:sp>
-      <p:sp>
-        <p:nvSpPr>
-          <p:cNvPr id="10" name="Rounded Rectangle 9"/>
-          <p:cNvSpPr/>
-          <p:nvPr/>
-        </p:nvSpPr>
-        <p:spPr>
-          <a:xfrm>
-            <a:off x="7772400" y="3611880"/>
-            <a:ext cx="3749039" cy="1554480"/>
-          </a:xfrm>
-          <a:prstGeom prst="roundRect">
-            <a:avLst/>
-          </a:prstGeom>
-          <a:solidFill>
-            <a:srgbClr val="F4F7FB"/>
-          </a:solidFill>
-          <a:ln w="12700">
-            <a:solidFill>
-              <a:srgbClr val="DDE4EC"/>
-            </a:solidFill>
-          </a:ln>
-          <a:effectLst/>
-        </p:spPr>
-        <p:style>
-          <a:lnRef idx="1">
-            <a:schemeClr val="accent1"/>
-          </a:lnRef>
-          <a:fillRef idx="3">
-            <a:schemeClr val="accent1"/>
-          </a:fillRef>
-          <a:effectRef idx="2">
-            <a:schemeClr val="accent1"/>
-          </a:effectRef>
-          <a:fontRef idx="minor">
-            <a:schemeClr val="lt1"/>
-          </a:fontRef>
-        </p:style>
-        <p:txBody>
-          <a:bodyPr rtlCol="0" anchor="ctr"/>
-          <a:lstStyle/>
-          <a:p>
-            <a:pPr algn="ctr"/>
-          </a:p>
-        </p:txBody>
-      </p:sp>
-      <p:sp>
-        <p:nvSpPr>
-          <p:cNvPr id="11" name="TextBox 10"/>
-          <p:cNvSpPr txBox="1"/>
-          <p:nvPr/>
-        </p:nvSpPr>
-        <p:spPr>
-          <a:xfrm>
-            <a:off x="7973568" y="3767328"/>
-            <a:ext cx="3383280" cy="1280160"/>
-          </a:xfrm>
-          <a:prstGeom prst="rect">
-            <a:avLst/>
-          </a:prstGeom>
-          <a:noFill/>
-        </p:spPr>
-        <p:txBody>
-          <a:bodyPr wrap="square" anchor="ctr">
-            <a:spAutoFit/>
-          </a:bodyPr>
-          <a:lstStyle/>
-          <a:p>
-            <a:pPr algn="l"/>
-            <a:r>
-              <a:rPr sz="1350" b="1" i="0">
-                <a:solidFill>
-                  <a:srgbClr val="0B0B0B"/>
-                </a:solidFill>
-                <a:latin typeface="Calibri"/>
-              </a:rPr>
-              <a:t>Padding-Pfad bestätigt</a:t>
-            </a:r>
-          </a:p>
-          <a:p>
-            <a:pPr algn="l"/>
-            <a:r>
-              <a:rPr sz="1250" b="0" i="0">
-                <a:solidFill>
-                  <a:srgbClr val="3F3E3A"/>
-                </a:solidFill>
-                <a:latin typeface="Calibri"/>
-              </a:rPr>
-              <a:t>auch die unteilbaren krumm-Shapes rechnen korrekt auf echter Hardware.</a:t>
-            </a:r>
-          </a:p>
-        </p:txBody>
-      </p:sp>
-      <p:sp>
-        <p:nvSpPr>
-          <p:cNvPr id="12" name="Rectangle 11"/>
+              <a:t>09</a:t>
+            </a:r>
+          </a:p>
+        </p:txBody>
+      </p:sp>
+      <p:pic>
+        <p:nvPicPr>
+          <p:cNvPr id="7" name="Picture 6" descr="fig_exec_order.png"/>
+          <p:cNvPicPr>
+            <a:picLocks noChangeAspect="1"/>
+          </p:cNvPicPr>
+          <p:nvPr/>
+        </p:nvPicPr>
+        <p:blipFill>
+          <a:blip r:embed="rId2"/>
+          <a:stretch>
+            <a:fillRect/>
+          </a:stretch>
+        </p:blipFill>
+        <p:spPr>
+          <a:xfrm>
+            <a:off x="1603070" y="1517904"/>
+            <a:ext cx="8955379" cy="4160520"/>
+          </a:xfrm>
+          <a:prstGeom prst="rect">
+            <a:avLst/>
+          </a:prstGeom>
+        </p:spPr>
+      </p:pic>
+      <p:sp>
+        <p:nvSpPr>
+          <p:cNvPr id="8" name="Rectangle 7"/>
           <p:cNvSpPr/>
           <p:nvPr/>
         </p:nvSpPr>
@@ -5913,7 +6010,7 @@
       </p:sp>
       <p:sp>
         <p:nvSpPr>
-          <p:cNvPr id="13" name="TextBox 12"/>
+          <p:cNvPr id="9" name="TextBox 8"/>
           <p:cNvSpPr txBox="1"/>
           <p:nvPr/>
         </p:nvSpPr>
@@ -5941,7 +6038,7 @@
                 </a:solidFill>
                 <a:latin typeface="Calibri"/>
               </a:rPr>
-              <a:t>Fair gegen drei Referenzen, jede Config auf Korrektheit geprüft — alles rechnet, inklusive Padding.</a:t>
+              <a:t>Jede Config ist by construction gültig: die Reihenfolge PAR │ SEQ │ PRIM steht fest (verify), der Tuner variiert nur die Split-Größen und A/B.</a:t>
             </a:r>
           </a:p>
         </p:txBody>
@@ -5960,7 +6057,7 @@
     <p:bg>
       <p:bgPr>
         <a:solidFill>
-          <a:srgbClr val="FFFFFF"/>
+          <a:srgbClr val="0E1B2E"/>
         </a:solidFill>
         <a:effectLst/>
       </p:bgPr>
@@ -5974,84 +6071,14 @@
       <p:grpSpPr/>
       <p:sp>
         <p:nvSpPr>
-          <p:cNvPr id="2" name="TextBox 1"/>
-          <p:cNvSpPr txBox="1"/>
-          <p:nvPr/>
-        </p:nvSpPr>
-        <p:spPr>
-          <a:xfrm>
-            <a:off x="640080" y="384048"/>
-            <a:ext cx="10972800" cy="256032"/>
-          </a:xfrm>
-          <a:prstGeom prst="rect">
-            <a:avLst/>
-          </a:prstGeom>
-          <a:noFill/>
-        </p:spPr>
-        <p:txBody>
-          <a:bodyPr wrap="square" anchor="t">
-            <a:spAutoFit/>
-          </a:bodyPr>
-          <a:lstStyle/>
-          <a:p>
-            <a:pPr algn="l"/>
-            <a:r>
-              <a:rPr sz="1250" b="1" i="0">
-                <a:solidFill>
-                  <a:srgbClr val="2A78D6"/>
-                </a:solidFill>
-                <a:latin typeface="Calibri"/>
-              </a:rPr>
-              <a:t>ERGEBNISSE · A05</a:t>
-            </a:r>
-          </a:p>
-        </p:txBody>
-      </p:sp>
-      <p:sp>
-        <p:nvSpPr>
-          <p:cNvPr id="3" name="TextBox 2"/>
-          <p:cNvSpPr txBox="1"/>
-          <p:nvPr/>
-        </p:nvSpPr>
-        <p:spPr>
-          <a:xfrm>
-            <a:off x="621792" y="676656"/>
-            <a:ext cx="10972800" cy="822960"/>
-          </a:xfrm>
-          <a:prstGeom prst="rect">
-            <a:avLst/>
-          </a:prstGeom>
-          <a:noFill/>
-        </p:spPr>
-        <p:txBody>
-          <a:bodyPr wrap="square" anchor="t">
-            <a:spAutoFit/>
-          </a:bodyPr>
-          <a:lstStyle/>
-          <a:p>
-            <a:pPr algn="l"/>
-            <a:r>
-              <a:rPr sz="2700" b="1" i="0">
-                <a:solidFill>
-                  <a:srgbClr val="0B0B0B"/>
-                </a:solidFill>
-                <a:latin typeface="Calibri"/>
-              </a:rPr>
-              <a:t>Der Tuner bestätigt die Handarbeit</a:t>
-            </a:r>
-          </a:p>
-        </p:txBody>
-      </p:sp>
-      <p:sp>
-        <p:nvSpPr>
-          <p:cNvPr id="4" name="Rectangle 3"/>
+          <p:cNvPr id="2" name="Rectangle 1"/>
           <p:cNvSpPr/>
           <p:nvPr/>
         </p:nvSpPr>
         <p:spPr>
           <a:xfrm>
-            <a:off x="658368" y="1389888"/>
-            <a:ext cx="1920240" cy="50292"/>
+            <a:off x="0" y="0"/>
+            <a:ext cx="320040" cy="6858000"/>
           </a:xfrm>
           <a:prstGeom prst="rect">
             <a:avLst/>
@@ -6088,14 +6115,14 @@
       </p:sp>
       <p:sp>
         <p:nvSpPr>
-          <p:cNvPr id="5" name="TextBox 4"/>
+          <p:cNvPr id="3" name="TextBox 2"/>
           <p:cNvSpPr txBox="1"/>
           <p:nvPr/>
         </p:nvSpPr>
         <p:spPr>
           <a:xfrm>
-            <a:off x="640080" y="6455664"/>
-            <a:ext cx="6400800" cy="274320"/>
+            <a:off x="822960" y="2487168"/>
+            <a:ext cx="10515600" cy="365760"/>
           </a:xfrm>
           <a:prstGeom prst="rect">
             <a:avLst/>
@@ -6110,27 +6137,27 @@
           <a:p>
             <a:pPr algn="l"/>
             <a:r>
-              <a:rPr sz="1000" b="0" i="0">
-                <a:solidFill>
-                  <a:srgbClr val="898781"/>
-                </a:solidFill>
-                <a:latin typeface="Calibri"/>
-              </a:rPr>
-              <a:t>cuTile Auto-Tuner · Becker-Klöser · Elagina</a:t>
-            </a:r>
-          </a:p>
-        </p:txBody>
-      </p:sp>
-      <p:sp>
-        <p:nvSpPr>
-          <p:cNvPr id="6" name="TextBox 5"/>
+              <a:rPr sz="1800" b="1" i="0">
+                <a:solidFill>
+                  <a:srgbClr val="2A78D6"/>
+                </a:solidFill>
+                <a:latin typeface="Calibri"/>
+              </a:rPr>
+              <a:t>TEIL 2</a:t>
+            </a:r>
+          </a:p>
+        </p:txBody>
+      </p:sp>
+      <p:sp>
+        <p:nvSpPr>
+          <p:cNvPr id="4" name="TextBox 3"/>
           <p:cNvSpPr txBox="1"/>
           <p:nvPr/>
         </p:nvSpPr>
         <p:spPr>
           <a:xfrm>
-            <a:off x="10607040" y="6455664"/>
-            <a:ext cx="1005840" cy="274320"/>
+            <a:off x="786384" y="2926080"/>
+            <a:ext cx="10607040" cy="1280160"/>
           </a:xfrm>
           <a:prstGeom prst="rect">
             <a:avLst/>
@@ -6143,160 +6170,29 @@
           </a:bodyPr>
           <a:lstStyle/>
           <a:p>
-            <a:pPr algn="r"/>
-            <a:r>
-              <a:rPr sz="1000" b="0" i="0">
-                <a:solidFill>
-                  <a:srgbClr val="898781"/>
-                </a:solidFill>
-                <a:latin typeface="Calibri"/>
-              </a:rPr>
-              <a:t>09</a:t>
-            </a:r>
-          </a:p>
-        </p:txBody>
-      </p:sp>
-      <p:pic>
-        <p:nvPicPr>
-          <p:cNvPr id="7" name="Picture 6" descr="fig_a05_bars.png"/>
-          <p:cNvPicPr>
-            <a:picLocks noChangeAspect="1"/>
-          </p:cNvPicPr>
-          <p:nvPr/>
-        </p:nvPicPr>
-        <p:blipFill>
-          <a:blip r:embed="rId2"/>
-          <a:stretch>
-            <a:fillRect/>
-          </a:stretch>
-        </p:blipFill>
-        <p:spPr>
-          <a:xfrm>
-            <a:off x="1446441" y="1554480"/>
-            <a:ext cx="6342557" cy="4114800"/>
-          </a:xfrm>
-          <a:prstGeom prst="rect">
-            <a:avLst/>
-          </a:prstGeom>
-        </p:spPr>
-      </p:pic>
-      <p:sp>
-        <p:nvSpPr>
-          <p:cNvPr id="8" name="TextBox 7"/>
-          <p:cNvSpPr txBox="1"/>
-          <p:nvPr/>
-        </p:nvSpPr>
-        <p:spPr>
-          <a:xfrm>
-            <a:off x="8869680" y="1874519"/>
-            <a:ext cx="2788920" cy="3840480"/>
-          </a:xfrm>
-          <a:prstGeom prst="rect">
-            <a:avLst/>
-          </a:prstGeom>
-          <a:noFill/>
-        </p:spPr>
-        <p:txBody>
-          <a:bodyPr wrap="square">
-            <a:spAutoFit/>
-          </a:bodyPr>
-          <a:lstStyle/>
-          <a:p>
-            <a:pPr>
-              <a:lnSpc>
-                <a:spcPct val="110000"/>
-              </a:lnSpc>
-              <a:spcAft>
-                <a:spcPts val="1000"/>
-              </a:spcAft>
-            </a:pPr>
-            <a:r>
-              <a:rPr sz="1450" b="1" i="0">
-                <a:solidFill>
-                  <a:srgbClr val="2A78D6"/>
-                </a:solidFill>
-                <a:latin typeface="Calibri"/>
-              </a:rPr>
-              <a:t>▸  </a:t>
-            </a:r>
-            <a:r>
-              <a:rPr sz="1450" b="0" i="0">
-                <a:solidFill>
-                  <a:srgbClr val="3F3E3A"/>
-                </a:solidFill>
-                <a:latin typeface="Calibri"/>
-              </a:rPr>
-              <a:t>Regulär: 1.00–1.02× — bestätigt Hand.</a:t>
-            </a:r>
-          </a:p>
-          <a:p>
-            <a:pPr>
-              <a:lnSpc>
-                <a:spcPct val="110000"/>
-              </a:lnSpc>
-              <a:spcAft>
-                <a:spcPts val="1000"/>
-              </a:spcAft>
-            </a:pPr>
-            <a:r>
-              <a:rPr sz="1450" b="1" i="0">
-                <a:solidFill>
-                  <a:srgbClr val="2A78D6"/>
-                </a:solidFill>
-                <a:latin typeface="Calibri"/>
-              </a:rPr>
-              <a:t>▸  </a:t>
-            </a:r>
-            <a:r>
-              <a:rPr sz="1450" b="0" i="0">
-                <a:solidFill>
-                  <a:srgbClr val="3F3E3A"/>
-                </a:solidFill>
-                <a:latin typeface="Calibri"/>
-              </a:rPr>
-              <a:t>large_k +7 %, krumm +58 %.</a:t>
-            </a:r>
-          </a:p>
-          <a:p>
-            <a:pPr>
-              <a:lnSpc>
-                <a:spcPct val="110000"/>
-              </a:lnSpc>
-              <a:spcAft>
-                <a:spcPts val="1000"/>
-              </a:spcAft>
-            </a:pPr>
-            <a:r>
-              <a:rPr sz="1450" b="1" i="0">
-                <a:solidFill>
-                  <a:srgbClr val="2A78D6"/>
-                </a:solidFill>
-                <a:latin typeface="Calibri"/>
-              </a:rPr>
-              <a:t>▸  </a:t>
-            </a:r>
-            <a:r>
-              <a:rPr sz="1450" b="0" i="0">
-                <a:solidFill>
-                  <a:srgbClr val="3F3E3A"/>
-                </a:solidFill>
-                <a:latin typeface="Calibri"/>
-              </a:rPr>
-              <a:t>Ø 1.03×, nie schlechter, 97.6 % des Optimums.</a:t>
-            </a:r>
-          </a:p>
-        </p:txBody>
-      </p:sp>
-      <p:sp>
-        <p:nvSpPr>
-          <p:cNvPr id="9" name="Rectangle 8"/>
+            <a:pPr algn="l"/>
+            <a:r>
+              <a:rPr sz="4000" b="1" i="0">
+                <a:solidFill>
+                  <a:srgbClr val="FFFFFF"/>
+                </a:solidFill>
+                <a:latin typeface="Calibri"/>
+              </a:rPr>
+              <a:t>Evaluation &amp; Ergebnisse</a:t>
+            </a:r>
+          </a:p>
+        </p:txBody>
+      </p:sp>
+      <p:sp>
+        <p:nvSpPr>
+          <p:cNvPr id="5" name="Rectangle 4"/>
           <p:cNvSpPr/>
           <p:nvPr/>
         </p:nvSpPr>
         <p:spPr>
           <a:xfrm>
-            <a:off x="658368" y="5870448"/>
-            <a:ext cx="82296" cy="402336"/>
+            <a:off x="841248" y="4114800"/>
+            <a:ext cx="1828800" cy="64008"/>
           </a:xfrm>
           <a:prstGeom prst="rect">
             <a:avLst/>
@@ -6333,14 +6229,14 @@
       </p:sp>
       <p:sp>
         <p:nvSpPr>
-          <p:cNvPr id="10" name="TextBox 9"/>
+          <p:cNvPr id="6" name="TextBox 5"/>
           <p:cNvSpPr txBox="1"/>
           <p:nvPr/>
         </p:nvSpPr>
         <p:spPr>
           <a:xfrm>
-            <a:off x="868680" y="5815584"/>
-            <a:ext cx="10607040" cy="502920"/>
+            <a:off x="822960" y="4343400"/>
+            <a:ext cx="10515600" cy="457200"/>
           </a:xfrm>
           <a:prstGeom prst="rect">
             <a:avLst/>
@@ -6348,7 +6244,7 @@
           <a:noFill/>
         </p:spPr>
         <p:txBody>
-          <a:bodyPr wrap="square" anchor="ctr">
+          <a:bodyPr wrap="square" anchor="t">
             <a:spAutoFit/>
           </a:bodyPr>
           <a:lstStyle/>
@@ -6357,11 +6253,11 @@
             <a:r>
               <a:rPr sz="1500" b="0" i="0">
                 <a:solidFill>
-                  <a:srgbClr val="3F3E3A"/>
-                </a:solidFill>
-                <a:latin typeface="Calibri"/>
-              </a:rPr>
-              <a:t>Auf regulären GEMMs holt er nichts heraus — er gewinnt genau dort, wo die feste 8×8-Gruppe schlecht passt.</a:t>
+                  <a:srgbClr val="C3D4EA"/>
+                </a:solidFill>
+                <a:latin typeface="Calibri"/>
+              </a:rPr>
+              <a:t>Gegen Handkernel · gegen cuBLAS · über Shapes &amp; GPUs</a:t>
             </a:r>
           </a:p>
         </p:txBody>
@@ -6422,7 +6318,7 @@
                 </a:solidFill>
                 <a:latin typeface="Calibri"/>
               </a:rPr>
-              <a:t>ERGEBNISSE · EHRLICHE BASELINE</a:t>
+              <a:t>EVALUATION</a:t>
             </a:r>
           </a:p>
         </p:txBody>
@@ -6457,7 +6353,7 @@
                 </a:solidFill>
                 <a:latin typeface="Calibri"/>
               </a:rPr>
-              <a:t>Tuner vs. cuBLAS / torch.einsum</a:t>
+              <a:t>Benchmark-Setup: acht Shape-Regime je Familie</a:t>
             </a:r>
           </a:p>
         </p:txBody>
@@ -6578,7 +6474,7 @@
       </p:sp>
       <p:pic>
         <p:nvPicPr>
-          <p:cNvPr id="7" name="Picture 6" descr="fig_tuner_vs_torch.png"/>
+          <p:cNvPr id="7" name="Picture 6" descr="fig_regimes.png"/>
           <p:cNvPicPr>
             <a:picLocks noChangeAspect="1"/>
           </p:cNvPicPr>
@@ -6592,8 +6488,8 @@
         </p:blipFill>
         <p:spPr>
           <a:xfrm>
-            <a:off x="1634370" y="1536192"/>
-            <a:ext cx="4595098" cy="4206240"/>
+            <a:off x="457200" y="1775154"/>
+            <a:ext cx="7223760" cy="3636875"/>
           </a:xfrm>
           <a:prstGeom prst="rect">
             <a:avLst/>
@@ -6608,8 +6504,8 @@
         </p:nvSpPr>
         <p:spPr>
           <a:xfrm>
-            <a:off x="7498079" y="1874519"/>
-            <a:ext cx="4160520" cy="3931920"/>
+            <a:off x="7818120" y="1874519"/>
+            <a:ext cx="3840480" cy="3657600"/>
           </a:xfrm>
           <a:prstGeom prst="rect">
             <a:avLst/>
@@ -6646,7 +6542,7 @@
                 </a:solidFill>
                 <a:latin typeface="Calibri"/>
               </a:rPr>
-              <a:t>GEMM (A05): cuBLAS gewinnt (Tuner ~77 % von torch) — erwartbar.</a:t>
+              <a:t>Pro Shape: Tuner vs. Default (8×8) vs. torch.einsum; A06 auch vs. Handkernel.</a:t>
             </a:r>
           </a:p>
           <a:p>
@@ -6674,7 +6570,7 @@
                 </a:solidFill>
                 <a:latin typeface="Calibri"/>
               </a:rPr>
-              <a:t>Ring (A06): im Mittel ~1.17× vorn, sehr shape-abhängig.</a:t>
+              <a:t>fp16 rein, fp32 Akku; jede Config gegen torch.einsum geprüft (allclose).</a:t>
             </a:r>
           </a:p>
           <a:p>
@@ -6702,7 +6598,7 @@
                 </a:solidFill>
                 <a:latin typeface="Calibri"/>
               </a:rPr>
-              <a:t>Großer Gewinn, wo torchs Pfad schlecht ist (tall 3.95×, large_k 2.65×).</a:t>
+              <a:t>8×342 (A05) + 8×171 (A06): 0 Fehlschläge, inkl. Padding-Pfad (krumm).</a:t>
             </a:r>
           </a:p>
           <a:p>
@@ -6730,7 +6626,7 @@
                 </a:solidFill>
                 <a:latin typeface="Calibri"/>
               </a:rPr>
-              <a:t>A06_TORCH=16.18 aus dem Assignment ist veraltet → frisch 60.2.</a:t>
+              <a:t>GPU: NVIDIA GB10 — 48 SMs, 25 MB L2, integrierter LPDDR.</a:t>
             </a:r>
           </a:p>
         </p:txBody>
@@ -6809,7 +6705,7 @@
                 </a:solidFill>
                 <a:latin typeface="Calibri"/>
               </a:rPr>
-              <a:t>Der Wert ist nicht „schneller als alles", sondern: ohne Handarbeit über beliebige Kontraktionen brauchbar — und stark, wo die Library keinen guten Pfad hat.</a:t>
+              <a:t>Acht Regime decken square / rechteckig / K-Extreme / unteilbar / Batch ab — fair gegen drei Referenzen, alles korrekt.</a:t>
             </a:r>
           </a:p>
         </p:txBody>
@@ -6870,7 +6766,7 @@
                 </a:solidFill>
                 <a:latin typeface="Calibri"/>
               </a:rPr>
-              <a:t>ERGEBNISSE · A06</a:t>
+              <a:t>ERGEBNISSE · A05</a:t>
             </a:r>
           </a:p>
         </p:txBody>
@@ -6905,7 +6801,7 @@
                 </a:solidFill>
                 <a:latin typeface="Calibri"/>
               </a:rPr>
-              <a:t>Transfer gelingt — Tuner schlägt den Handkernel</a:t>
+              <a:t>Der Tuner bestätigt die Handarbeit</a:t>
             </a:r>
           </a:p>
         </p:txBody>
@@ -7026,7 +6922,7 @@
       </p:sp>
       <p:pic>
         <p:nvPicPr>
-          <p:cNvPr id="7" name="Picture 6" descr="fig_a06_bars.png"/>
+          <p:cNvPr id="7" name="Picture 6" descr="fig_a05_bars.png"/>
           <p:cNvPicPr>
             <a:picLocks noChangeAspect="1"/>
           </p:cNvPicPr>
@@ -7040,38 +6936,121 @@
         </p:blipFill>
         <p:spPr>
           <a:xfrm>
-            <a:off x="669201" y="1572768"/>
-            <a:ext cx="6342557" cy="4114800"/>
+            <a:off x="1273568" y="1554480"/>
+            <a:ext cx="6779743" cy="4114800"/>
           </a:xfrm>
           <a:prstGeom prst="rect">
             <a:avLst/>
           </a:prstGeom>
         </p:spPr>
       </p:pic>
-      <p:pic>
-        <p:nvPicPr>
-          <p:cNvPr id="8" name="Picture 7" descr="fig_a06_ladder.png"/>
-          <p:cNvPicPr>
-            <a:picLocks noChangeAspect="1"/>
-          </p:cNvPicPr>
-          <p:nvPr/>
-        </p:nvPicPr>
-        <p:blipFill>
-          <a:blip r:embed="rId3"/>
-          <a:stretch>
-            <a:fillRect/>
-          </a:stretch>
-        </p:blipFill>
-        <p:spPr>
-          <a:xfrm>
-            <a:off x="7315200" y="1755154"/>
-            <a:ext cx="4389120" cy="3750026"/>
-          </a:xfrm>
-          <a:prstGeom prst="rect">
-            <a:avLst/>
-          </a:prstGeom>
-        </p:spPr>
-      </p:pic>
+      <p:sp>
+        <p:nvSpPr>
+          <p:cNvPr id="8" name="TextBox 7"/>
+          <p:cNvSpPr txBox="1"/>
+          <p:nvPr/>
+        </p:nvSpPr>
+        <p:spPr>
+          <a:xfrm>
+            <a:off x="9006840" y="1920240"/>
+            <a:ext cx="2651760" cy="3794760"/>
+          </a:xfrm>
+          <a:prstGeom prst="rect">
+            <a:avLst/>
+          </a:prstGeom>
+          <a:noFill/>
+        </p:spPr>
+        <p:txBody>
+          <a:bodyPr wrap="square">
+            <a:spAutoFit/>
+          </a:bodyPr>
+          <a:lstStyle/>
+          <a:p>
+            <a:pPr>
+              <a:lnSpc>
+                <a:spcPct val="110000"/>
+              </a:lnSpc>
+              <a:spcAft>
+                <a:spcPts val="1000"/>
+              </a:spcAft>
+            </a:pPr>
+            <a:r>
+              <a:rPr sz="1350" b="1" i="0">
+                <a:solidFill>
+                  <a:srgbClr val="2A78D6"/>
+                </a:solidFill>
+                <a:latin typeface="Calibri"/>
+              </a:rPr>
+              <a:t>▸  </a:t>
+            </a:r>
+            <a:r>
+              <a:rPr sz="1350" b="0" i="0">
+                <a:solidFill>
+                  <a:srgbClr val="3F3E3A"/>
+                </a:solidFill>
+                <a:latin typeface="Calibri"/>
+              </a:rPr>
+              <a:t>Tuner-Pick (top-7) ≈ Default → bestätigt die Hand.</a:t>
+            </a:r>
+          </a:p>
+          <a:p>
+            <a:pPr>
+              <a:lnSpc>
+                <a:spcPct val="110000"/>
+              </a:lnSpc>
+              <a:spcAft>
+                <a:spcPts val="1000"/>
+              </a:spcAft>
+            </a:pPr>
+            <a:r>
+              <a:rPr sz="1350" b="1" i="0">
+                <a:solidFill>
+                  <a:srgbClr val="2A78D6"/>
+                </a:solidFill>
+                <a:latin typeface="Calibri"/>
+              </a:rPr>
+              <a:t>▸  </a:t>
+            </a:r>
+            <a:r>
+              <a:rPr sz="1350" b="0" i="0">
+                <a:solidFill>
+                  <a:srgbClr val="3F3E3A"/>
+                </a:solidFill>
+                <a:latin typeface="Calibri"/>
+              </a:rPr>
+              <a:t>Bench-Best (von 342) nur knapp drüber; krumm +58 %.</a:t>
+            </a:r>
+          </a:p>
+          <a:p>
+            <a:pPr>
+              <a:lnSpc>
+                <a:spcPct val="110000"/>
+              </a:lnSpc>
+              <a:spcAft>
+                <a:spcPts val="1000"/>
+              </a:spcAft>
+            </a:pPr>
+            <a:r>
+              <a:rPr sz="1350" b="1" i="0">
+                <a:solidFill>
+                  <a:srgbClr val="2A78D6"/>
+                </a:solidFill>
+                <a:latin typeface="Calibri"/>
+              </a:rPr>
+              <a:t>▸  </a:t>
+            </a:r>
+            <a:r>
+              <a:rPr sz="1350" b="0" i="0">
+                <a:solidFill>
+                  <a:srgbClr val="3F3E3A"/>
+                </a:solidFill>
+                <a:latin typeface="Calibri"/>
+              </a:rPr>
+              <a:t>Aber: selbst die Bench-Best bleibt auf GEMM unter cuBLAS.</a:t>
+            </a:r>
+          </a:p>
+        </p:txBody>
+      </p:sp>
       <p:sp>
         <p:nvSpPr>
           <p:cNvPr id="9" name="Rectangle 8"/>
@@ -7146,7 +7125,7 @@
                 </a:solidFill>
                 <a:latin typeface="Calibri"/>
               </a:rPr>
-              <a:t>Der Gewinn kommt aus k_prim=32 (Hand nahm p=64 als einen mma-Tile) — Default 26 → Hand 50 → Tuner 60 ≈ torch 60.</a:t>
+              <a:t>Warum verliert selbst unsere Bench-Best gegen torch? cuBLAS ist eine gereifte GEMM-Library (hand-optimiertes SASS, Split-K, Pipelining) — das schlägt ein einfaches Template.</a:t>
             </a:r>
           </a:p>
         </p:txBody>
@@ -7207,7 +7186,7 @@
                 </a:solidFill>
                 <a:latin typeface="Calibri"/>
               </a:rPr>
-              <a:t>MODELL · PRAXIS</a:t>
+              <a:t>ERGEBNISSE · EHRLICHE BASELINE</a:t>
             </a:r>
           </a:p>
         </p:txBody>
@@ -7242,7 +7221,7 @@
                 </a:solidFill>
                 <a:latin typeface="Calibri"/>
               </a:rPr>
-              <a:t>Wie oft ist das Optimum in den Top-k?</a:t>
+              <a:t>Tuner vs. cuBLAS / torch.einsum</a:t>
             </a:r>
           </a:p>
         </p:txBody>
@@ -7363,7 +7342,7 @@
       </p:sp>
       <p:pic>
         <p:nvPicPr>
-          <p:cNvPr id="7" name="Picture 6" descr="fig_topk_curve.png"/>
+          <p:cNvPr id="7" name="Picture 6" descr="fig_tuner_vs_torch.png"/>
           <p:cNvPicPr>
             <a:picLocks noChangeAspect="1"/>
           </p:cNvPicPr>
@@ -7377,8 +7356,8 @@
         </p:blipFill>
         <p:spPr>
           <a:xfrm>
-            <a:off x="1225870" y="1554480"/>
-            <a:ext cx="6509379" cy="4160520"/>
+            <a:off x="1634370" y="1536192"/>
+            <a:ext cx="4595098" cy="4206240"/>
           </a:xfrm>
           <a:prstGeom prst="rect">
             <a:avLst/>
@@ -7393,8 +7372,8 @@
         </p:nvSpPr>
         <p:spPr>
           <a:xfrm>
-            <a:off x="8595360" y="1965960"/>
-            <a:ext cx="3063240" cy="3657600"/>
+            <a:off x="7498079" y="1874519"/>
+            <a:ext cx="4160520" cy="3931920"/>
           </a:xfrm>
           <a:prstGeom prst="rect">
             <a:avLst/>
@@ -7416,7 +7395,7 @@
               </a:spcAft>
             </a:pPr>
             <a:r>
-              <a:rPr sz="1500" b="1" i="0">
+              <a:rPr sz="1450" b="1" i="0">
                 <a:solidFill>
                   <a:srgbClr val="2A78D6"/>
                 </a:solidFill>
@@ -7425,13 +7404,13 @@
               <a:t>▸  </a:t>
             </a:r>
             <a:r>
-              <a:rPr sz="1500" b="1" i="0">
-                <a:solidFill>
-                  <a:srgbClr val="0B0B0B"/>
-                </a:solidFill>
-                <a:latin typeface="Calibri"/>
-              </a:rPr>
-              <a:t>top-7 · ~3 s · ≥ 95 %</a:t>
+              <a:rPr sz="1450" b="0" i="0">
+                <a:solidFill>
+                  <a:srgbClr val="3F3E3A"/>
+                </a:solidFill>
+                <a:latin typeface="Calibri"/>
+              </a:rPr>
+              <a:t>GEMM (A05): cuBLAS gewinnt (Tuner ~77 % von torch) — erwartbar.</a:t>
             </a:r>
           </a:p>
           <a:p>
@@ -7444,7 +7423,7 @@
               </a:spcAft>
             </a:pPr>
             <a:r>
-              <a:rPr sz="1500" b="1" i="0">
+              <a:rPr sz="1450" b="1" i="0">
                 <a:solidFill>
                   <a:srgbClr val="2A78D6"/>
                 </a:solidFill>
@@ -7453,13 +7432,13 @@
               <a:t>▸  </a:t>
             </a:r>
             <a:r>
-              <a:rPr sz="1500" b="1" i="0">
-                <a:solidFill>
-                  <a:srgbClr val="0B0B0B"/>
-                </a:solidFill>
-                <a:latin typeface="Calibri"/>
-              </a:rPr>
-              <a:t>top-45 · ~18 s · ≥ 99 %</a:t>
+              <a:rPr sz="1450" b="0" i="0">
+                <a:solidFill>
+                  <a:srgbClr val="3F3E3A"/>
+                </a:solidFill>
+                <a:latin typeface="Calibri"/>
+              </a:rPr>
+              <a:t>Ring (A06): im Mittel ~1.17× vorn, sehr shape-abhängig.</a:t>
             </a:r>
           </a:p>
           <a:p>
@@ -7472,7 +7451,7 @@
               </a:spcAft>
             </a:pPr>
             <a:r>
-              <a:rPr sz="1500" b="1" i="0">
+              <a:rPr sz="1450" b="1" i="0">
                 <a:solidFill>
                   <a:srgbClr val="2A78D6"/>
                 </a:solidFill>
@@ -7481,13 +7460,13 @@
               <a:t>▸  </a:t>
             </a:r>
             <a:r>
-              <a:rPr sz="1500" b="1" i="0">
-                <a:solidFill>
-                  <a:srgbClr val="0B0B0B"/>
-                </a:solidFill>
-                <a:latin typeface="Calibri"/>
-              </a:rPr>
-              <a:t>Voll-Sweep · ~3 min · 100 %</a:t>
+              <a:rPr sz="1450" b="0" i="0">
+                <a:solidFill>
+                  <a:srgbClr val="3F3E3A"/>
+                </a:solidFill>
+                <a:latin typeface="Calibri"/>
+              </a:rPr>
+              <a:t>Großer Gewinn, wo torchs Pfad schlecht ist (tall 3.95×, large_k 2.65×).</a:t>
             </a:r>
           </a:p>
           <a:p>
@@ -7500,7 +7479,7 @@
               </a:spcAft>
             </a:pPr>
             <a:r>
-              <a:rPr sz="1500" b="1" i="0">
+              <a:rPr sz="1450" b="1" i="0">
                 <a:solidFill>
                   <a:srgbClr val="2A78D6"/>
                 </a:solidFill>
@@ -7509,13 +7488,13 @@
               <a:t>▸  </a:t>
             </a:r>
             <a:r>
-              <a:rPr sz="1500" b="0" i="0">
+              <a:rPr sz="1450" b="0" i="0">
                 <a:solidFill>
                   <a:srgbClr val="3F3E3A"/>
                 </a:solidFill>
                 <a:latin typeface="Calibri"/>
               </a:rPr>
-              <a:t>Exakt-Beste sitzt tief — Spitzenfeld liegt im Messrauschen.</a:t>
+              <a:t>A06_TORCH=16.18 aus dem Assignment ist veraltet → frisch 60.2.</a:t>
             </a:r>
           </a:p>
         </p:txBody>
@@ -7594,7 +7573,7 @@
                 </a:solidFill>
                 <a:latin typeface="Calibri"/>
               </a:rPr>
-              <a:t>Als Vorauswahl reicht das Modell fast immer; als exakter Treffer selten — top-7 ist der Sweet Spot.</a:t>
+              <a:t>Der Wert ist nicht „schneller als alles", sondern: ohne Handarbeit über beliebige Kontraktionen brauchbar — und stark, wo die Library keinen guten Pfad hat.</a:t>
             </a:r>
           </a:p>
         </p:txBody>
@@ -7655,7 +7634,7 @@
                 </a:solidFill>
                 <a:latin typeface="Calibri"/>
               </a:rPr>
-              <a:t>MODELL</a:t>
+              <a:t>ERGEBNISSE · A06</a:t>
             </a:r>
           </a:p>
         </p:txBody>
@@ -7690,7 +7669,7 @@
                 </a:solidFill>
                 <a:latin typeface="Calibri"/>
               </a:rPr>
-              <a:t>Besserer Ranker ≠ besserer Vorfilter</a:t>
+              <a:t>Transfer gelingt — Tuner schlägt den Handkernel</a:t>
             </a:r>
           </a:p>
         </p:txBody>
@@ -7811,7 +7790,7 @@
       </p:sp>
       <p:pic>
         <p:nvPicPr>
-          <p:cNvPr id="7" name="Picture 6" descr="fig_ranking_models.png"/>
+          <p:cNvPr id="7" name="Picture 6" descr="fig_a06_bars.png"/>
           <p:cNvPicPr>
             <a:picLocks noChangeAspect="1"/>
           </p:cNvPicPr>
@@ -7825,121 +7804,38 @@
         </p:blipFill>
         <p:spPr>
           <a:xfrm>
-            <a:off x="1610738" y="1554480"/>
-            <a:ext cx="5556762" cy="4160520"/>
+            <a:off x="636099" y="1572768"/>
+            <a:ext cx="6774520" cy="4114800"/>
           </a:xfrm>
           <a:prstGeom prst="rect">
             <a:avLst/>
           </a:prstGeom>
         </p:spPr>
       </p:pic>
-      <p:sp>
-        <p:nvSpPr>
-          <p:cNvPr id="8" name="TextBox 7"/>
-          <p:cNvSpPr txBox="1"/>
-          <p:nvPr/>
-        </p:nvSpPr>
-        <p:spPr>
-          <a:xfrm>
-            <a:off x="8412480" y="1920240"/>
-            <a:ext cx="3246120" cy="3749039"/>
-          </a:xfrm>
-          <a:prstGeom prst="rect">
-            <a:avLst/>
-          </a:prstGeom>
-          <a:noFill/>
-        </p:spPr>
-        <p:txBody>
-          <a:bodyPr wrap="square">
-            <a:spAutoFit/>
-          </a:bodyPr>
-          <a:lstStyle/>
-          <a:p>
-            <a:pPr>
-              <a:lnSpc>
-                <a:spcPct val="110000"/>
-              </a:lnSpc>
-              <a:spcAft>
-                <a:spcPts val="1000"/>
-              </a:spcAft>
-            </a:pPr>
-            <a:r>
-              <a:rPr sz="1450" b="1" i="0">
-                <a:solidFill>
-                  <a:srgbClr val="2A78D6"/>
-                </a:solidFill>
-                <a:latin typeface="Calibri"/>
-              </a:rPr>
-              <a:t>▸  </a:t>
-            </a:r>
-            <a:r>
-              <a:rPr sz="1450" b="0" i="0">
-                <a:solidFill>
-                  <a:srgbClr val="3F3E3A"/>
-                </a:solidFill>
-                <a:latin typeface="Calibri"/>
-              </a:rPr>
-              <a:t>bw (Bandbreite): falsche Physik — 25 MB L2.</a:t>
-            </a:r>
-          </a:p>
-          <a:p>
-            <a:pPr>
-              <a:lnSpc>
-                <a:spcPct val="110000"/>
-              </a:lnSpc>
-              <a:spcAft>
-                <a:spcPts val="1000"/>
-              </a:spcAft>
-            </a:pPr>
-            <a:r>
-              <a:rPr sz="1450" b="1" i="0">
-                <a:solidFill>
-                  <a:srgbClr val="2A78D6"/>
-                </a:solidFill>
-                <a:latin typeface="Calibri"/>
-              </a:rPr>
-              <a:t>▸  </a:t>
-            </a:r>
-            <a:r>
-              <a:rPr sz="1450" b="0" i="0">
-                <a:solidFill>
-                  <a:srgbClr val="3F3E3A"/>
-                </a:solidFill>
-                <a:latin typeface="Calibri"/>
-              </a:rPr>
-              <a:t>v2 (bw + Reg-Filter): 97.8 % top-7 → Default.</a:t>
-            </a:r>
-          </a:p>
-          <a:p>
-            <a:pPr>
-              <a:lnSpc>
-                <a:spcPct val="110000"/>
-              </a:lnSpc>
-              <a:spcAft>
-                <a:spcPts val="1000"/>
-              </a:spcAft>
-            </a:pPr>
-            <a:r>
-              <a:rPr sz="1450" b="1" i="0">
-                <a:solidFill>
-                  <a:srgbClr val="2A78D6"/>
-                </a:solidFill>
-                <a:latin typeface="Calibri"/>
-              </a:rPr>
-              <a:t>▸  </a:t>
-            </a:r>
-            <a:r>
-              <a:rPr sz="1450" b="0" i="0">
-                <a:solidFill>
-                  <a:srgbClr val="3F3E3A"/>
-                </a:solidFill>
-                <a:latin typeface="Calibri"/>
-              </a:rPr>
-              <a:t>roofline: beste Korrelation, schaltet Regime selbst um.</a:t>
-            </a:r>
-          </a:p>
-        </p:txBody>
-      </p:sp>
+      <p:pic>
+        <p:nvPicPr>
+          <p:cNvPr id="8" name="Picture 7" descr="fig_a06_ladder.png"/>
+          <p:cNvPicPr>
+            <a:picLocks noChangeAspect="1"/>
+          </p:cNvPicPr>
+          <p:nvPr/>
+        </p:nvPicPr>
+        <p:blipFill>
+          <a:blip r:embed="rId3"/>
+          <a:stretch>
+            <a:fillRect/>
+          </a:stretch>
+        </p:blipFill>
+        <p:spPr>
+          <a:xfrm>
+            <a:off x="7726679" y="1911405"/>
+            <a:ext cx="4023360" cy="3437524"/>
+          </a:xfrm>
+          <a:prstGeom prst="rect">
+            <a:avLst/>
+          </a:prstGeom>
+        </p:spPr>
+      </p:pic>
       <p:sp>
         <p:nvSpPr>
           <p:cNvPr id="9" name="Rectangle 8"/>
@@ -8014,7 +7910,7 @@
                 </a:solidFill>
                 <a:latin typeface="Calibri"/>
               </a:rPr>
-              <a:t>Höchste Korrelation ≠ beste Top-k-Ausbeute — für die Praxis zählt der Vorfilter, also v2.</a:t>
+              <a:t>Anders als GEMM: unsere Bench-Best schlägt torch, wo dessen Ring-Pfad schlecht ist (tall, large_k); der Tuner schlägt zudem den Handkernel (+24 %, aus k_prim=32).</a:t>
             </a:r>
           </a:p>
         </p:txBody>
@@ -8075,7 +7971,7 @@
                 </a:solidFill>
                 <a:latin typeface="Calibri"/>
               </a:rPr>
-              <a:t>ERGEBNISSE · CROSS-GPU</a:t>
+              <a:t>MODELL · PRAXIS</a:t>
             </a:r>
           </a:p>
         </p:txBody>
@@ -8110,7 +8006,7 @@
                 </a:solidFill>
                 <a:latin typeface="Calibri"/>
               </a:rPr>
-              <a:t>Derselbe Hebel, aber andere Config pro GPU</a:t>
+              <a:t>Wie oft ist das Optimum in den Top-k?</a:t>
             </a:r>
           </a:p>
         </p:txBody>
@@ -8231,7 +8127,7 @@
       </p:sp>
       <p:pic>
         <p:nvPicPr>
-          <p:cNvPr id="7" name="Picture 6" descr="fig_crossgpu_lever.png"/>
+          <p:cNvPr id="7" name="Picture 6" descr="fig_topk_curve.png"/>
           <p:cNvPicPr>
             <a:picLocks noChangeAspect="1"/>
           </p:cNvPicPr>
@@ -8245,8 +8141,8 @@
         </p:blipFill>
         <p:spPr>
           <a:xfrm>
-            <a:off x="2449389" y="1572768"/>
-            <a:ext cx="7262740" cy="4069080"/>
+            <a:off x="1225870" y="1554480"/>
+            <a:ext cx="6509379" cy="4160520"/>
           </a:xfrm>
           <a:prstGeom prst="rect">
             <a:avLst/>
@@ -8255,7 +8151,142 @@
       </p:pic>
       <p:sp>
         <p:nvSpPr>
-          <p:cNvPr id="8" name="Rectangle 7"/>
+          <p:cNvPr id="8" name="TextBox 7"/>
+          <p:cNvSpPr txBox="1"/>
+          <p:nvPr/>
+        </p:nvSpPr>
+        <p:spPr>
+          <a:xfrm>
+            <a:off x="8595360" y="1965960"/>
+            <a:ext cx="3063240" cy="3657600"/>
+          </a:xfrm>
+          <a:prstGeom prst="rect">
+            <a:avLst/>
+          </a:prstGeom>
+          <a:noFill/>
+        </p:spPr>
+        <p:txBody>
+          <a:bodyPr wrap="square">
+            <a:spAutoFit/>
+          </a:bodyPr>
+          <a:lstStyle/>
+          <a:p>
+            <a:pPr>
+              <a:lnSpc>
+                <a:spcPct val="110000"/>
+              </a:lnSpc>
+              <a:spcAft>
+                <a:spcPts val="1000"/>
+              </a:spcAft>
+            </a:pPr>
+            <a:r>
+              <a:rPr sz="1500" b="1" i="0">
+                <a:solidFill>
+                  <a:srgbClr val="2A78D6"/>
+                </a:solidFill>
+                <a:latin typeface="Calibri"/>
+              </a:rPr>
+              <a:t>▸  </a:t>
+            </a:r>
+            <a:r>
+              <a:rPr sz="1500" b="1" i="0">
+                <a:solidFill>
+                  <a:srgbClr val="0B0B0B"/>
+                </a:solidFill>
+                <a:latin typeface="Calibri"/>
+              </a:rPr>
+              <a:t>top-7 · ~3 s · ≥ 95 %</a:t>
+            </a:r>
+          </a:p>
+          <a:p>
+            <a:pPr>
+              <a:lnSpc>
+                <a:spcPct val="110000"/>
+              </a:lnSpc>
+              <a:spcAft>
+                <a:spcPts val="1000"/>
+              </a:spcAft>
+            </a:pPr>
+            <a:r>
+              <a:rPr sz="1500" b="1" i="0">
+                <a:solidFill>
+                  <a:srgbClr val="2A78D6"/>
+                </a:solidFill>
+                <a:latin typeface="Calibri"/>
+              </a:rPr>
+              <a:t>▸  </a:t>
+            </a:r>
+            <a:r>
+              <a:rPr sz="1500" b="1" i="0">
+                <a:solidFill>
+                  <a:srgbClr val="0B0B0B"/>
+                </a:solidFill>
+                <a:latin typeface="Calibri"/>
+              </a:rPr>
+              <a:t>top-45 · ~18 s · ≥ 99 %</a:t>
+            </a:r>
+          </a:p>
+          <a:p>
+            <a:pPr>
+              <a:lnSpc>
+                <a:spcPct val="110000"/>
+              </a:lnSpc>
+              <a:spcAft>
+                <a:spcPts val="1000"/>
+              </a:spcAft>
+            </a:pPr>
+            <a:r>
+              <a:rPr sz="1500" b="1" i="0">
+                <a:solidFill>
+                  <a:srgbClr val="2A78D6"/>
+                </a:solidFill>
+                <a:latin typeface="Calibri"/>
+              </a:rPr>
+              <a:t>▸  </a:t>
+            </a:r>
+            <a:r>
+              <a:rPr sz="1500" b="1" i="0">
+                <a:solidFill>
+                  <a:srgbClr val="0B0B0B"/>
+                </a:solidFill>
+                <a:latin typeface="Calibri"/>
+              </a:rPr>
+              <a:t>Voll-Sweep · ~3 min · 100 %</a:t>
+            </a:r>
+          </a:p>
+          <a:p>
+            <a:pPr>
+              <a:lnSpc>
+                <a:spcPct val="110000"/>
+              </a:lnSpc>
+              <a:spcAft>
+                <a:spcPts val="1000"/>
+              </a:spcAft>
+            </a:pPr>
+            <a:r>
+              <a:rPr sz="1500" b="1" i="0">
+                <a:solidFill>
+                  <a:srgbClr val="2A78D6"/>
+                </a:solidFill>
+                <a:latin typeface="Calibri"/>
+              </a:rPr>
+              <a:t>▸  </a:t>
+            </a:r>
+            <a:r>
+              <a:rPr sz="1500" b="0" i="0">
+                <a:solidFill>
+                  <a:srgbClr val="3F3E3A"/>
+                </a:solidFill>
+                <a:latin typeface="Calibri"/>
+              </a:rPr>
+              <a:t>Exakt-Beste sitzt tief — Spitzenfeld liegt im Messrauschen.</a:t>
+            </a:r>
+          </a:p>
+        </p:txBody>
+      </p:sp>
+      <p:sp>
+        <p:nvSpPr>
+          <p:cNvPr id="9" name="Rectangle 8"/>
           <p:cNvSpPr/>
           <p:nvPr/>
         </p:nvSpPr>
@@ -8299,7 +8330,7 @@
       </p:sp>
       <p:sp>
         <p:nvSpPr>
-          <p:cNvPr id="9" name="TextBox 8"/>
+          <p:cNvPr id="10" name="TextBox 9"/>
           <p:cNvSpPr txBox="1"/>
           <p:nvPr/>
         </p:nvSpPr>
@@ -8327,7 +8358,7 @@
                 </a:solidFill>
                 <a:latin typeface="Calibri"/>
               </a:rPr>
-              <a:t>Tuning hilft auf beiden Karten (Ø 1.36× GB10, 1.88× 3070) und die optimale Config ist in 16/16 Shapes verschieden — genau deshalb: GPU-spezifisch tunen + cachen.</a:t>
+              <a:t>Als Vorauswahl reicht das Modell fast immer; als exakter Treffer selten — top-7 ist der Sweet Spot.</a:t>
             </a:r>
           </a:p>
         </p:txBody>
@@ -8388,7 +8419,7 @@
                 </a:solidFill>
                 <a:latin typeface="Calibri"/>
               </a:rPr>
-              <a:t>ERGEBNISSE · CROSS-GPU</a:t>
+              <a:t>MODELL</a:t>
             </a:r>
           </a:p>
         </p:txBody>
@@ -8423,7 +8454,7 @@
                 </a:solidFill>
                 <a:latin typeface="Calibri"/>
               </a:rPr>
-              <a:t>Was der Tuner pro GPU wählt — und was es kostet</a:t>
+              <a:t>Besserer Ranker ≠ besserer Vorfilter</a:t>
             </a:r>
           </a:p>
         </p:txBody>
@@ -8544,7 +8575,7 @@
       </p:sp>
       <p:pic>
         <p:nvPicPr>
-          <p:cNvPr id="7" name="Picture 6" descr="fig_config_table.png"/>
+          <p:cNvPr id="7" name="Picture 6" descr="fig_ranking_models.png"/>
           <p:cNvPicPr>
             <a:picLocks noChangeAspect="1"/>
           </p:cNvPicPr>
@@ -8558,8 +8589,8 @@
         </p:blipFill>
         <p:spPr>
           <a:xfrm>
-            <a:off x="457200" y="1668356"/>
-            <a:ext cx="7635240" cy="3832183"/>
+            <a:off x="1610738" y="1554480"/>
+            <a:ext cx="5556762" cy="4160520"/>
           </a:xfrm>
           <a:prstGeom prst="rect">
             <a:avLst/>
@@ -8574,8 +8605,8 @@
         </p:nvSpPr>
         <p:spPr>
           <a:xfrm>
-            <a:off x="8229600" y="1874519"/>
-            <a:ext cx="3429000" cy="3794760"/>
+            <a:off x="8412480" y="1920240"/>
+            <a:ext cx="3246120" cy="3749039"/>
           </a:xfrm>
           <a:prstGeom prst="rect">
             <a:avLst/>
@@ -8597,7 +8628,7 @@
               </a:spcAft>
             </a:pPr>
             <a:r>
-              <a:rPr sz="1400" b="1" i="0">
+              <a:rPr sz="1450" b="1" i="0">
                 <a:solidFill>
                   <a:srgbClr val="2A78D6"/>
                 </a:solidFill>
@@ -8606,13 +8637,13 @@
               <a:t>▸  </a:t>
             </a:r>
             <a:r>
-              <a:rPr sz="1400" b="0" i="0">
+              <a:rPr sz="1450" b="0" i="0">
                 <a:solidFill>
                   <a:srgbClr val="3F3E3A"/>
                 </a:solidFill>
                 <a:latin typeface="Calibri"/>
               </a:rPr>
-              <a:t>Optimum in 16/16 Shapes verschieden — pro GPU eine andere Config.</a:t>
+              <a:t>bw (Bandbreite): falsche Physik — 25 MB L2.</a:t>
             </a:r>
           </a:p>
           <a:p>
@@ -8625,7 +8656,7 @@
               </a:spcAft>
             </a:pPr>
             <a:r>
-              <a:rPr sz="1400" b="1" i="0">
+              <a:rPr sz="1450" b="1" i="0">
                 <a:solidFill>
                   <a:srgbClr val="2A78D6"/>
                 </a:solidFill>
@@ -8634,13 +8665,13 @@
               <a:t>▸  </a:t>
             </a:r>
             <a:r>
-              <a:rPr sz="1400" b="0" i="0">
+              <a:rPr sz="1450" b="0" i="0">
                 <a:solidFill>
                   <a:srgbClr val="3F3E3A"/>
                 </a:solidFill>
                 <a:latin typeface="Calibri"/>
               </a:rPr>
-              <a:t>Autotuner (v2, top-7) trifft ⌀ 96 % (GB10) / 90 % (3070) des Optimums.</a:t>
+              <a:t>v2 (bw + Reg-Filter): 97.8 % top-7 → Default.</a:t>
             </a:r>
           </a:p>
           <a:p>
@@ -8653,7 +8684,7 @@
               </a:spcAft>
             </a:pPr>
             <a:r>
-              <a:rPr sz="1400" b="1" i="0">
+              <a:rPr sz="1450" b="1" i="0">
                 <a:solidFill>
                   <a:srgbClr val="2A78D6"/>
                 </a:solidFill>
@@ -8662,41 +8693,13 @@
               <a:t>▸  </a:t>
             </a:r>
             <a:r>
-              <a:rPr sz="1400" b="0" i="0">
+              <a:rPr sz="1450" b="0" i="0">
                 <a:solidFill>
                   <a:srgbClr val="3F3E3A"/>
                 </a:solidFill>
                 <a:latin typeface="Calibri"/>
               </a:rPr>
-              <a:t>Kosten: GB10 ~3 s/Shape; 3070 (WSL-Compile) ~3 s–2 min — Compile dominiert.</a:t>
-            </a:r>
-          </a:p>
-          <a:p>
-            <a:pPr>
-              <a:lnSpc>
-                <a:spcPct val="110000"/>
-              </a:lnSpc>
-              <a:spcAft>
-                <a:spcPts val="1000"/>
-              </a:spcAft>
-            </a:pPr>
-            <a:r>
-              <a:rPr sz="1400" b="1" i="0">
-                <a:solidFill>
-                  <a:srgbClr val="2A78D6"/>
-                </a:solidFill>
-                <a:latin typeface="Calibri"/>
-              </a:rPr>
-              <a:t>▸  </a:t>
-            </a:r>
-            <a:r>
-              <a:rPr sz="1400" b="0" i="0">
-                <a:solidFill>
-                  <a:srgbClr val="3F3E3A"/>
-                </a:solidFill>
-                <a:latin typeface="Calibri"/>
-              </a:rPr>
-              <a:t>Roofline schaltet sein Regime selbst um; praktisch bleibt v2 der beste Vorfilter.</a:t>
+              <a:t>roofline: beste Korrelation, schaltet Regime selbst um.</a:t>
             </a:r>
           </a:p>
         </p:txBody>
@@ -8775,7 +8778,7 @@
                 </a:solidFill>
                 <a:latin typeface="Calibri"/>
               </a:rPr>
-              <a:t>Pro GPU von Hand zu tunen ist nicht machbar — das nimmt der gecachte Tuner ab, ohne auf eine Karte zu overfitten.</a:t>
+              <a:t>Höchste Korrelation ≠ beste Top-k-Ausbeute — für die Praxis zählt der Vorfilter, also v2.</a:t>
             </a:r>
           </a:p>
         </p:txBody>
@@ -8836,7 +8839,7 @@
                 </a:solidFill>
                 <a:latin typeface="Calibri"/>
               </a:rPr>
-              <a:t>EINORDNUNG</a:t>
+              <a:t>ERGEBNISSE · CROSS-GPU</a:t>
             </a:r>
           </a:p>
         </p:txBody>
@@ -8871,7 +8874,7 @@
                 </a:solidFill>
                 <a:latin typeface="Calibri"/>
               </a:rPr>
-              <a:t>Wann sich Tuning lohnt: Cache &amp; Amortisierung</a:t>
+              <a:t>Derselbe Hebel, aber andere Config pro GPU</a:t>
             </a:r>
           </a:p>
         </p:txBody>
@@ -8990,307 +8993,33 @@
           </a:p>
         </p:txBody>
       </p:sp>
-      <p:sp>
-        <p:nvSpPr>
-          <p:cNvPr id="7" name="TextBox 6"/>
-          <p:cNvSpPr txBox="1"/>
-          <p:nvPr/>
-        </p:nvSpPr>
-        <p:spPr>
-          <a:xfrm>
-            <a:off x="658368" y="1783080"/>
-            <a:ext cx="6766560" cy="3657600"/>
-          </a:xfrm>
-          <a:prstGeom prst="rect">
-            <a:avLst/>
-          </a:prstGeom>
-          <a:noFill/>
-        </p:spPr>
-        <p:txBody>
-          <a:bodyPr wrap="square">
-            <a:spAutoFit/>
-          </a:bodyPr>
-          <a:lstStyle/>
-          <a:p>
-            <a:pPr>
-              <a:lnSpc>
-                <a:spcPct val="110000"/>
-              </a:lnSpc>
-              <a:spcAft>
-                <a:spcPts val="1000"/>
-              </a:spcAft>
-            </a:pPr>
-            <a:r>
-              <a:rPr sz="1650" b="1" i="0">
-                <a:solidFill>
-                  <a:srgbClr val="2A78D6"/>
-                </a:solidFill>
-                <a:latin typeface="Calibri"/>
-              </a:rPr>
-              <a:t>▸  </a:t>
-            </a:r>
-            <a:r>
-              <a:rPr sz="1650" b="0" i="0">
-                <a:solidFill>
-                  <a:srgbClr val="3F3E3A"/>
-                </a:solidFill>
-                <a:latin typeface="Calibri"/>
-              </a:rPr>
-              <a:t>Eine Kontraktion läuft ~8 ms; Tuning ~3 s ist ein Einmalposten.</a:t>
-            </a:r>
-          </a:p>
-          <a:p>
-            <a:pPr>
-              <a:lnSpc>
-                <a:spcPct val="110000"/>
-              </a:lnSpc>
-              <a:spcAft>
-                <a:spcPts val="1000"/>
-              </a:spcAft>
-            </a:pPr>
-            <a:r>
-              <a:rPr sz="1650" b="1" i="0">
-                <a:solidFill>
-                  <a:srgbClr val="2A78D6"/>
-                </a:solidFill>
-                <a:latin typeface="Calibri"/>
-              </a:rPr>
-              <a:t>▸  </a:t>
-            </a:r>
-            <a:r>
-              <a:rPr sz="1650" b="0" i="0">
-                <a:solidFill>
-                  <a:srgbClr val="3F3E3A"/>
-                </a:solidFill>
-                <a:latin typeface="Calibri"/>
-              </a:rPr>
-              <a:t>Im Netz sind Layer-Dims fix → millionenfach dieselbe Shape.</a:t>
-            </a:r>
-          </a:p>
-          <a:p>
-            <a:pPr>
-              <a:lnSpc>
-                <a:spcPct val="110000"/>
-              </a:lnSpc>
-              <a:spcAft>
-                <a:spcPts val="1000"/>
-              </a:spcAft>
-            </a:pPr>
-            <a:r>
-              <a:rPr sz="1650" b="1" i="0">
-                <a:solidFill>
-                  <a:srgbClr val="2A78D6"/>
-                </a:solidFill>
-                <a:latin typeface="Calibri"/>
-              </a:rPr>
-              <a:t>▸  </a:t>
-            </a:r>
-            <a:r>
-              <a:rPr sz="1650" b="0" i="0">
-                <a:solidFill>
-                  <a:srgbClr val="3F3E3A"/>
-                </a:solidFill>
-                <a:latin typeface="Calibri"/>
-              </a:rPr>
-              <a:t>Config-Cache: Key = Einsum + Shapes + GPU-Modell.</a:t>
-            </a:r>
-          </a:p>
-          <a:p>
-            <a:pPr>
-              <a:lnSpc>
-                <a:spcPct val="110000"/>
-              </a:lnSpc>
-              <a:spcAft>
-                <a:spcPts val="1000"/>
-              </a:spcAft>
-            </a:pPr>
-            <a:r>
-              <a:rPr sz="1650" b="1" i="0">
-                <a:solidFill>
-                  <a:srgbClr val="2A78D6"/>
-                </a:solidFill>
-                <a:latin typeface="Calibri"/>
-              </a:rPr>
-              <a:t>▸  </a:t>
-            </a:r>
-            <a:r>
-              <a:rPr sz="1650" b="0" i="0">
-                <a:solidFill>
-                  <a:srgbClr val="3F3E3A"/>
-                </a:solidFill>
-                <a:latin typeface="Calibri"/>
-              </a:rPr>
-              <a:t>Genau so machen es cuBLAS, Triton (autotune), torch.compile.</a:t>
-            </a:r>
-          </a:p>
-        </p:txBody>
-      </p:sp>
-      <p:sp>
-        <p:nvSpPr>
-          <p:cNvPr id="8" name="TextBox 7"/>
-          <p:cNvSpPr txBox="1"/>
-          <p:nvPr/>
-        </p:nvSpPr>
-        <p:spPr>
-          <a:xfrm>
-            <a:off x="7772400" y="2011680"/>
-            <a:ext cx="3749039" cy="640080"/>
-          </a:xfrm>
-          <a:prstGeom prst="rect">
-            <a:avLst/>
-          </a:prstGeom>
-          <a:noFill/>
-        </p:spPr>
-        <p:txBody>
-          <a:bodyPr wrap="square" anchor="t">
-            <a:spAutoFit/>
-          </a:bodyPr>
-          <a:lstStyle/>
-          <a:p>
-            <a:pPr algn="ctr"/>
-            <a:r>
-              <a:rPr sz="3400" b="1" i="0">
-                <a:solidFill>
-                  <a:srgbClr val="2A78D6"/>
-                </a:solidFill>
-                <a:latin typeface="Calibri"/>
-              </a:rPr>
-              <a:t>~3 s → 0 s</a:t>
-            </a:r>
-          </a:p>
-        </p:txBody>
-      </p:sp>
-      <p:sp>
-        <p:nvSpPr>
-          <p:cNvPr id="9" name="TextBox 8"/>
-          <p:cNvSpPr txBox="1"/>
-          <p:nvPr/>
-        </p:nvSpPr>
-        <p:spPr>
-          <a:xfrm>
-            <a:off x="7772400" y="2670048"/>
-            <a:ext cx="3749039" cy="457200"/>
-          </a:xfrm>
-          <a:prstGeom prst="rect">
-            <a:avLst/>
-          </a:prstGeom>
-          <a:noFill/>
-        </p:spPr>
-        <p:txBody>
-          <a:bodyPr wrap="square" anchor="t">
-            <a:spAutoFit/>
-          </a:bodyPr>
-          <a:lstStyle/>
-          <a:p>
-            <a:pPr algn="ctr"/>
-            <a:r>
-              <a:rPr sz="1250" b="0" i="0">
-                <a:solidFill>
-                  <a:srgbClr val="3F3E3A"/>
-                </a:solidFill>
-                <a:latin typeface="Calibri"/>
-              </a:rPr>
-              <a:t>erste getunte Shape → jede weitere aus dem Cache</a:t>
-            </a:r>
-          </a:p>
-        </p:txBody>
-      </p:sp>
-      <p:sp>
-        <p:nvSpPr>
-          <p:cNvPr id="10" name="Rounded Rectangle 9"/>
-          <p:cNvSpPr/>
-          <p:nvPr/>
-        </p:nvSpPr>
-        <p:spPr>
-          <a:xfrm>
-            <a:off x="7772400" y="3657600"/>
-            <a:ext cx="3749039" cy="1463040"/>
-          </a:xfrm>
-          <a:prstGeom prst="roundRect">
-            <a:avLst/>
-          </a:prstGeom>
-          <a:solidFill>
-            <a:srgbClr val="F4F7FB"/>
-          </a:solidFill>
-          <a:ln w="12700">
-            <a:solidFill>
-              <a:srgbClr val="DDE4EC"/>
-            </a:solidFill>
-          </a:ln>
-          <a:effectLst/>
-        </p:spPr>
-        <p:style>
-          <a:lnRef idx="1">
-            <a:schemeClr val="accent1"/>
-          </a:lnRef>
-          <a:fillRef idx="3">
-            <a:schemeClr val="accent1"/>
-          </a:fillRef>
-          <a:effectRef idx="2">
-            <a:schemeClr val="accent1"/>
-          </a:effectRef>
-          <a:fontRef idx="minor">
-            <a:schemeClr val="lt1"/>
-          </a:fontRef>
-        </p:style>
-        <p:txBody>
-          <a:bodyPr rtlCol="0" anchor="ctr"/>
-          <a:lstStyle/>
-          <a:p>
-            <a:pPr algn="ctr"/>
-          </a:p>
-        </p:txBody>
-      </p:sp>
-      <p:sp>
-        <p:nvSpPr>
-          <p:cNvPr id="11" name="TextBox 10"/>
-          <p:cNvSpPr txBox="1"/>
-          <p:nvPr/>
-        </p:nvSpPr>
-        <p:spPr>
-          <a:xfrm>
-            <a:off x="7973568" y="3822191"/>
-            <a:ext cx="3383280" cy="1188720"/>
-          </a:xfrm>
-          <a:prstGeom prst="rect">
-            <a:avLst/>
-          </a:prstGeom>
-          <a:noFill/>
-        </p:spPr>
-        <p:txBody>
-          <a:bodyPr wrap="square" anchor="ctr">
-            <a:spAutoFit/>
-          </a:bodyPr>
-          <a:lstStyle/>
-          <a:p>
-            <a:pPr algn="l"/>
-            <a:r>
-              <a:rPr sz="1350" b="1" i="0">
-                <a:solidFill>
-                  <a:srgbClr val="0B0B0B"/>
-                </a:solidFill>
-                <a:latin typeface="Calibri"/>
-              </a:rPr>
-              <a:t>End-to-end bestätigt</a:t>
-            </a:r>
-          </a:p>
-          <a:p>
-            <a:pPr algn="l"/>
-            <a:r>
-              <a:rPr sz="1250" b="0" i="0">
-                <a:solidFill>
-                  <a:srgbClr val="3F3E3A"/>
-                </a:solidFill>
-                <a:latin typeface="Calibri"/>
-              </a:rPr>
-              <a:t>16 Shapes getunt &amp; gecacht, 2. Aufruf Cache-Hit, Top-7 bei ~95–100 %.</a:t>
-            </a:r>
-          </a:p>
-        </p:txBody>
-      </p:sp>
-      <p:sp>
-        <p:nvSpPr>
-          <p:cNvPr id="12" name="Rectangle 11"/>
+      <p:pic>
+        <p:nvPicPr>
+          <p:cNvPr id="7" name="Picture 6" descr="fig_crossgpu_lever.png"/>
+          <p:cNvPicPr>
+            <a:picLocks noChangeAspect="1"/>
+          </p:cNvPicPr>
+          <p:nvPr/>
+        </p:nvPicPr>
+        <p:blipFill>
+          <a:blip r:embed="rId2"/>
+          <a:stretch>
+            <a:fillRect/>
+          </a:stretch>
+        </p:blipFill>
+        <p:spPr>
+          <a:xfrm>
+            <a:off x="2449389" y="1572768"/>
+            <a:ext cx="7262740" cy="4069080"/>
+          </a:xfrm>
+          <a:prstGeom prst="rect">
+            <a:avLst/>
+          </a:prstGeom>
+        </p:spPr>
+      </p:pic>
+      <p:sp>
+        <p:nvSpPr>
+          <p:cNvPr id="8" name="Rectangle 7"/>
           <p:cNvSpPr/>
           <p:nvPr/>
         </p:nvSpPr>
@@ -9334,7 +9063,7 @@
       </p:sp>
       <p:sp>
         <p:nvSpPr>
-          <p:cNvPr id="13" name="TextBox 12"/>
+          <p:cNvPr id="9" name="TextBox 8"/>
           <p:cNvSpPr txBox="1"/>
           <p:nvPr/>
         </p:nvSpPr>
@@ -9362,7 +9091,7 @@
                 </a:solidFill>
                 <a:latin typeface="Calibri"/>
               </a:rPr>
-              <a:t>Break-even in Sekunden bei fester Shape; für stark dynamische Shapes hilft Bucketing/Padding.</a:t>
+              <a:t>Tuning hilft auf beiden Karten (Ø 1.36× GB10, 1.88× 3070) und die optimale Config ist in 16/16 Shapes verschieden — genau deshalb: GPU-spezifisch tunen + cachen.</a:t>
             </a:r>
           </a:p>
         </p:txBody>
@@ -9980,6 +9709,1041 @@
     <p:bg>
       <p:bgPr>
         <a:solidFill>
+          <a:srgbClr val="FFFFFF"/>
+        </a:solidFill>
+        <a:effectLst/>
+      </p:bgPr>
+    </p:bg>
+    <p:spTree>
+      <p:nvGrpSpPr>
+        <p:cNvPr id="1" name=""/>
+        <p:cNvGrpSpPr/>
+        <p:nvPr/>
+      </p:nvGrpSpPr>
+      <p:grpSpPr/>
+      <p:sp>
+        <p:nvSpPr>
+          <p:cNvPr id="2" name="TextBox 1"/>
+          <p:cNvSpPr txBox="1"/>
+          <p:nvPr/>
+        </p:nvSpPr>
+        <p:spPr>
+          <a:xfrm>
+            <a:off x="640080" y="384048"/>
+            <a:ext cx="10972800" cy="256032"/>
+          </a:xfrm>
+          <a:prstGeom prst="rect">
+            <a:avLst/>
+          </a:prstGeom>
+          <a:noFill/>
+        </p:spPr>
+        <p:txBody>
+          <a:bodyPr wrap="square" anchor="t">
+            <a:spAutoFit/>
+          </a:bodyPr>
+          <a:lstStyle/>
+          <a:p>
+            <a:pPr algn="l"/>
+            <a:r>
+              <a:rPr sz="1250" b="1" i="0">
+                <a:solidFill>
+                  <a:srgbClr val="2A78D6"/>
+                </a:solidFill>
+                <a:latin typeface="Calibri"/>
+              </a:rPr>
+              <a:t>ERGEBNISSE · CROSS-GPU</a:t>
+            </a:r>
+          </a:p>
+        </p:txBody>
+      </p:sp>
+      <p:sp>
+        <p:nvSpPr>
+          <p:cNvPr id="3" name="TextBox 2"/>
+          <p:cNvSpPr txBox="1"/>
+          <p:nvPr/>
+        </p:nvSpPr>
+        <p:spPr>
+          <a:xfrm>
+            <a:off x="621792" y="676656"/>
+            <a:ext cx="10972800" cy="822960"/>
+          </a:xfrm>
+          <a:prstGeom prst="rect">
+            <a:avLst/>
+          </a:prstGeom>
+          <a:noFill/>
+        </p:spPr>
+        <p:txBody>
+          <a:bodyPr wrap="square" anchor="t">
+            <a:spAutoFit/>
+          </a:bodyPr>
+          <a:lstStyle/>
+          <a:p>
+            <a:pPr algn="l"/>
+            <a:r>
+              <a:rPr sz="2700" b="1" i="0">
+                <a:solidFill>
+                  <a:srgbClr val="0B0B0B"/>
+                </a:solidFill>
+                <a:latin typeface="Calibri"/>
+              </a:rPr>
+              <a:t>Was der Tuner pro GPU wählt — und was es kostet</a:t>
+            </a:r>
+          </a:p>
+        </p:txBody>
+      </p:sp>
+      <p:sp>
+        <p:nvSpPr>
+          <p:cNvPr id="4" name="Rectangle 3"/>
+          <p:cNvSpPr/>
+          <p:nvPr/>
+        </p:nvSpPr>
+        <p:spPr>
+          <a:xfrm>
+            <a:off x="658368" y="1389888"/>
+            <a:ext cx="1920240" cy="50292"/>
+          </a:xfrm>
+          <a:prstGeom prst="rect">
+            <a:avLst/>
+          </a:prstGeom>
+          <a:solidFill>
+            <a:srgbClr val="2A78D6"/>
+          </a:solidFill>
+          <a:ln>
+            <a:noFill/>
+          </a:ln>
+          <a:effectLst/>
+        </p:spPr>
+        <p:style>
+          <a:lnRef idx="1">
+            <a:schemeClr val="accent1"/>
+          </a:lnRef>
+          <a:fillRef idx="3">
+            <a:schemeClr val="accent1"/>
+          </a:fillRef>
+          <a:effectRef idx="2">
+            <a:schemeClr val="accent1"/>
+          </a:effectRef>
+          <a:fontRef idx="minor">
+            <a:schemeClr val="lt1"/>
+          </a:fontRef>
+        </p:style>
+        <p:txBody>
+          <a:bodyPr rtlCol="0" anchor="ctr"/>
+          <a:lstStyle/>
+          <a:p>
+            <a:pPr algn="ctr"/>
+          </a:p>
+        </p:txBody>
+      </p:sp>
+      <p:sp>
+        <p:nvSpPr>
+          <p:cNvPr id="5" name="TextBox 4"/>
+          <p:cNvSpPr txBox="1"/>
+          <p:nvPr/>
+        </p:nvSpPr>
+        <p:spPr>
+          <a:xfrm>
+            <a:off x="640080" y="6455664"/>
+            <a:ext cx="6400800" cy="274320"/>
+          </a:xfrm>
+          <a:prstGeom prst="rect">
+            <a:avLst/>
+          </a:prstGeom>
+          <a:noFill/>
+        </p:spPr>
+        <p:txBody>
+          <a:bodyPr wrap="square" anchor="t">
+            <a:spAutoFit/>
+          </a:bodyPr>
+          <a:lstStyle/>
+          <a:p>
+            <a:pPr algn="l"/>
+            <a:r>
+              <a:rPr sz="1000" b="0" i="0">
+                <a:solidFill>
+                  <a:srgbClr val="898781"/>
+                </a:solidFill>
+                <a:latin typeface="Calibri"/>
+              </a:rPr>
+              <a:t>cuTile Auto-Tuner · Becker-Klöser · Elagina</a:t>
+            </a:r>
+          </a:p>
+        </p:txBody>
+      </p:sp>
+      <p:sp>
+        <p:nvSpPr>
+          <p:cNvPr id="6" name="TextBox 5"/>
+          <p:cNvSpPr txBox="1"/>
+          <p:nvPr/>
+        </p:nvSpPr>
+        <p:spPr>
+          <a:xfrm>
+            <a:off x="10607040" y="6455664"/>
+            <a:ext cx="1005840" cy="274320"/>
+          </a:xfrm>
+          <a:prstGeom prst="rect">
+            <a:avLst/>
+          </a:prstGeom>
+          <a:noFill/>
+        </p:spPr>
+        <p:txBody>
+          <a:bodyPr wrap="square" anchor="t">
+            <a:spAutoFit/>
+          </a:bodyPr>
+          <a:lstStyle/>
+          <a:p>
+            <a:pPr algn="r"/>
+            <a:r>
+              <a:rPr sz="1000" b="0" i="0">
+                <a:solidFill>
+                  <a:srgbClr val="898781"/>
+                </a:solidFill>
+                <a:latin typeface="Calibri"/>
+              </a:rPr>
+              <a:t>17</a:t>
+            </a:r>
+          </a:p>
+        </p:txBody>
+      </p:sp>
+      <p:pic>
+        <p:nvPicPr>
+          <p:cNvPr id="7" name="Picture 6" descr="fig_config_table.png"/>
+          <p:cNvPicPr>
+            <a:picLocks noChangeAspect="1"/>
+          </p:cNvPicPr>
+          <p:nvPr/>
+        </p:nvPicPr>
+        <p:blipFill>
+          <a:blip r:embed="rId2"/>
+          <a:stretch>
+            <a:fillRect/>
+          </a:stretch>
+        </p:blipFill>
+        <p:spPr>
+          <a:xfrm>
+            <a:off x="457200" y="1668356"/>
+            <a:ext cx="7635240" cy="3832183"/>
+          </a:xfrm>
+          <a:prstGeom prst="rect">
+            <a:avLst/>
+          </a:prstGeom>
+        </p:spPr>
+      </p:pic>
+      <p:sp>
+        <p:nvSpPr>
+          <p:cNvPr id="8" name="TextBox 7"/>
+          <p:cNvSpPr txBox="1"/>
+          <p:nvPr/>
+        </p:nvSpPr>
+        <p:spPr>
+          <a:xfrm>
+            <a:off x="8229600" y="1874519"/>
+            <a:ext cx="3429000" cy="3794760"/>
+          </a:xfrm>
+          <a:prstGeom prst="rect">
+            <a:avLst/>
+          </a:prstGeom>
+          <a:noFill/>
+        </p:spPr>
+        <p:txBody>
+          <a:bodyPr wrap="square">
+            <a:spAutoFit/>
+          </a:bodyPr>
+          <a:lstStyle/>
+          <a:p>
+            <a:pPr>
+              <a:lnSpc>
+                <a:spcPct val="110000"/>
+              </a:lnSpc>
+              <a:spcAft>
+                <a:spcPts val="1000"/>
+              </a:spcAft>
+            </a:pPr>
+            <a:r>
+              <a:rPr sz="1400" b="1" i="0">
+                <a:solidFill>
+                  <a:srgbClr val="2A78D6"/>
+                </a:solidFill>
+                <a:latin typeface="Calibri"/>
+              </a:rPr>
+              <a:t>▸  </a:t>
+            </a:r>
+            <a:r>
+              <a:rPr sz="1400" b="0" i="0">
+                <a:solidFill>
+                  <a:srgbClr val="3F3E3A"/>
+                </a:solidFill>
+                <a:latin typeface="Calibri"/>
+              </a:rPr>
+              <a:t>Optimum in 16/16 Shapes verschieden — pro GPU eine andere Config.</a:t>
+            </a:r>
+          </a:p>
+          <a:p>
+            <a:pPr>
+              <a:lnSpc>
+                <a:spcPct val="110000"/>
+              </a:lnSpc>
+              <a:spcAft>
+                <a:spcPts val="1000"/>
+              </a:spcAft>
+            </a:pPr>
+            <a:r>
+              <a:rPr sz="1400" b="1" i="0">
+                <a:solidFill>
+                  <a:srgbClr val="2A78D6"/>
+                </a:solidFill>
+                <a:latin typeface="Calibri"/>
+              </a:rPr>
+              <a:t>▸  </a:t>
+            </a:r>
+            <a:r>
+              <a:rPr sz="1400" b="0" i="0">
+                <a:solidFill>
+                  <a:srgbClr val="3F3E3A"/>
+                </a:solidFill>
+                <a:latin typeface="Calibri"/>
+              </a:rPr>
+              <a:t>Autotuner (v2, top-7) trifft ⌀ 96 % (GB10) / 90 % (3070) des Optimums.</a:t>
+            </a:r>
+          </a:p>
+          <a:p>
+            <a:pPr>
+              <a:lnSpc>
+                <a:spcPct val="110000"/>
+              </a:lnSpc>
+              <a:spcAft>
+                <a:spcPts val="1000"/>
+              </a:spcAft>
+            </a:pPr>
+            <a:r>
+              <a:rPr sz="1400" b="1" i="0">
+                <a:solidFill>
+                  <a:srgbClr val="2A78D6"/>
+                </a:solidFill>
+                <a:latin typeface="Calibri"/>
+              </a:rPr>
+              <a:t>▸  </a:t>
+            </a:r>
+            <a:r>
+              <a:rPr sz="1400" b="0" i="0">
+                <a:solidFill>
+                  <a:srgbClr val="3F3E3A"/>
+                </a:solidFill>
+                <a:latin typeface="Calibri"/>
+              </a:rPr>
+              <a:t>Kosten: GB10 ~3 s/Shape; 3070 (WSL-Compile) ~3 s–2 min — Compile dominiert.</a:t>
+            </a:r>
+          </a:p>
+          <a:p>
+            <a:pPr>
+              <a:lnSpc>
+                <a:spcPct val="110000"/>
+              </a:lnSpc>
+              <a:spcAft>
+                <a:spcPts val="1000"/>
+              </a:spcAft>
+            </a:pPr>
+            <a:r>
+              <a:rPr sz="1400" b="1" i="0">
+                <a:solidFill>
+                  <a:srgbClr val="2A78D6"/>
+                </a:solidFill>
+                <a:latin typeface="Calibri"/>
+              </a:rPr>
+              <a:t>▸  </a:t>
+            </a:r>
+            <a:r>
+              <a:rPr sz="1400" b="0" i="0">
+                <a:solidFill>
+                  <a:srgbClr val="3F3E3A"/>
+                </a:solidFill>
+                <a:latin typeface="Calibri"/>
+              </a:rPr>
+              <a:t>Roofline schaltet sein Regime selbst um; praktisch bleibt v2 der beste Vorfilter.</a:t>
+            </a:r>
+          </a:p>
+        </p:txBody>
+      </p:sp>
+      <p:sp>
+        <p:nvSpPr>
+          <p:cNvPr id="9" name="Rectangle 8"/>
+          <p:cNvSpPr/>
+          <p:nvPr/>
+        </p:nvSpPr>
+        <p:spPr>
+          <a:xfrm>
+            <a:off x="658368" y="5870448"/>
+            <a:ext cx="82296" cy="402336"/>
+          </a:xfrm>
+          <a:prstGeom prst="rect">
+            <a:avLst/>
+          </a:prstGeom>
+          <a:solidFill>
+            <a:srgbClr val="EB6834"/>
+          </a:solidFill>
+          <a:ln>
+            <a:noFill/>
+          </a:ln>
+          <a:effectLst/>
+        </p:spPr>
+        <p:style>
+          <a:lnRef idx="1">
+            <a:schemeClr val="accent1"/>
+          </a:lnRef>
+          <a:fillRef idx="3">
+            <a:schemeClr val="accent1"/>
+          </a:fillRef>
+          <a:effectRef idx="2">
+            <a:schemeClr val="accent1"/>
+          </a:effectRef>
+          <a:fontRef idx="minor">
+            <a:schemeClr val="lt1"/>
+          </a:fontRef>
+        </p:style>
+        <p:txBody>
+          <a:bodyPr rtlCol="0" anchor="ctr"/>
+          <a:lstStyle/>
+          <a:p>
+            <a:pPr algn="ctr"/>
+          </a:p>
+        </p:txBody>
+      </p:sp>
+      <p:sp>
+        <p:nvSpPr>
+          <p:cNvPr id="10" name="TextBox 9"/>
+          <p:cNvSpPr txBox="1"/>
+          <p:nvPr/>
+        </p:nvSpPr>
+        <p:spPr>
+          <a:xfrm>
+            <a:off x="868680" y="5815584"/>
+            <a:ext cx="10607040" cy="502920"/>
+          </a:xfrm>
+          <a:prstGeom prst="rect">
+            <a:avLst/>
+          </a:prstGeom>
+          <a:noFill/>
+        </p:spPr>
+        <p:txBody>
+          <a:bodyPr wrap="square" anchor="ctr">
+            <a:spAutoFit/>
+          </a:bodyPr>
+          <a:lstStyle/>
+          <a:p>
+            <a:pPr algn="l"/>
+            <a:r>
+              <a:rPr sz="1500" b="0" i="0">
+                <a:solidFill>
+                  <a:srgbClr val="3F3E3A"/>
+                </a:solidFill>
+                <a:latin typeface="Calibri"/>
+              </a:rPr>
+              <a:t>Pro GPU von Hand zu tunen ist nicht machbar — das nimmt der gecachte Tuner ab, ohne auf eine Karte zu overfitten.</a:t>
+            </a:r>
+          </a:p>
+        </p:txBody>
+      </p:sp>
+    </p:spTree>
+  </p:cSld>
+  <p:clrMapOvr>
+    <a:masterClrMapping/>
+  </p:clrMapOvr>
+</p:sld>
+</file>
+
+<file path=ppt/slides/slide21.xml><?xml version="1.0" encoding="utf-8"?>
+<p:sld xmlns:a="http://schemas.openxmlformats.org/drawingml/2006/main" xmlns:p="http://schemas.openxmlformats.org/presentationml/2006/main" xmlns:r="http://schemas.openxmlformats.org/officeDocument/2006/relationships">
+  <p:cSld>
+    <p:bg>
+      <p:bgPr>
+        <a:solidFill>
+          <a:srgbClr val="FFFFFF"/>
+        </a:solidFill>
+        <a:effectLst/>
+      </p:bgPr>
+    </p:bg>
+    <p:spTree>
+      <p:nvGrpSpPr>
+        <p:cNvPr id="1" name=""/>
+        <p:cNvGrpSpPr/>
+        <p:nvPr/>
+      </p:nvGrpSpPr>
+      <p:grpSpPr/>
+      <p:sp>
+        <p:nvSpPr>
+          <p:cNvPr id="2" name="TextBox 1"/>
+          <p:cNvSpPr txBox="1"/>
+          <p:nvPr/>
+        </p:nvSpPr>
+        <p:spPr>
+          <a:xfrm>
+            <a:off x="640080" y="384048"/>
+            <a:ext cx="10972800" cy="256032"/>
+          </a:xfrm>
+          <a:prstGeom prst="rect">
+            <a:avLst/>
+          </a:prstGeom>
+          <a:noFill/>
+        </p:spPr>
+        <p:txBody>
+          <a:bodyPr wrap="square" anchor="t">
+            <a:spAutoFit/>
+          </a:bodyPr>
+          <a:lstStyle/>
+          <a:p>
+            <a:pPr algn="l"/>
+            <a:r>
+              <a:rPr sz="1250" b="1" i="0">
+                <a:solidFill>
+                  <a:srgbClr val="2A78D6"/>
+                </a:solidFill>
+                <a:latin typeface="Calibri"/>
+              </a:rPr>
+              <a:t>EINORDNUNG</a:t>
+            </a:r>
+          </a:p>
+        </p:txBody>
+      </p:sp>
+      <p:sp>
+        <p:nvSpPr>
+          <p:cNvPr id="3" name="TextBox 2"/>
+          <p:cNvSpPr txBox="1"/>
+          <p:nvPr/>
+        </p:nvSpPr>
+        <p:spPr>
+          <a:xfrm>
+            <a:off x="621792" y="676656"/>
+            <a:ext cx="10972800" cy="822960"/>
+          </a:xfrm>
+          <a:prstGeom prst="rect">
+            <a:avLst/>
+          </a:prstGeom>
+          <a:noFill/>
+        </p:spPr>
+        <p:txBody>
+          <a:bodyPr wrap="square" anchor="t">
+            <a:spAutoFit/>
+          </a:bodyPr>
+          <a:lstStyle/>
+          <a:p>
+            <a:pPr algn="l"/>
+            <a:r>
+              <a:rPr sz="2700" b="1" i="0">
+                <a:solidFill>
+                  <a:srgbClr val="0B0B0B"/>
+                </a:solidFill>
+                <a:latin typeface="Calibri"/>
+              </a:rPr>
+              <a:t>Wann sich Tuning lohnt: Cache &amp; Amortisierung</a:t>
+            </a:r>
+          </a:p>
+        </p:txBody>
+      </p:sp>
+      <p:sp>
+        <p:nvSpPr>
+          <p:cNvPr id="4" name="Rectangle 3"/>
+          <p:cNvSpPr/>
+          <p:nvPr/>
+        </p:nvSpPr>
+        <p:spPr>
+          <a:xfrm>
+            <a:off x="658368" y="1389888"/>
+            <a:ext cx="1920240" cy="50292"/>
+          </a:xfrm>
+          <a:prstGeom prst="rect">
+            <a:avLst/>
+          </a:prstGeom>
+          <a:solidFill>
+            <a:srgbClr val="2A78D6"/>
+          </a:solidFill>
+          <a:ln>
+            <a:noFill/>
+          </a:ln>
+          <a:effectLst/>
+        </p:spPr>
+        <p:style>
+          <a:lnRef idx="1">
+            <a:schemeClr val="accent1"/>
+          </a:lnRef>
+          <a:fillRef idx="3">
+            <a:schemeClr val="accent1"/>
+          </a:fillRef>
+          <a:effectRef idx="2">
+            <a:schemeClr val="accent1"/>
+          </a:effectRef>
+          <a:fontRef idx="minor">
+            <a:schemeClr val="lt1"/>
+          </a:fontRef>
+        </p:style>
+        <p:txBody>
+          <a:bodyPr rtlCol="0" anchor="ctr"/>
+          <a:lstStyle/>
+          <a:p>
+            <a:pPr algn="ctr"/>
+          </a:p>
+        </p:txBody>
+      </p:sp>
+      <p:sp>
+        <p:nvSpPr>
+          <p:cNvPr id="5" name="TextBox 4"/>
+          <p:cNvSpPr txBox="1"/>
+          <p:nvPr/>
+        </p:nvSpPr>
+        <p:spPr>
+          <a:xfrm>
+            <a:off x="640080" y="6455664"/>
+            <a:ext cx="6400800" cy="274320"/>
+          </a:xfrm>
+          <a:prstGeom prst="rect">
+            <a:avLst/>
+          </a:prstGeom>
+          <a:noFill/>
+        </p:spPr>
+        <p:txBody>
+          <a:bodyPr wrap="square" anchor="t">
+            <a:spAutoFit/>
+          </a:bodyPr>
+          <a:lstStyle/>
+          <a:p>
+            <a:pPr algn="l"/>
+            <a:r>
+              <a:rPr sz="1000" b="0" i="0">
+                <a:solidFill>
+                  <a:srgbClr val="898781"/>
+                </a:solidFill>
+                <a:latin typeface="Calibri"/>
+              </a:rPr>
+              <a:t>cuTile Auto-Tuner · Becker-Klöser · Elagina</a:t>
+            </a:r>
+          </a:p>
+        </p:txBody>
+      </p:sp>
+      <p:sp>
+        <p:nvSpPr>
+          <p:cNvPr id="6" name="TextBox 5"/>
+          <p:cNvSpPr txBox="1"/>
+          <p:nvPr/>
+        </p:nvSpPr>
+        <p:spPr>
+          <a:xfrm>
+            <a:off x="10607040" y="6455664"/>
+            <a:ext cx="1005840" cy="274320"/>
+          </a:xfrm>
+          <a:prstGeom prst="rect">
+            <a:avLst/>
+          </a:prstGeom>
+          <a:noFill/>
+        </p:spPr>
+        <p:txBody>
+          <a:bodyPr wrap="square" anchor="t">
+            <a:spAutoFit/>
+          </a:bodyPr>
+          <a:lstStyle/>
+          <a:p>
+            <a:pPr algn="r"/>
+            <a:r>
+              <a:rPr sz="1000" b="0" i="0">
+                <a:solidFill>
+                  <a:srgbClr val="898781"/>
+                </a:solidFill>
+                <a:latin typeface="Calibri"/>
+              </a:rPr>
+              <a:t>18</a:t>
+            </a:r>
+          </a:p>
+        </p:txBody>
+      </p:sp>
+      <p:sp>
+        <p:nvSpPr>
+          <p:cNvPr id="7" name="TextBox 6"/>
+          <p:cNvSpPr txBox="1"/>
+          <p:nvPr/>
+        </p:nvSpPr>
+        <p:spPr>
+          <a:xfrm>
+            <a:off x="658368" y="1783080"/>
+            <a:ext cx="6766560" cy="3657600"/>
+          </a:xfrm>
+          <a:prstGeom prst="rect">
+            <a:avLst/>
+          </a:prstGeom>
+          <a:noFill/>
+        </p:spPr>
+        <p:txBody>
+          <a:bodyPr wrap="square">
+            <a:spAutoFit/>
+          </a:bodyPr>
+          <a:lstStyle/>
+          <a:p>
+            <a:pPr>
+              <a:lnSpc>
+                <a:spcPct val="110000"/>
+              </a:lnSpc>
+              <a:spcAft>
+                <a:spcPts val="1000"/>
+              </a:spcAft>
+            </a:pPr>
+            <a:r>
+              <a:rPr sz="1650" b="1" i="0">
+                <a:solidFill>
+                  <a:srgbClr val="2A78D6"/>
+                </a:solidFill>
+                <a:latin typeface="Calibri"/>
+              </a:rPr>
+              <a:t>▸  </a:t>
+            </a:r>
+            <a:r>
+              <a:rPr sz="1650" b="0" i="0">
+                <a:solidFill>
+                  <a:srgbClr val="3F3E3A"/>
+                </a:solidFill>
+                <a:latin typeface="Calibri"/>
+              </a:rPr>
+              <a:t>Eine Kontraktion läuft ~8 ms; Tuning ~3 s ist ein Einmalposten.</a:t>
+            </a:r>
+          </a:p>
+          <a:p>
+            <a:pPr>
+              <a:lnSpc>
+                <a:spcPct val="110000"/>
+              </a:lnSpc>
+              <a:spcAft>
+                <a:spcPts val="1000"/>
+              </a:spcAft>
+            </a:pPr>
+            <a:r>
+              <a:rPr sz="1650" b="1" i="0">
+                <a:solidFill>
+                  <a:srgbClr val="2A78D6"/>
+                </a:solidFill>
+                <a:latin typeface="Calibri"/>
+              </a:rPr>
+              <a:t>▸  </a:t>
+            </a:r>
+            <a:r>
+              <a:rPr sz="1650" b="0" i="0">
+                <a:solidFill>
+                  <a:srgbClr val="3F3E3A"/>
+                </a:solidFill>
+                <a:latin typeface="Calibri"/>
+              </a:rPr>
+              <a:t>Im Netz sind Layer-Dims fix → millionenfach dieselbe Shape.</a:t>
+            </a:r>
+          </a:p>
+          <a:p>
+            <a:pPr>
+              <a:lnSpc>
+                <a:spcPct val="110000"/>
+              </a:lnSpc>
+              <a:spcAft>
+                <a:spcPts val="1000"/>
+              </a:spcAft>
+            </a:pPr>
+            <a:r>
+              <a:rPr sz="1650" b="1" i="0">
+                <a:solidFill>
+                  <a:srgbClr val="2A78D6"/>
+                </a:solidFill>
+                <a:latin typeface="Calibri"/>
+              </a:rPr>
+              <a:t>▸  </a:t>
+            </a:r>
+            <a:r>
+              <a:rPr sz="1650" b="0" i="0">
+                <a:solidFill>
+                  <a:srgbClr val="3F3E3A"/>
+                </a:solidFill>
+                <a:latin typeface="Calibri"/>
+              </a:rPr>
+              <a:t>Config-Cache: Key = Einsum + Shapes + GPU-Modell.</a:t>
+            </a:r>
+          </a:p>
+          <a:p>
+            <a:pPr>
+              <a:lnSpc>
+                <a:spcPct val="110000"/>
+              </a:lnSpc>
+              <a:spcAft>
+                <a:spcPts val="1000"/>
+              </a:spcAft>
+            </a:pPr>
+            <a:r>
+              <a:rPr sz="1650" b="1" i="0">
+                <a:solidFill>
+                  <a:srgbClr val="2A78D6"/>
+                </a:solidFill>
+                <a:latin typeface="Calibri"/>
+              </a:rPr>
+              <a:t>▸  </a:t>
+            </a:r>
+            <a:r>
+              <a:rPr sz="1650" b="0" i="0">
+                <a:solidFill>
+                  <a:srgbClr val="3F3E3A"/>
+                </a:solidFill>
+                <a:latin typeface="Calibri"/>
+              </a:rPr>
+              <a:t>Genau so machen es cuBLAS, Triton (autotune), torch.compile.</a:t>
+            </a:r>
+          </a:p>
+        </p:txBody>
+      </p:sp>
+      <p:sp>
+        <p:nvSpPr>
+          <p:cNvPr id="8" name="TextBox 7"/>
+          <p:cNvSpPr txBox="1"/>
+          <p:nvPr/>
+        </p:nvSpPr>
+        <p:spPr>
+          <a:xfrm>
+            <a:off x="7772400" y="2011680"/>
+            <a:ext cx="3749039" cy="640080"/>
+          </a:xfrm>
+          <a:prstGeom prst="rect">
+            <a:avLst/>
+          </a:prstGeom>
+          <a:noFill/>
+        </p:spPr>
+        <p:txBody>
+          <a:bodyPr wrap="square" anchor="t">
+            <a:spAutoFit/>
+          </a:bodyPr>
+          <a:lstStyle/>
+          <a:p>
+            <a:pPr algn="ctr"/>
+            <a:r>
+              <a:rPr sz="3400" b="1" i="0">
+                <a:solidFill>
+                  <a:srgbClr val="2A78D6"/>
+                </a:solidFill>
+                <a:latin typeface="Calibri"/>
+              </a:rPr>
+              <a:t>~3 s → 0 s</a:t>
+            </a:r>
+          </a:p>
+        </p:txBody>
+      </p:sp>
+      <p:sp>
+        <p:nvSpPr>
+          <p:cNvPr id="9" name="TextBox 8"/>
+          <p:cNvSpPr txBox="1"/>
+          <p:nvPr/>
+        </p:nvSpPr>
+        <p:spPr>
+          <a:xfrm>
+            <a:off x="7772400" y="2670048"/>
+            <a:ext cx="3749039" cy="457200"/>
+          </a:xfrm>
+          <a:prstGeom prst="rect">
+            <a:avLst/>
+          </a:prstGeom>
+          <a:noFill/>
+        </p:spPr>
+        <p:txBody>
+          <a:bodyPr wrap="square" anchor="t">
+            <a:spAutoFit/>
+          </a:bodyPr>
+          <a:lstStyle/>
+          <a:p>
+            <a:pPr algn="ctr"/>
+            <a:r>
+              <a:rPr sz="1250" b="0" i="0">
+                <a:solidFill>
+                  <a:srgbClr val="3F3E3A"/>
+                </a:solidFill>
+                <a:latin typeface="Calibri"/>
+              </a:rPr>
+              <a:t>erste getunte Shape → jede weitere aus dem Cache</a:t>
+            </a:r>
+          </a:p>
+        </p:txBody>
+      </p:sp>
+      <p:sp>
+        <p:nvSpPr>
+          <p:cNvPr id="10" name="Rounded Rectangle 9"/>
+          <p:cNvSpPr/>
+          <p:nvPr/>
+        </p:nvSpPr>
+        <p:spPr>
+          <a:xfrm>
+            <a:off x="7772400" y="3657600"/>
+            <a:ext cx="3749039" cy="1463040"/>
+          </a:xfrm>
+          <a:prstGeom prst="roundRect">
+            <a:avLst/>
+          </a:prstGeom>
+          <a:solidFill>
+            <a:srgbClr val="F4F7FB"/>
+          </a:solidFill>
+          <a:ln w="12700">
+            <a:solidFill>
+              <a:srgbClr val="DDE4EC"/>
+            </a:solidFill>
+          </a:ln>
+          <a:effectLst/>
+        </p:spPr>
+        <p:style>
+          <a:lnRef idx="1">
+            <a:schemeClr val="accent1"/>
+          </a:lnRef>
+          <a:fillRef idx="3">
+            <a:schemeClr val="accent1"/>
+          </a:fillRef>
+          <a:effectRef idx="2">
+            <a:schemeClr val="accent1"/>
+          </a:effectRef>
+          <a:fontRef idx="minor">
+            <a:schemeClr val="lt1"/>
+          </a:fontRef>
+        </p:style>
+        <p:txBody>
+          <a:bodyPr rtlCol="0" anchor="ctr"/>
+          <a:lstStyle/>
+          <a:p>
+            <a:pPr algn="ctr"/>
+          </a:p>
+        </p:txBody>
+      </p:sp>
+      <p:sp>
+        <p:nvSpPr>
+          <p:cNvPr id="11" name="TextBox 10"/>
+          <p:cNvSpPr txBox="1"/>
+          <p:nvPr/>
+        </p:nvSpPr>
+        <p:spPr>
+          <a:xfrm>
+            <a:off x="7973568" y="3822191"/>
+            <a:ext cx="3383280" cy="1188720"/>
+          </a:xfrm>
+          <a:prstGeom prst="rect">
+            <a:avLst/>
+          </a:prstGeom>
+          <a:noFill/>
+        </p:spPr>
+        <p:txBody>
+          <a:bodyPr wrap="square" anchor="ctr">
+            <a:spAutoFit/>
+          </a:bodyPr>
+          <a:lstStyle/>
+          <a:p>
+            <a:pPr algn="l"/>
+            <a:r>
+              <a:rPr sz="1350" b="1" i="0">
+                <a:solidFill>
+                  <a:srgbClr val="0B0B0B"/>
+                </a:solidFill>
+                <a:latin typeface="Calibri"/>
+              </a:rPr>
+              <a:t>End-to-end bestätigt</a:t>
+            </a:r>
+          </a:p>
+          <a:p>
+            <a:pPr algn="l"/>
+            <a:r>
+              <a:rPr sz="1250" b="0" i="0">
+                <a:solidFill>
+                  <a:srgbClr val="3F3E3A"/>
+                </a:solidFill>
+                <a:latin typeface="Calibri"/>
+              </a:rPr>
+              <a:t>16 Shapes getunt &amp; gecacht, 2. Aufruf Cache-Hit, Top-7 bei ~95–100 %.</a:t>
+            </a:r>
+          </a:p>
+        </p:txBody>
+      </p:sp>
+      <p:sp>
+        <p:nvSpPr>
+          <p:cNvPr id="12" name="Rectangle 11"/>
+          <p:cNvSpPr/>
+          <p:nvPr/>
+        </p:nvSpPr>
+        <p:spPr>
+          <a:xfrm>
+            <a:off x="658368" y="5870448"/>
+            <a:ext cx="82296" cy="402336"/>
+          </a:xfrm>
+          <a:prstGeom prst="rect">
+            <a:avLst/>
+          </a:prstGeom>
+          <a:solidFill>
+            <a:srgbClr val="EB6834"/>
+          </a:solidFill>
+          <a:ln>
+            <a:noFill/>
+          </a:ln>
+          <a:effectLst/>
+        </p:spPr>
+        <p:style>
+          <a:lnRef idx="1">
+            <a:schemeClr val="accent1"/>
+          </a:lnRef>
+          <a:fillRef idx="3">
+            <a:schemeClr val="accent1"/>
+          </a:fillRef>
+          <a:effectRef idx="2">
+            <a:schemeClr val="accent1"/>
+          </a:effectRef>
+          <a:fontRef idx="minor">
+            <a:schemeClr val="lt1"/>
+          </a:fontRef>
+        </p:style>
+        <p:txBody>
+          <a:bodyPr rtlCol="0" anchor="ctr"/>
+          <a:lstStyle/>
+          <a:p>
+            <a:pPr algn="ctr"/>
+          </a:p>
+        </p:txBody>
+      </p:sp>
+      <p:sp>
+        <p:nvSpPr>
+          <p:cNvPr id="13" name="TextBox 12"/>
+          <p:cNvSpPr txBox="1"/>
+          <p:nvPr/>
+        </p:nvSpPr>
+        <p:spPr>
+          <a:xfrm>
+            <a:off x="868680" y="5815584"/>
+            <a:ext cx="10607040" cy="502920"/>
+          </a:xfrm>
+          <a:prstGeom prst="rect">
+            <a:avLst/>
+          </a:prstGeom>
+          <a:noFill/>
+        </p:spPr>
+        <p:txBody>
+          <a:bodyPr wrap="square" anchor="ctr">
+            <a:spAutoFit/>
+          </a:bodyPr>
+          <a:lstStyle/>
+          <a:p>
+            <a:pPr algn="l"/>
+            <a:r>
+              <a:rPr sz="1500" b="0" i="0">
+                <a:solidFill>
+                  <a:srgbClr val="3F3E3A"/>
+                </a:solidFill>
+                <a:latin typeface="Calibri"/>
+              </a:rPr>
+              <a:t>Break-even in Sekunden bei fester Shape; für stark dynamische Shapes hilft Bucketing/Padding.</a:t>
+            </a:r>
+          </a:p>
+        </p:txBody>
+      </p:sp>
+    </p:spTree>
+  </p:cSld>
+  <p:clrMapOvr>
+    <a:masterClrMapping/>
+  </p:clrMapOvr>
+</p:sld>
+</file>
+
+<file path=ppt/slides/slide22.xml><?xml version="1.0" encoding="utf-8"?>
+<p:sld xmlns:a="http://schemas.openxmlformats.org/drawingml/2006/main" xmlns:p="http://schemas.openxmlformats.org/presentationml/2006/main" xmlns:r="http://schemas.openxmlformats.org/officeDocument/2006/relationships">
+  <p:cSld>
+    <p:bg>
+      <p:bgPr>
+        <a:solidFill>
           <a:srgbClr val="0E1B2E"/>
         </a:solidFill>
         <a:effectLst/>
@@ -12616,8 +13380,8 @@
         </p:blipFill>
         <p:spPr>
           <a:xfrm>
-            <a:off x="484191" y="1600200"/>
-            <a:ext cx="5706737" cy="3200400"/>
+            <a:off x="497136" y="1600200"/>
+            <a:ext cx="5543687" cy="3108960"/>
           </a:xfrm>
           <a:prstGeom prst="rect">
             <a:avLst/>
@@ -12640,7 +13404,7 @@
         </p:blipFill>
         <p:spPr>
           <a:xfrm>
-            <a:off x="6355080" y="1998560"/>
+            <a:off x="6355080" y="1774532"/>
             <a:ext cx="5394960" cy="2449399"/>
           </a:xfrm>
           <a:prstGeom prst="rect">
@@ -12650,7 +13414,112 @@
       </p:pic>
       <p:sp>
         <p:nvSpPr>
-          <p:cNvPr id="9" name="Rectangle 8"/>
+          <p:cNvPr id="9" name="Rounded Rectangle 8"/>
+          <p:cNvSpPr/>
+          <p:nvPr/>
+        </p:nvSpPr>
+        <p:spPr>
+          <a:xfrm>
+            <a:off x="6355080" y="4572000"/>
+            <a:ext cx="5394960" cy="1133856"/>
+          </a:xfrm>
+          <a:prstGeom prst="roundRect">
+            <a:avLst/>
+          </a:prstGeom>
+          <a:solidFill>
+            <a:srgbClr val="F4F7FB"/>
+          </a:solidFill>
+          <a:ln w="12700">
+            <a:solidFill>
+              <a:srgbClr val="DDE4EC"/>
+            </a:solidFill>
+          </a:ln>
+          <a:effectLst/>
+        </p:spPr>
+        <p:style>
+          <a:lnRef idx="1">
+            <a:schemeClr val="accent1"/>
+          </a:lnRef>
+          <a:fillRef idx="3">
+            <a:schemeClr val="accent1"/>
+          </a:fillRef>
+          <a:effectRef idx="2">
+            <a:schemeClr val="accent1"/>
+          </a:effectRef>
+          <a:fontRef idx="minor">
+            <a:schemeClr val="lt1"/>
+          </a:fontRef>
+        </p:style>
+        <p:txBody>
+          <a:bodyPr rtlCol="0" anchor="ctr"/>
+          <a:lstStyle/>
+          <a:p>
+            <a:pPr algn="ctr"/>
+          </a:p>
+        </p:txBody>
+      </p:sp>
+      <p:sp>
+        <p:nvSpPr>
+          <p:cNvPr id="10" name="TextBox 9"/>
+          <p:cNvSpPr txBox="1"/>
+          <p:nvPr/>
+        </p:nvSpPr>
+        <p:spPr>
+          <a:xfrm>
+            <a:off x="6537960" y="4645152"/>
+            <a:ext cx="5074920" cy="987552"/>
+          </a:xfrm>
+          <a:prstGeom prst="rect">
+            <a:avLst/>
+          </a:prstGeom>
+          <a:noFill/>
+        </p:spPr>
+        <p:txBody>
+          <a:bodyPr wrap="square" anchor="ctr">
+            <a:spAutoFit/>
+          </a:bodyPr>
+          <a:lstStyle/>
+          <a:p>
+            <a:pPr algn="l"/>
+            <a:r>
+              <a:rPr sz="1200" b="1" i="0">
+                <a:solidFill>
+                  <a:srgbClr val="0B0B0B"/>
+                </a:solidFill>
+                <a:latin typeface="Calibri"/>
+              </a:rPr>
+              <a:t>Was Filter 2 &amp; 3 rechnen  (Formeln → nächste Folie)</a:t>
+            </a:r>
+          </a:p>
+          <a:p>
+            <a:pPr algn="l"/>
+            <a:r>
+              <a:rPr sz="1050" b="0" i="0">
+                <a:solidFill>
+                  <a:srgbClr val="3F3E3A"/>
+                </a:solidFill>
+                <a:latin typeface="Calibri"/>
+              </a:rPr>
+              <a:t>SMEM  (m·k + k·n)·2 B·2 Stages ≤ 100 KB   → 126 raus</a:t>
+            </a:r>
+          </a:p>
+          <a:p>
+            <a:pPr algn="l"/>
+            <a:r>
+              <a:rPr sz="1050" b="0" i="0">
+                <a:solidFill>
+                  <a:srgbClr val="3F3E3A"/>
+                </a:solidFill>
+                <a:latin typeface="Calibri"/>
+              </a:rPr>
+              <a:t>Akku  m_prim·n_prim ≤ ½·65536 (fp32-Reg)   → 18 raus</a:t>
+            </a:r>
+          </a:p>
+        </p:txBody>
+      </p:sp>
+      <p:sp>
+        <p:nvSpPr>
+          <p:cNvPr id="11" name="Rectangle 10"/>
           <p:cNvSpPr/>
           <p:nvPr/>
         </p:nvSpPr>
@@ -12694,7 +13563,7 @@
       </p:sp>
       <p:sp>
         <p:nvSpPr>
-          <p:cNvPr id="10" name="TextBox 9"/>
+          <p:cNvPr id="12" name="TextBox 11"/>
           <p:cNvSpPr txBox="1"/>
           <p:nvPr/>
         </p:nvSpPr>
@@ -12783,7 +13652,7 @@
                 </a:solidFill>
                 <a:latin typeface="Calibri"/>
               </a:rPr>
-              <a:t>ERWEITERUNG</a:t>
+              <a:t>SCHRITT 3 · DETAILS</a:t>
             </a:r>
           </a:p>
         </p:txBody>
@@ -12818,7 +13687,7 @@
                 </a:solidFill>
                 <a:latin typeface="Calibri"/>
               </a:rPr>
-              <a:t>A06: eine zweite Struktur-Familie</a:t>
+              <a:t>Was Pruning und Kostenmodell konkret rechnen</a:t>
             </a:r>
           </a:p>
         </p:txBody>
@@ -12939,7 +13808,7 @@
       </p:sp>
       <p:pic>
         <p:nvPicPr>
-          <p:cNvPr id="7" name="Picture 6" descr="code_ring_a.png"/>
+          <p:cNvPr id="7" name="Picture 6" descr="fig_math.png"/>
           <p:cNvPicPr>
             <a:picLocks noChangeAspect="1"/>
           </p:cNvPicPr>
@@ -12953,8 +13822,8 @@
         </p:blipFill>
         <p:spPr>
           <a:xfrm>
-            <a:off x="1024574" y="1554480"/>
-            <a:ext cx="6729090" cy="4114800"/>
+            <a:off x="1728821" y="1572768"/>
+            <a:ext cx="8703877" cy="4114800"/>
           </a:xfrm>
           <a:prstGeom prst="rect">
             <a:avLst/>
@@ -12963,142 +13832,7 @@
       </p:pic>
       <p:sp>
         <p:nvSpPr>
-          <p:cNvPr id="8" name="TextBox 7"/>
-          <p:cNvSpPr txBox="1"/>
-          <p:nvPr/>
-        </p:nvSpPr>
-        <p:spPr>
-          <a:xfrm>
-            <a:off x="8412480" y="1874519"/>
-            <a:ext cx="3246120" cy="3840480"/>
-          </a:xfrm>
-          <a:prstGeom prst="rect">
-            <a:avLst/>
-          </a:prstGeom>
-          <a:noFill/>
-        </p:spPr>
-        <p:txBody>
-          <a:bodyPr wrap="square">
-            <a:spAutoFit/>
-          </a:bodyPr>
-          <a:lstStyle/>
-          <a:p>
-            <a:pPr>
-              <a:lnSpc>
-                <a:spcPct val="110000"/>
-              </a:lnSpc>
-              <a:spcAft>
-                <a:spcPts val="1000"/>
-              </a:spcAft>
-            </a:pPr>
-            <a:r>
-              <a:rPr sz="1450" b="1" i="0">
-                <a:solidFill>
-                  <a:srgbClr val="2A78D6"/>
-                </a:solidFill>
-                <a:latin typeface="Calibri"/>
-              </a:rPr>
-              <a:t>▸  </a:t>
-            </a:r>
-            <a:r>
-              <a:rPr sz="1450" b="0" i="0">
-                <a:solidFill>
-                  <a:srgbClr val="3F3E3A"/>
-                </a:solidFill>
-                <a:latin typeface="Calibri"/>
-              </a:rPr>
-              <a:t>Nicht „doppeltes K" — die Batch-Topologie ist das Problem.</a:t>
-            </a:r>
-          </a:p>
-          <a:p>
-            <a:pPr>
-              <a:lnSpc>
-                <a:spcPct val="110000"/>
-              </a:lnSpc>
-              <a:spcAft>
-                <a:spcPts val="1000"/>
-              </a:spcAft>
-            </a:pPr>
-            <a:r>
-              <a:rPr sz="1450" b="1" i="0">
-                <a:solidFill>
-                  <a:srgbClr val="2A78D6"/>
-                </a:solidFill>
-                <a:latin typeface="Calibri"/>
-              </a:rPr>
-              <a:t>▸  </a:t>
-            </a:r>
-            <a:r>
-              <a:rPr sz="1450" b="0" i="0">
-                <a:solidFill>
-                  <a:srgbClr val="3F3E3A"/>
-                </a:solidFill>
-                <a:latin typeface="Calibri"/>
-              </a:rPr>
-              <a:t>A05: geteilter Batch c. A06: unabhängige a,c (A) und b (B).</a:t>
-            </a:r>
-          </a:p>
-          <a:p>
-            <a:pPr>
-              <a:lnSpc>
-                <a:spcPct val="110000"/>
-              </a:lnSpc>
-              <a:spcAft>
-                <a:spcPts val="1000"/>
-              </a:spcAft>
-            </a:pPr>
-            <a:r>
-              <a:rPr sz="1450" b="1" i="0">
-                <a:solidFill>
-                  <a:srgbClr val="2A78D6"/>
-                </a:solidFill>
-                <a:latin typeface="Calibri"/>
-              </a:rPr>
-              <a:t>▸  </a:t>
-            </a:r>
-            <a:r>
-              <a:rPr sz="1450" b="0" i="0">
-                <a:solidFill>
-                  <a:srgbClr val="3F3E3A"/>
-                </a:solidFill>
-                <a:latin typeface="Calibri"/>
-              </a:rPr>
-              <a:t>→ zweiter Kernel-Typ (Ring), kein Umbau.</a:t>
-            </a:r>
-          </a:p>
-          <a:p>
-            <a:pPr>
-              <a:lnSpc>
-                <a:spcPct val="110000"/>
-              </a:lnSpc>
-              <a:spcAft>
-                <a:spcPts val="1000"/>
-              </a:spcAft>
-            </a:pPr>
-            <a:r>
-              <a:rPr sz="1450" b="1" i="0">
-                <a:solidFill>
-                  <a:srgbClr val="2A78D6"/>
-                </a:solidFill>
-                <a:latin typeface="Calibri"/>
-              </a:rPr>
-              <a:t>▸  </a:t>
-            </a:r>
-            <a:r>
-              <a:rPr sz="1450" b="0" i="0">
-                <a:solidFill>
-                  <a:srgbClr val="3F3E3A"/>
-                </a:solidFill>
-                <a:latin typeface="Calibri"/>
-              </a:rPr>
-              <a:t>Der Tuner sucht Configs, nicht Kernel — A05-Pfad bleibt bitgleich.</a:t>
-            </a:r>
-          </a:p>
-        </p:txBody>
-      </p:sp>
-      <p:sp>
-        <p:nvSpPr>
-          <p:cNvPr id="9" name="Rectangle 8"/>
+          <p:cNvPr id="8" name="Rectangle 7"/>
           <p:cNvSpPr/>
           <p:nvPr/>
         </p:nvSpPr>
@@ -13142,7 +13876,7 @@
       </p:sp>
       <p:sp>
         <p:nvSpPr>
-          <p:cNvPr id="10" name="TextBox 9"/>
+          <p:cNvPr id="9" name="TextBox 8"/>
           <p:cNvSpPr txBox="1"/>
           <p:nvPr/>
         </p:nvSpPr>
@@ -13170,7 +13904,7 @@
                 </a:solidFill>
                 <a:latin typeface="Calibri"/>
               </a:rPr>
-              <a:t>Wie cuBLAS/CUTLASS (Template-Menge) oder Triton (autotune pro @jit): neue Topologie = neues Template, Configs getunt.</a:t>
+              <a:t>Alles aus device_props ausgelesen (SMEM / Register / Bandbreite / Peak) — nur Tile-Form, k_prim und L2-Gruppe variiert der Tuner.</a:t>
             </a:r>
           </a:p>
         </p:txBody>

</xml_diff>